<commit_message>
Update slides and transcript with live run results and R6-R9
Slide 6 now shows the live briefing from local Qwen, slide 8 the current
test counts (83 passed, 96% coverage), slide 9 the four fixes from the
live run. Speaker notes and transcript.md match.

Co-Authored-By: Claude Opus 5.5 (1M context) <noreply@anthropic.com>
Claude-Session: https://claude.ai/code/session_01Mez8dJTBQNaNNdQEmFVTYu
</commit_message>
<xml_diff>
--- a/presentation/Academic_Evidence_Investigator.pptx
+++ b/presentation/Academic_Evidence_Investigator.pptx
@@ -279,7 +279,7 @@
                   <c:v>11</c:v>
                 </c:pt>
                 <c:pt idx="3">
-                  <c:v>60</c:v>
+                  <c:v>67</c:v>
                 </c:pt>
               </c:numCache>
             </c:numRef>
@@ -1166,7 +1166,7 @@
           <a:p>
             <a:r>
               <a:rPr lang="en-US" dirty="0"/>
-              <a:t>The guiding principle, taken from the proposal, is that the LLM only does work that needs language understanding. Qwen2.5-7B-Instruct, through Hugging Face, proposes a plan, appraises abstracts and drafts the briefing. Python handles everything with one correct answer: deduplication by DOI and then by title and first author, ranking, rate limiting, and retries. Every LLM output crosses a Pydantic schema before anything else uses it. The Critic sends all new papers to the model in one batched call, and only new papers, which keeps token cost in line with new evidence.</a:t>
+              <a:t>The guiding principle, taken from the proposal, is that the LLM only does work that needs language understanding. Qwen2.5-7B-Instruct proposes a plan, appraises abstracts and drafts the briefing. For the live demonstration it ran locally under Ollama, through the same OpenAI-style interface the code uses for Hugging Face. Python handles everything with one correct answer: deduplication by DOI and then by title and first author, ranking, rate limiting, and retries. Every LLM output crosses a Pydantic schema before anything else uses it. The Critic sends all new papers to the model in one batched call, and only new papers, which keeps token cost in line with new evidence.</a:t>
             </a:r>
             <a:endParaRPr lang="en-US" dirty="0"/>
           </a:p>
@@ -1342,7 +1342,7 @@
           <a:p>
             <a:r>
               <a:rPr lang="en-US" dirty="0"/>
-              <a:t>Here is the Flask interface after an offline run. The researcher types a question and presses Investigate. The status line at the top is written by Python from the Critic's verdict, so the system cannot overstate how complete its evidence is. Each key finding carries in-text citations to the papers it came from. Below that are conflicting evidence, limitations, and possible research opportunities, framed only as gaps within the retrieved papers. The evidence table shows each paper's design, stance and relevance, and the audit trail lists every search and decision. The whole run is stored in SQLite and can be reopened or downloaded as JSON. With a Hugging Face token set, the same code searches Semantic Scholar and Crossref live and uses Qwen for each LLM step; offline mode makes this demonstration reproducible.</a:t>
+              <a:t>Here is the Flask interface after a live run on my own computer, asking the question from our Unit 6 proposal: does generative AI improve university students' academic performance? The agent searched Semantic Scholar and Crossref and used Qwen running locally. The status line at the top is written by Python from the Critic's verdict, so the system cannot overstate how complete its evidence is. Here the Critic judged twelve papers sufficient and balanced after one cycle. Each key finding carries in-text citations to the papers it came from. Below that are conflicting evidence, limitations, and possible research opportunities, framed only as gaps within the retrieved papers. The evidence table shows each paper's design, stance and relevance, and the audit trail lists every search and decision, including which steps used the model and which fell back. The whole run is stored in SQLite and can be reopened or downloaded as JSON. Offline mode runs the same code on built-in data, which keeps the next demonstration reproducible.</a:t>
             </a:r>
             <a:endParaRPr lang="en-US" dirty="0"/>
           </a:p>
@@ -1518,7 +1518,7 @@
           <a:p>
             <a:r>
               <a:rPr lang="en-US" dirty="0"/>
-              <a:t>The test suite has 76 automated tests, all passing, with 97 percent line coverage, and it needs no network or API key. That is possible because the sources and the LLM are injected through small interfaces, so tests use scripted fakes and synthetic API responses. Sixty unit tests cover each agent, parser and rule. Eleven functional tests run the real graph end to end and prove the behaviours the proposal promised, listed on the right: the re-plan, the cycle limit, an outage, deduplication, an invented citation being removed, and a complete LLM outage still producing a briefing. Interface tests drive the command line and the web app, including escaping a malicious paper title. Four live tests call the real services when enabled.</a:t>
+              <a:t>The test suite has 83 automated tests, all passing, with 96 percent line coverage, and it needs no network or API key. That is possible because the sources and the LLM are injected through small interfaces, so tests use scripted fakes and synthetic API responses. Sixty-seven unit tests cover each agent, parser and rule. Eleven functional tests run the real graph end to end and prove the behaviours the proposal promised, listed on the right: the re-plan, the cycle limit, an outage, deduplication, an invented citation being removed, and a complete LLM outage still producing a briefing. Interface tests drive the command line and the web app, including escaping a malicious paper title. Four live tests call the real services and the model when enabled.</a:t>
             </a:r>
             <a:endParaRPr lang="en-US" dirty="0"/>
           </a:p>
@@ -1606,7 +1606,7 @@
           <a:p>
             <a:r>
               <a:rPr lang="en-US" dirty="0"/>
-              <a:t>Testing changed the code. The first smoke run showed that "LLM-based" never matched abstracts that say "large language models", so the agent wasted all three cycles. Adding synonym folding and light stemming took the same question from two papers in three cycles to ten papers in one. The same run showed that the Critic treated all-neutral evidence as biased. The first coverage report showed leaked database connections, and the suite now fails on any leak. A new retry test showed a 404 being retried like a rate limit. Reviewing a screenshot showed references in the wrong order for Harvard style. Each fix has a regression test, the full log is in docs/TESTING.md, and the Git history shows the system being built up step by step.</a:t>
+              <a:t>Testing changed the code. Offline, the first smoke run showed that "LLM-based" never matched abstracts that say "large language models", so the agent wasted all three cycles; synonym folding and light stemming took it from two papers in three cycles to ten in one. Other tests caught all-neutral evidence being called biased, leaked database connections, a 404 being retried like a rate limit, and references in the wrong order. Running live on Windows found four more problems. The hosted Qwen model was no longer served and the free credit ran out, so I made the endpoint configurable and ran Qwen locally. Semantic Scholar throttled requests, so retries now back off longer. One malformed appraisal discarded all twelve, so each is now validated separately, and eleven of twelve were then kept. And the model once wrote invalid JSON, so an optional JSON mode now constrains its output. In every case the fallbacks kept the run going and the audit trail showed what happened. Each fix has a regression test, and the full log is in docs/TESTING.md.</a:t>
             </a:r>
             <a:endParaRPr lang="en-US" dirty="0"/>
           </a:p>
@@ -6878,7 +6878,7 @@
       </p:sp>
       <p:pic>
         <p:nvPicPr>
-          <p:cNvPr id="3" name="Briefing screenshot" descr="briefing_crop.png">    </p:cNvPr>
+          <p:cNvPr id="3" name="Briefing screenshot" descr="Live briefing page for the generative AI question, run with local Qwen">    </p:cNvPr>
           <p:cNvPicPr>
             <a:picLocks noChangeAspect="1"/>
           </p:cNvPicPr>
@@ -7984,7 +7984,7 @@
                 <a:ea typeface="Cambria" pitchFamily="34" charset="-122"/>
                 <a:cs typeface="Cambria" pitchFamily="34" charset="-120"/>
               </a:rPr>
-              <a:t>Testing: 76 tests, no network needed</a:t>
+              <a:t>Testing: 83 tests, no network needed</a:t>
             </a:r>
             <a:endParaRPr lang="en-US" sz="3000" dirty="0"/>
           </a:p>
@@ -8023,7 +8023,7 @@
                 <a:ea typeface="Cambria" pitchFamily="34" charset="-122"/>
                 <a:cs typeface="Cambria" pitchFamily="34" charset="-120"/>
               </a:rPr>
-              <a:t>76</a:t>
+              <a:t>83</a:t>
             </a:r>
             <a:endParaRPr lang="en-US" sz="4400" dirty="0"/>
           </a:p>
@@ -8173,7 +8173,7 @@
                 <a:ea typeface="Cambria" pitchFamily="34" charset="-122"/>
                 <a:cs typeface="Cambria" pitchFamily="34" charset="-120"/>
               </a:rPr>
-              <a:t>97%</a:t>
+              <a:t>96%</a:t>
             </a:r>
             <a:endParaRPr lang="en-US" sz="4400" dirty="0"/>
           </a:p>
@@ -8608,14 +8608,14 @@
       </p:sp>
       <p:sp>
         <p:nvSpPr>
-          <p:cNvPr id="3" name="R1 badge"/>
+          <p:cNvPr id="4" name="R1 badge"/>
           <p:cNvSpPr/>
           <p:nvPr/>
         </p:nvSpPr>
         <p:spPr>
           <a:xfrm>
-            <a:off x="457200" y="1143000"/>
-            <a:ext cx="457200" cy="457200"/>
+            <a:off x="457200" y="1033272"/>
+            <a:ext cx="283464" cy="283464"/>
           </a:xfrm>
           <a:prstGeom prst="ellipse">
             <a:avLst/>
@@ -8627,26 +8627,24 @@
             <a:solidFill>
               <a:schemeClr val="accent2"/>
             </a:solidFill>
-            <a:prstDash val="solid"/>
           </a:ln>
         </p:spPr>
       </p:sp>
       <p:sp>
         <p:nvSpPr>
-          <p:cNvPr id="4" name="Text 2"/>
+          <p:cNvPr id="5" name="R1 label"/>
           <p:cNvSpPr txBox="1"/>
           <p:nvPr/>
         </p:nvSpPr>
         <p:spPr>
           <a:xfrm>
-            <a:off x="457200" y="1143000"/>
-            <a:ext cx="457200" cy="457200"/>
-          </a:xfrm>
-          <a:prstGeom prst="rect">
-            <a:avLst/>
-          </a:prstGeom>
-          <a:noFill/>
-          <a:ln/>
+            <a:off x="457200" y="1033272"/>
+            <a:ext cx="283464" cy="283464"/>
+          </a:xfrm>
+          <a:prstGeom prst="rect">
+            <a:avLst/>
+          </a:prstGeom>
+          <a:noFill/>
         </p:spPr>
         <p:txBody>
           <a:bodyPr wrap="square" lIns="0" tIns="0" rIns="0" bIns="0" rtlCol="0" anchor="ctr"/>
@@ -8656,33 +8654,31 @@
               <a:buNone/>
             </a:pPr>
             <a:r>
-              <a:rPr lang="en-US" sz="1200" b="1" dirty="0">
+              <a:rPr lang="en-GB" sz="1000" b="1" dirty="0">
                 <a:solidFill>
                   <a:schemeClr val="bg1"/>
                 </a:solidFill>
               </a:rPr>
               <a:t>R1</a:t>
             </a:r>
-            <a:endParaRPr lang="en-US" sz="1200" dirty="0"/>
-          </a:p>
-        </p:txBody>
-      </p:sp>
-      <p:sp>
-        <p:nvSpPr>
-          <p:cNvPr id="5" name="Text 3"/>
+          </a:p>
+        </p:txBody>
+      </p:sp>
+      <p:sp>
+        <p:nvSpPr>
+          <p:cNvPr id="6" name="R1 problem"/>
           <p:cNvSpPr txBox="1"/>
           <p:nvPr/>
         </p:nvSpPr>
         <p:spPr>
           <a:xfrm>
-            <a:off x="1051560" y="1097280"/>
-            <a:ext cx="3291840" cy="548640"/>
-          </a:xfrm>
-          <a:prstGeom prst="rect">
-            <a:avLst/>
-          </a:prstGeom>
-          <a:noFill/>
-          <a:ln/>
+            <a:off x="868680" y="1005840"/>
+            <a:ext cx="3566160" cy="338328"/>
+          </a:xfrm>
+          <a:prstGeom prst="rect">
+            <a:avLst/>
+          </a:prstGeom>
+          <a:noFill/>
         </p:spPr>
         <p:txBody>
           <a:bodyPr wrap="square" rtlCol="0" anchor="ctr"/>
@@ -8692,33 +8688,31 @@
               <a:buNone/>
             </a:pPr>
             <a:r>
-              <a:rPr lang="en-US" sz="1250" dirty="0">
+              <a:rPr lang="en-GB" sz="1150" dirty="0">
                 <a:solidFill>
                   <a:schemeClr val="tx1"/>
                 </a:solidFill>
               </a:rPr>
               <a:t>"LLM-based" never matched "large language models"</a:t>
             </a:r>
-            <a:endParaRPr lang="en-US" sz="1250" dirty="0"/>
-          </a:p>
-        </p:txBody>
-      </p:sp>
-      <p:sp>
-        <p:nvSpPr>
-          <p:cNvPr id="6" name="Text 4"/>
+          </a:p>
+        </p:txBody>
+      </p:sp>
+      <p:sp>
+        <p:nvSpPr>
+          <p:cNvPr id="7" name="R1 fix"/>
           <p:cNvSpPr txBox="1"/>
           <p:nvPr/>
         </p:nvSpPr>
         <p:spPr>
           <a:xfrm>
-            <a:off x="4434840" y="1097280"/>
-            <a:ext cx="4251960" cy="548640"/>
-          </a:xfrm>
-          <a:prstGeom prst="rect">
-            <a:avLst/>
-          </a:prstGeom>
-          <a:noFill/>
-          <a:ln/>
+            <a:off x="4480560" y="1005840"/>
+            <a:ext cx="4206240" cy="338328"/>
+          </a:xfrm>
+          <a:prstGeom prst="rect">
+            <a:avLst/>
+          </a:prstGeom>
+          <a:noFill/>
         </p:spPr>
         <p:txBody>
           <a:bodyPr wrap="square" rtlCol="0" anchor="ctr"/>
@@ -8728,27 +8722,26 @@
               <a:buNone/>
             </a:pPr>
             <a:r>
-              <a:rPr lang="en-US" sz="1250" b="1" dirty="0">
+              <a:rPr lang="en-GB" sz="1150" b="1" dirty="0">
                 <a:solidFill>
                   <a:schemeClr val="accent1"/>
                 </a:solidFill>
               </a:rPr>
-              <a:t>Synonym folding + light stemming: 2 papers in 3 cycles became 10 in 1</a:t>
-            </a:r>
-            <a:endParaRPr lang="en-US" sz="1250" dirty="0"/>
-          </a:p>
-        </p:txBody>
-      </p:sp>
-      <p:sp>
-        <p:nvSpPr>
-          <p:cNvPr id="7" name="R2 badge"/>
+              <a:t>Synonym folding + stemming: 2 papers in 3 cycles became 10 in 1</a:t>
+            </a:r>
+          </a:p>
+        </p:txBody>
+      </p:sp>
+      <p:sp>
+        <p:nvSpPr>
+          <p:cNvPr id="8" name="R2 badge"/>
           <p:cNvSpPr/>
           <p:nvPr/>
         </p:nvSpPr>
         <p:spPr>
           <a:xfrm>
-            <a:off x="457200" y="1746504"/>
-            <a:ext cx="457200" cy="457200"/>
+            <a:off x="457200" y="1371600"/>
+            <a:ext cx="283464" cy="283464"/>
           </a:xfrm>
           <a:prstGeom prst="ellipse">
             <a:avLst/>
@@ -8760,26 +8753,24 @@
             <a:solidFill>
               <a:schemeClr val="accent2"/>
             </a:solidFill>
-            <a:prstDash val="solid"/>
           </a:ln>
         </p:spPr>
       </p:sp>
       <p:sp>
         <p:nvSpPr>
-          <p:cNvPr id="8" name="Text 6"/>
+          <p:cNvPr id="9" name="R2 label"/>
           <p:cNvSpPr txBox="1"/>
           <p:nvPr/>
         </p:nvSpPr>
         <p:spPr>
           <a:xfrm>
-            <a:off x="457200" y="1746504"/>
-            <a:ext cx="457200" cy="457200"/>
-          </a:xfrm>
-          <a:prstGeom prst="rect">
-            <a:avLst/>
-          </a:prstGeom>
-          <a:noFill/>
-          <a:ln/>
+            <a:off x="457200" y="1371600"/>
+            <a:ext cx="283464" cy="283464"/>
+          </a:xfrm>
+          <a:prstGeom prst="rect">
+            <a:avLst/>
+          </a:prstGeom>
+          <a:noFill/>
         </p:spPr>
         <p:txBody>
           <a:bodyPr wrap="square" lIns="0" tIns="0" rIns="0" bIns="0" rtlCol="0" anchor="ctr"/>
@@ -8789,33 +8780,31 @@
               <a:buNone/>
             </a:pPr>
             <a:r>
-              <a:rPr lang="en-US" sz="1200" b="1" dirty="0">
+              <a:rPr lang="en-GB" sz="1000" b="1" dirty="0">
                 <a:solidFill>
                   <a:schemeClr val="bg1"/>
                 </a:solidFill>
               </a:rPr>
               <a:t>R2</a:t>
             </a:r>
-            <a:endParaRPr lang="en-US" sz="1200" dirty="0"/>
-          </a:p>
-        </p:txBody>
-      </p:sp>
-      <p:sp>
-        <p:nvSpPr>
-          <p:cNvPr id="9" name="Text 7"/>
+          </a:p>
+        </p:txBody>
+      </p:sp>
+      <p:sp>
+        <p:nvSpPr>
+          <p:cNvPr id="10" name="R2 problem"/>
           <p:cNvSpPr txBox="1"/>
           <p:nvPr/>
         </p:nvSpPr>
         <p:spPr>
           <a:xfrm>
-            <a:off x="1051560" y="1700784"/>
-            <a:ext cx="3291840" cy="548640"/>
-          </a:xfrm>
-          <a:prstGeom prst="rect">
-            <a:avLst/>
-          </a:prstGeom>
-          <a:noFill/>
-          <a:ln/>
+            <a:off x="868680" y="1344168"/>
+            <a:ext cx="3566160" cy="338328"/>
+          </a:xfrm>
+          <a:prstGeom prst="rect">
+            <a:avLst/>
+          </a:prstGeom>
+          <a:noFill/>
         </p:spPr>
         <p:txBody>
           <a:bodyPr wrap="square" rtlCol="0" anchor="ctr"/>
@@ -8825,33 +8814,31 @@
               <a:buNone/>
             </a:pPr>
             <a:r>
-              <a:rPr lang="en-US" sz="1250" dirty="0">
+              <a:rPr lang="en-GB" sz="1150" dirty="0">
                 <a:solidFill>
                   <a:schemeClr val="tx1"/>
                 </a:solidFill>
               </a:rPr>
               <a:t>All-neutral evidence flagged as one-sided</a:t>
             </a:r>
-            <a:endParaRPr lang="en-US" sz="1250" dirty="0"/>
-          </a:p>
-        </p:txBody>
-      </p:sp>
-      <p:sp>
-        <p:nvSpPr>
-          <p:cNvPr id="10" name="Text 8"/>
+          </a:p>
+        </p:txBody>
+      </p:sp>
+      <p:sp>
+        <p:nvSpPr>
+          <p:cNvPr id="11" name="R2 fix"/>
           <p:cNvSpPr txBox="1"/>
           <p:nvPr/>
         </p:nvSpPr>
         <p:spPr>
           <a:xfrm>
-            <a:off x="4434840" y="1700784"/>
-            <a:ext cx="4251960" cy="548640"/>
-          </a:xfrm>
-          <a:prstGeom prst="rect">
-            <a:avLst/>
-          </a:prstGeom>
-          <a:noFill/>
-          <a:ln/>
+            <a:off x="4480560" y="1344168"/>
+            <a:ext cx="4206240" cy="338328"/>
+          </a:xfrm>
+          <a:prstGeom prst="rect">
+            <a:avLst/>
+          </a:prstGeom>
+          <a:noFill/>
         </p:spPr>
         <p:txBody>
           <a:bodyPr wrap="square" rtlCol="0" anchor="ctr"/>
@@ -8861,27 +8848,26 @@
               <a:buNone/>
             </a:pPr>
             <a:r>
-              <a:rPr lang="en-US" sz="1250" b="1" dirty="0">
+              <a:rPr lang="en-GB" sz="1150" b="1" dirty="0">
                 <a:solidFill>
                   <a:schemeClr val="accent1"/>
                 </a:solidFill>
               </a:rPr>
               <a:t>Only uniform supports/opposes counts as bias</a:t>
             </a:r>
-            <a:endParaRPr lang="en-US" sz="1250" dirty="0"/>
-          </a:p>
-        </p:txBody>
-      </p:sp>
-      <p:sp>
-        <p:nvSpPr>
-          <p:cNvPr id="11" name="R3 badge"/>
+          </a:p>
+        </p:txBody>
+      </p:sp>
+      <p:sp>
+        <p:nvSpPr>
+          <p:cNvPr id="12" name="R3 badge"/>
           <p:cNvSpPr/>
           <p:nvPr/>
         </p:nvSpPr>
         <p:spPr>
           <a:xfrm>
-            <a:off x="457200" y="2350008"/>
-            <a:ext cx="457200" cy="457200"/>
+            <a:off x="457200" y="1709928"/>
+            <a:ext cx="283464" cy="283464"/>
           </a:xfrm>
           <a:prstGeom prst="ellipse">
             <a:avLst/>
@@ -8893,26 +8879,24 @@
             <a:solidFill>
               <a:schemeClr val="accent2"/>
             </a:solidFill>
-            <a:prstDash val="solid"/>
           </a:ln>
         </p:spPr>
       </p:sp>
       <p:sp>
         <p:nvSpPr>
-          <p:cNvPr id="12" name="Text 10"/>
+          <p:cNvPr id="13" name="R3 label"/>
           <p:cNvSpPr txBox="1"/>
           <p:nvPr/>
         </p:nvSpPr>
         <p:spPr>
           <a:xfrm>
-            <a:off x="457200" y="2350008"/>
-            <a:ext cx="457200" cy="457200"/>
-          </a:xfrm>
-          <a:prstGeom prst="rect">
-            <a:avLst/>
-          </a:prstGeom>
-          <a:noFill/>
-          <a:ln/>
+            <a:off x="457200" y="1709928"/>
+            <a:ext cx="283464" cy="283464"/>
+          </a:xfrm>
+          <a:prstGeom prst="rect">
+            <a:avLst/>
+          </a:prstGeom>
+          <a:noFill/>
         </p:spPr>
         <p:txBody>
           <a:bodyPr wrap="square" lIns="0" tIns="0" rIns="0" bIns="0" rtlCol="0" anchor="ctr"/>
@@ -8922,33 +8906,31 @@
               <a:buNone/>
             </a:pPr>
             <a:r>
-              <a:rPr lang="en-US" sz="1200" b="1" dirty="0">
+              <a:rPr lang="en-GB" sz="1000" b="1" dirty="0">
                 <a:solidFill>
                   <a:schemeClr val="bg1"/>
                 </a:solidFill>
               </a:rPr>
               <a:t>R3</a:t>
             </a:r>
-            <a:endParaRPr lang="en-US" sz="1200" dirty="0"/>
-          </a:p>
-        </p:txBody>
-      </p:sp>
-      <p:sp>
-        <p:nvSpPr>
-          <p:cNvPr id="13" name="Text 11"/>
+          </a:p>
+        </p:txBody>
+      </p:sp>
+      <p:sp>
+        <p:nvSpPr>
+          <p:cNvPr id="14" name="R3 problem"/>
           <p:cNvSpPr txBox="1"/>
           <p:nvPr/>
         </p:nvSpPr>
         <p:spPr>
           <a:xfrm>
-            <a:off x="1051560" y="2304288"/>
-            <a:ext cx="3291840" cy="548640"/>
-          </a:xfrm>
-          <a:prstGeom prst="rect">
-            <a:avLst/>
-          </a:prstGeom>
-          <a:noFill/>
-          <a:ln/>
+            <a:off x="868680" y="1682496"/>
+            <a:ext cx="3566160" cy="338328"/>
+          </a:xfrm>
+          <a:prstGeom prst="rect">
+            <a:avLst/>
+          </a:prstGeom>
+          <a:noFill/>
         </p:spPr>
         <p:txBody>
           <a:bodyPr wrap="square" rtlCol="0" anchor="ctr"/>
@@ -8958,33 +8940,31 @@
               <a:buNone/>
             </a:pPr>
             <a:r>
-              <a:rPr lang="en-US" sz="1250" dirty="0">
+              <a:rPr lang="en-GB" sz="1150" dirty="0">
                 <a:solidFill>
                   <a:schemeClr val="tx1"/>
                 </a:solidFill>
               </a:rPr>
-              <a:t>Unclosed SQLite connections (ResourceWarning)</a:t>
-            </a:r>
-            <a:endParaRPr lang="en-US" sz="1250" dirty="0"/>
-          </a:p>
-        </p:txBody>
-      </p:sp>
-      <p:sp>
-        <p:nvSpPr>
-          <p:cNvPr id="14" name="Text 12"/>
+              <a:t>Unclosed SQLite connections</a:t>
+            </a:r>
+          </a:p>
+        </p:txBody>
+      </p:sp>
+      <p:sp>
+        <p:nvSpPr>
+          <p:cNvPr id="15" name="R3 fix"/>
           <p:cNvSpPr txBox="1"/>
           <p:nvPr/>
         </p:nvSpPr>
         <p:spPr>
           <a:xfrm>
-            <a:off x="4434840" y="2304288"/>
-            <a:ext cx="4251960" cy="548640"/>
-          </a:xfrm>
-          <a:prstGeom prst="rect">
-            <a:avLst/>
-          </a:prstGeom>
-          <a:noFill/>
-          <a:ln/>
+            <a:off x="4480560" y="1682496"/>
+            <a:ext cx="4206240" cy="338328"/>
+          </a:xfrm>
+          <a:prstGeom prst="rect">
+            <a:avLst/>
+          </a:prstGeom>
+          <a:noFill/>
         </p:spPr>
         <p:txBody>
           <a:bodyPr wrap="square" rtlCol="0" anchor="ctr"/>
@@ -8994,27 +8974,26 @@
               <a:buNone/>
             </a:pPr>
             <a:r>
-              <a:rPr lang="en-US" sz="1250" b="1" dirty="0">
+              <a:rPr lang="en-GB" sz="1150" b="1" dirty="0">
                 <a:solidFill>
                   <a:schemeClr val="accent1"/>
                 </a:solidFill>
               </a:rPr>
               <a:t>Shared Storage; suite now fails on any leak</a:t>
             </a:r>
-            <a:endParaRPr lang="en-US" sz="1250" dirty="0"/>
-          </a:p>
-        </p:txBody>
-      </p:sp>
-      <p:sp>
-        <p:nvSpPr>
-          <p:cNvPr id="15" name="R4 badge"/>
+          </a:p>
+        </p:txBody>
+      </p:sp>
+      <p:sp>
+        <p:nvSpPr>
+          <p:cNvPr id="16" name="R4 badge"/>
           <p:cNvSpPr/>
           <p:nvPr/>
         </p:nvSpPr>
         <p:spPr>
           <a:xfrm>
-            <a:off x="457200" y="2953512"/>
-            <a:ext cx="457200" cy="457200"/>
+            <a:off x="457200" y="2048256"/>
+            <a:ext cx="283464" cy="283464"/>
           </a:xfrm>
           <a:prstGeom prst="ellipse">
             <a:avLst/>
@@ -9026,26 +9005,24 @@
             <a:solidFill>
               <a:schemeClr val="accent2"/>
             </a:solidFill>
-            <a:prstDash val="solid"/>
           </a:ln>
         </p:spPr>
       </p:sp>
       <p:sp>
         <p:nvSpPr>
-          <p:cNvPr id="16" name="Text 14"/>
+          <p:cNvPr id="17" name="R4 label"/>
           <p:cNvSpPr txBox="1"/>
           <p:nvPr/>
         </p:nvSpPr>
         <p:spPr>
           <a:xfrm>
-            <a:off x="457200" y="2953512"/>
-            <a:ext cx="457200" cy="457200"/>
-          </a:xfrm>
-          <a:prstGeom prst="rect">
-            <a:avLst/>
-          </a:prstGeom>
-          <a:noFill/>
-          <a:ln/>
+            <a:off x="457200" y="2048256"/>
+            <a:ext cx="283464" cy="283464"/>
+          </a:xfrm>
+          <a:prstGeom prst="rect">
+            <a:avLst/>
+          </a:prstGeom>
+          <a:noFill/>
         </p:spPr>
         <p:txBody>
           <a:bodyPr wrap="square" lIns="0" tIns="0" rIns="0" bIns="0" rtlCol="0" anchor="ctr"/>
@@ -9055,33 +9032,31 @@
               <a:buNone/>
             </a:pPr>
             <a:r>
-              <a:rPr lang="en-US" sz="1200" b="1" dirty="0">
+              <a:rPr lang="en-GB" sz="1000" b="1" dirty="0">
                 <a:solidFill>
                   <a:schemeClr val="bg1"/>
                 </a:solidFill>
               </a:rPr>
               <a:t>R4</a:t>
             </a:r>
-            <a:endParaRPr lang="en-US" sz="1200" dirty="0"/>
-          </a:p>
-        </p:txBody>
-      </p:sp>
-      <p:sp>
-        <p:nvSpPr>
-          <p:cNvPr id="17" name="Text 15"/>
+          </a:p>
+        </p:txBody>
+      </p:sp>
+      <p:sp>
+        <p:nvSpPr>
+          <p:cNvPr id="18" name="R4 problem"/>
           <p:cNvSpPr txBox="1"/>
           <p:nvPr/>
         </p:nvSpPr>
         <p:spPr>
           <a:xfrm>
-            <a:off x="1051560" y="2907792"/>
-            <a:ext cx="3291840" cy="548640"/>
-          </a:xfrm>
-          <a:prstGeom prst="rect">
-            <a:avLst/>
-          </a:prstGeom>
-          <a:noFill/>
-          <a:ln/>
+            <a:off x="868680" y="2020824"/>
+            <a:ext cx="3566160" cy="338328"/>
+          </a:xfrm>
+          <a:prstGeom prst="rect">
+            <a:avLst/>
+          </a:prstGeom>
+          <a:noFill/>
         </p:spPr>
         <p:txBody>
           <a:bodyPr wrap="square" rtlCol="0" anchor="ctr"/>
@@ -9091,33 +9066,31 @@
               <a:buNone/>
             </a:pPr>
             <a:r>
-              <a:rPr lang="en-US" sz="1250" dirty="0">
+              <a:rPr lang="en-GB" sz="1150" dirty="0">
                 <a:solidFill>
                   <a:schemeClr val="tx1"/>
                 </a:solidFill>
               </a:rPr>
               <a:t>HTTP 404 retried like a rate limit</a:t>
             </a:r>
-            <a:endParaRPr lang="en-US" sz="1250" dirty="0"/>
-          </a:p>
-        </p:txBody>
-      </p:sp>
-      <p:sp>
-        <p:nvSpPr>
-          <p:cNvPr id="18" name="Text 16"/>
+          </a:p>
+        </p:txBody>
+      </p:sp>
+      <p:sp>
+        <p:nvSpPr>
+          <p:cNvPr id="19" name="R4 fix"/>
           <p:cNvSpPr txBox="1"/>
           <p:nvPr/>
         </p:nvSpPr>
         <p:spPr>
           <a:xfrm>
-            <a:off x="4434840" y="2907792"/>
-            <a:ext cx="4251960" cy="548640"/>
-          </a:xfrm>
-          <a:prstGeom prst="rect">
-            <a:avLst/>
-          </a:prstGeom>
-          <a:noFill/>
-          <a:ln/>
+            <a:off x="4480560" y="2020824"/>
+            <a:ext cx="4206240" cy="338328"/>
+          </a:xfrm>
+          <a:prstGeom prst="rect">
+            <a:avLst/>
+          </a:prstGeom>
+          <a:noFill/>
         </p:spPr>
         <p:txBody>
           <a:bodyPr wrap="square" rtlCol="0" anchor="ctr"/>
@@ -9127,27 +9100,26 @@
               <a:buNone/>
             </a:pPr>
             <a:r>
-              <a:rPr lang="en-US" sz="1250" b="1" dirty="0">
+              <a:rPr lang="en-GB" sz="1150" b="1" dirty="0">
                 <a:solidFill>
                   <a:schemeClr val="accent1"/>
                 </a:solidFill>
               </a:rPr>
               <a:t>Retry only timeouts, 429 and 5xx</a:t>
             </a:r>
-            <a:endParaRPr lang="en-US" sz="1250" dirty="0"/>
-          </a:p>
-        </p:txBody>
-      </p:sp>
-      <p:sp>
-        <p:nvSpPr>
-          <p:cNvPr id="19" name="R5 badge"/>
+          </a:p>
+        </p:txBody>
+      </p:sp>
+      <p:sp>
+        <p:nvSpPr>
+          <p:cNvPr id="20" name="R5 badge"/>
           <p:cNvSpPr/>
           <p:nvPr/>
         </p:nvSpPr>
         <p:spPr>
           <a:xfrm>
-            <a:off x="457200" y="3557016"/>
-            <a:ext cx="457200" cy="457200"/>
+            <a:off x="457200" y="2386584"/>
+            <a:ext cx="283464" cy="283464"/>
           </a:xfrm>
           <a:prstGeom prst="ellipse">
             <a:avLst/>
@@ -9159,26 +9131,24 @@
             <a:solidFill>
               <a:schemeClr val="accent2"/>
             </a:solidFill>
-            <a:prstDash val="solid"/>
           </a:ln>
         </p:spPr>
       </p:sp>
       <p:sp>
         <p:nvSpPr>
-          <p:cNvPr id="20" name="Text 18"/>
+          <p:cNvPr id="21" name="R5 label"/>
           <p:cNvSpPr txBox="1"/>
           <p:nvPr/>
         </p:nvSpPr>
         <p:spPr>
           <a:xfrm>
-            <a:off x="457200" y="3557016"/>
-            <a:ext cx="457200" cy="457200"/>
-          </a:xfrm>
-          <a:prstGeom prst="rect">
-            <a:avLst/>
-          </a:prstGeom>
-          <a:noFill/>
-          <a:ln/>
+            <a:off x="457200" y="2386584"/>
+            <a:ext cx="283464" cy="283464"/>
+          </a:xfrm>
+          <a:prstGeom prst="rect">
+            <a:avLst/>
+          </a:prstGeom>
+          <a:noFill/>
         </p:spPr>
         <p:txBody>
           <a:bodyPr wrap="square" lIns="0" tIns="0" rIns="0" bIns="0" rtlCol="0" anchor="ctr"/>
@@ -9188,33 +9158,31 @@
               <a:buNone/>
             </a:pPr>
             <a:r>
-              <a:rPr lang="en-US" sz="1200" b="1" dirty="0">
+              <a:rPr lang="en-GB" sz="1000" b="1" dirty="0">
                 <a:solidFill>
                   <a:schemeClr val="bg1"/>
                 </a:solidFill>
               </a:rPr>
               <a:t>R5</a:t>
             </a:r>
-            <a:endParaRPr lang="en-US" sz="1200" dirty="0"/>
-          </a:p>
-        </p:txBody>
-      </p:sp>
-      <p:sp>
-        <p:nvSpPr>
-          <p:cNvPr id="21" name="Text 19"/>
+          </a:p>
+        </p:txBody>
+      </p:sp>
+      <p:sp>
+        <p:nvSpPr>
+          <p:cNvPr id="22" name="R5 problem"/>
           <p:cNvSpPr txBox="1"/>
           <p:nvPr/>
         </p:nvSpPr>
         <p:spPr>
           <a:xfrm>
-            <a:off x="1051560" y="3511296"/>
-            <a:ext cx="3291840" cy="548640"/>
-          </a:xfrm>
-          <a:prstGeom prst="rect">
-            <a:avLst/>
-          </a:prstGeom>
-          <a:noFill/>
-          <a:ln/>
+            <a:off x="868680" y="2359152"/>
+            <a:ext cx="3566160" cy="338328"/>
+          </a:xfrm>
+          <a:prstGeom prst="rect">
+            <a:avLst/>
+          </a:prstGeom>
+          <a:noFill/>
         </p:spPr>
         <p:txBody>
           <a:bodyPr wrap="square" rtlCol="0" anchor="ctr"/>
@@ -9224,33 +9192,31 @@
               <a:buNone/>
             </a:pPr>
             <a:r>
-              <a:rPr lang="en-US" sz="1250" dirty="0">
+              <a:rPr lang="en-GB" sz="1150" dirty="0">
                 <a:solidFill>
                   <a:schemeClr val="tx1"/>
                 </a:solidFill>
               </a:rPr>
               <a:t>References ordered by title</a:t>
             </a:r>
-            <a:endParaRPr lang="en-US" sz="1250" dirty="0"/>
-          </a:p>
-        </p:txBody>
-      </p:sp>
-      <p:sp>
-        <p:nvSpPr>
-          <p:cNvPr id="22" name="Text 20"/>
+          </a:p>
+        </p:txBody>
+      </p:sp>
+      <p:sp>
+        <p:nvSpPr>
+          <p:cNvPr id="23" name="R5 fix"/>
           <p:cNvSpPr txBox="1"/>
           <p:nvPr/>
         </p:nvSpPr>
         <p:spPr>
           <a:xfrm>
-            <a:off x="4434840" y="3511296"/>
-            <a:ext cx="4251960" cy="548640"/>
-          </a:xfrm>
-          <a:prstGeom prst="rect">
-            <a:avLst/>
-          </a:prstGeom>
-          <a:noFill/>
-          <a:ln/>
+            <a:off x="4480560" y="2359152"/>
+            <a:ext cx="4206240" cy="338328"/>
+          </a:xfrm>
+          <a:prstGeom prst="rect">
+            <a:avLst/>
+          </a:prstGeom>
+          <a:noFill/>
         </p:spPr>
         <p:txBody>
           <a:bodyPr wrap="square" rtlCol="0" anchor="ctr"/>
@@ -9260,33 +9226,89 @@
               <a:buNone/>
             </a:pPr>
             <a:r>
-              <a:rPr lang="en-US" sz="1250" b="1" dirty="0">
+              <a:rPr lang="en-GB" sz="1150" b="1" dirty="0">
                 <a:solidFill>
                   <a:schemeClr val="accent1"/>
                 </a:solidFill>
               </a:rPr>
               <a:t>Alphabetical by first author, per Harvard</a:t>
             </a:r>
-            <a:endParaRPr lang="en-US" sz="1250" dirty="0"/>
-          </a:p>
-        </p:txBody>
-      </p:sp>
-      <p:sp>
-        <p:nvSpPr>
-          <p:cNvPr id="23" name="Text 21"/>
+          </a:p>
+        </p:txBody>
+      </p:sp>
+      <p:sp>
+        <p:nvSpPr>
+          <p:cNvPr id="24" name="R6 badge"/>
+          <p:cNvSpPr/>
+          <p:nvPr/>
+        </p:nvSpPr>
+        <p:spPr>
+          <a:xfrm>
+            <a:off x="457200" y="2724912"/>
+            <a:ext cx="283464" cy="283464"/>
+          </a:xfrm>
+          <a:prstGeom prst="ellipse">
+            <a:avLst/>
+          </a:prstGeom>
+          <a:solidFill>
+            <a:schemeClr val="accent1"/>
+          </a:solidFill>
+          <a:ln w="12700">
+            <a:solidFill>
+              <a:schemeClr val="accent1"/>
+            </a:solidFill>
+          </a:ln>
+        </p:spPr>
+      </p:sp>
+      <p:sp>
+        <p:nvSpPr>
+          <p:cNvPr id="25" name="R6 label"/>
           <p:cNvSpPr txBox="1"/>
           <p:nvPr/>
         </p:nvSpPr>
         <p:spPr>
           <a:xfrm>
-            <a:off x="457200" y="4160520"/>
-            <a:ext cx="8229600" cy="502920"/>
-          </a:xfrm>
-          <a:prstGeom prst="rect">
-            <a:avLst/>
-          </a:prstGeom>
-          <a:noFill/>
-          <a:ln/>
+            <a:off x="457200" y="2724912"/>
+            <a:ext cx="283464" cy="283464"/>
+          </a:xfrm>
+          <a:prstGeom prst="rect">
+            <a:avLst/>
+          </a:prstGeom>
+          <a:noFill/>
+        </p:spPr>
+        <p:txBody>
+          <a:bodyPr wrap="square" lIns="0" tIns="0" rIns="0" bIns="0" rtlCol="0" anchor="ctr"/>
+          <a:lstStyle/>
+          <a:p>
+            <a:pPr algn="ctr" indent="0" marL="0">
+              <a:buNone/>
+            </a:pPr>
+            <a:r>
+              <a:rPr lang="en-GB" sz="1000" b="1" dirty="0">
+                <a:solidFill>
+                  <a:schemeClr val="bg1"/>
+                </a:solidFill>
+              </a:rPr>
+              <a:t>R6</a:t>
+            </a:r>
+          </a:p>
+        </p:txBody>
+      </p:sp>
+      <p:sp>
+        <p:nvSpPr>
+          <p:cNvPr id="26" name="R6 problem"/>
+          <p:cNvSpPr txBox="1"/>
+          <p:nvPr/>
+        </p:nvSpPr>
+        <p:spPr>
+          <a:xfrm>
+            <a:off x="868680" y="2697480"/>
+            <a:ext cx="3566160" cy="338328"/>
+          </a:xfrm>
+          <a:prstGeom prst="rect">
+            <a:avLst/>
+          </a:prstGeom>
+          <a:noFill/>
         </p:spPr>
         <p:txBody>
           <a:bodyPr wrap="square" rtlCol="0" anchor="ctr"/>
@@ -9296,20 +9318,465 @@
               <a:buNone/>
             </a:pPr>
             <a:r>
-              <a:rPr lang="en-US" sz="1200" i="1" dirty="0">
+              <a:rPr lang="en-GB" sz="1150" dirty="0">
+                <a:solidFill>
+                  <a:schemeClr val="tx1"/>
+                </a:solidFill>
+              </a:rPr>
+              <a:t>Live: hosted Qwen withdrawn, credit used up (400/402)</a:t>
+            </a:r>
+          </a:p>
+        </p:txBody>
+      </p:sp>
+      <p:sp>
+        <p:nvSpPr>
+          <p:cNvPr id="27" name="R6 fix"/>
+          <p:cNvSpPr txBox="1"/>
+          <p:nvPr/>
+        </p:nvSpPr>
+        <p:spPr>
+          <a:xfrm>
+            <a:off x="4480560" y="2697480"/>
+            <a:ext cx="4206240" cy="338328"/>
+          </a:xfrm>
+          <a:prstGeom prst="rect">
+            <a:avLst/>
+          </a:prstGeom>
+          <a:noFill/>
+        </p:spPr>
+        <p:txBody>
+          <a:bodyPr wrap="square" rtlCol="0" anchor="ctr"/>
+          <a:lstStyle/>
+          <a:p>
+            <a:pPr indent="0" marL="0">
+              <a:buNone/>
+            </a:pPr>
+            <a:r>
+              <a:rPr lang="en-GB" sz="1150" b="1" dirty="0">
+                <a:solidFill>
+                  <a:schemeClr val="accent1"/>
+                </a:solidFill>
+              </a:rPr>
+              <a:t>Configurable endpoint; Qwen runs locally under Ollama</a:t>
+            </a:r>
+          </a:p>
+        </p:txBody>
+      </p:sp>
+      <p:sp>
+        <p:nvSpPr>
+          <p:cNvPr id="28" name="R7 badge"/>
+          <p:cNvSpPr/>
+          <p:nvPr/>
+        </p:nvSpPr>
+        <p:spPr>
+          <a:xfrm>
+            <a:off x="457200" y="3063240"/>
+            <a:ext cx="283464" cy="283464"/>
+          </a:xfrm>
+          <a:prstGeom prst="ellipse">
+            <a:avLst/>
+          </a:prstGeom>
+          <a:solidFill>
+            <a:schemeClr val="accent1"/>
+          </a:solidFill>
+          <a:ln w="12700">
+            <a:solidFill>
+              <a:schemeClr val="accent1"/>
+            </a:solidFill>
+          </a:ln>
+        </p:spPr>
+      </p:sp>
+      <p:sp>
+        <p:nvSpPr>
+          <p:cNvPr id="29" name="R7 label"/>
+          <p:cNvSpPr txBox="1"/>
+          <p:nvPr/>
+        </p:nvSpPr>
+        <p:spPr>
+          <a:xfrm>
+            <a:off x="457200" y="3063240"/>
+            <a:ext cx="283464" cy="283464"/>
+          </a:xfrm>
+          <a:prstGeom prst="rect">
+            <a:avLst/>
+          </a:prstGeom>
+          <a:noFill/>
+        </p:spPr>
+        <p:txBody>
+          <a:bodyPr wrap="square" lIns="0" tIns="0" rIns="0" bIns="0" rtlCol="0" anchor="ctr"/>
+          <a:lstStyle/>
+          <a:p>
+            <a:pPr algn="ctr" indent="0" marL="0">
+              <a:buNone/>
+            </a:pPr>
+            <a:r>
+              <a:rPr lang="en-GB" sz="1000" b="1" dirty="0">
+                <a:solidFill>
+                  <a:schemeClr val="bg1"/>
+                </a:solidFill>
+              </a:rPr>
+              <a:t>R7</a:t>
+            </a:r>
+          </a:p>
+        </p:txBody>
+      </p:sp>
+      <p:sp>
+        <p:nvSpPr>
+          <p:cNvPr id="30" name="R7 problem"/>
+          <p:cNvSpPr txBox="1"/>
+          <p:nvPr/>
+        </p:nvSpPr>
+        <p:spPr>
+          <a:xfrm>
+            <a:off x="868680" y="3035808"/>
+            <a:ext cx="3566160" cy="338328"/>
+          </a:xfrm>
+          <a:prstGeom prst="rect">
+            <a:avLst/>
+          </a:prstGeom>
+          <a:noFill/>
+        </p:spPr>
+        <p:txBody>
+          <a:bodyPr wrap="square" rtlCol="0" anchor="ctr"/>
+          <a:lstStyle/>
+          <a:p>
+            <a:pPr indent="0" marL="0">
+              <a:buNone/>
+            </a:pPr>
+            <a:r>
+              <a:rPr lang="en-GB" sz="1150" dirty="0">
+                <a:solidFill>
+                  <a:schemeClr val="tx1"/>
+                </a:solidFill>
+              </a:rPr>
+              <a:t>Live: Semantic Scholar throttled (429)</a:t>
+            </a:r>
+          </a:p>
+        </p:txBody>
+      </p:sp>
+      <p:sp>
+        <p:nvSpPr>
+          <p:cNvPr id="31" name="R7 fix"/>
+          <p:cNvSpPr txBox="1"/>
+          <p:nvPr/>
+        </p:nvSpPr>
+        <p:spPr>
+          <a:xfrm>
+            <a:off x="4480560" y="3035808"/>
+            <a:ext cx="4206240" cy="338328"/>
+          </a:xfrm>
+          <a:prstGeom prst="rect">
+            <a:avLst/>
+          </a:prstGeom>
+          <a:noFill/>
+        </p:spPr>
+        <p:txBody>
+          <a:bodyPr wrap="square" rtlCol="0" anchor="ctr"/>
+          <a:lstStyle/>
+          <a:p>
+            <a:pPr indent="0" marL="0">
+              <a:buNone/>
+            </a:pPr>
+            <a:r>
+              <a:rPr lang="en-GB" sz="1150" b="1" dirty="0">
+                <a:solidFill>
+                  <a:schemeClr val="accent1"/>
+                </a:solidFill>
+              </a:rPr>
+              <a:t>Longer back-off, Retry-After, optional API key</a:t>
+            </a:r>
+          </a:p>
+        </p:txBody>
+      </p:sp>
+      <p:sp>
+        <p:nvSpPr>
+          <p:cNvPr id="32" name="R8 badge"/>
+          <p:cNvSpPr/>
+          <p:nvPr/>
+        </p:nvSpPr>
+        <p:spPr>
+          <a:xfrm>
+            <a:off x="457200" y="3401568"/>
+            <a:ext cx="283464" cy="283464"/>
+          </a:xfrm>
+          <a:prstGeom prst="ellipse">
+            <a:avLst/>
+          </a:prstGeom>
+          <a:solidFill>
+            <a:schemeClr val="accent1"/>
+          </a:solidFill>
+          <a:ln w="12700">
+            <a:solidFill>
+              <a:schemeClr val="accent1"/>
+            </a:solidFill>
+          </a:ln>
+        </p:spPr>
+      </p:sp>
+      <p:sp>
+        <p:nvSpPr>
+          <p:cNvPr id="33" name="R8 label"/>
+          <p:cNvSpPr txBox="1"/>
+          <p:nvPr/>
+        </p:nvSpPr>
+        <p:spPr>
+          <a:xfrm>
+            <a:off x="457200" y="3401568"/>
+            <a:ext cx="283464" cy="283464"/>
+          </a:xfrm>
+          <a:prstGeom prst="rect">
+            <a:avLst/>
+          </a:prstGeom>
+          <a:noFill/>
+        </p:spPr>
+        <p:txBody>
+          <a:bodyPr wrap="square" lIns="0" tIns="0" rIns="0" bIns="0" rtlCol="0" anchor="ctr"/>
+          <a:lstStyle/>
+          <a:p>
+            <a:pPr algn="ctr" indent="0" marL="0">
+              <a:buNone/>
+            </a:pPr>
+            <a:r>
+              <a:rPr lang="en-GB" sz="1000" b="1" dirty="0">
+                <a:solidFill>
+                  <a:schemeClr val="bg1"/>
+                </a:solidFill>
+              </a:rPr>
+              <a:t>R8</a:t>
+            </a:r>
+          </a:p>
+        </p:txBody>
+      </p:sp>
+      <p:sp>
+        <p:nvSpPr>
+          <p:cNvPr id="34" name="R8 problem"/>
+          <p:cNvSpPr txBox="1"/>
+          <p:nvPr/>
+        </p:nvSpPr>
+        <p:spPr>
+          <a:xfrm>
+            <a:off x="868680" y="3374136"/>
+            <a:ext cx="3566160" cy="338328"/>
+          </a:xfrm>
+          <a:prstGeom prst="rect">
+            <a:avLst/>
+          </a:prstGeom>
+          <a:noFill/>
+        </p:spPr>
+        <p:txBody>
+          <a:bodyPr wrap="square" rtlCol="0" anchor="ctr"/>
+          <a:lstStyle/>
+          <a:p>
+            <a:pPr indent="0" marL="0">
+              <a:buNone/>
+            </a:pPr>
+            <a:r>
+              <a:rPr lang="en-GB" sz="1150" dirty="0">
+                <a:solidFill>
+                  <a:schemeClr val="tx1"/>
+                </a:solidFill>
+              </a:rPr>
+              <a:t>Live: one bad appraisal discarded all 12</a:t>
+            </a:r>
+          </a:p>
+        </p:txBody>
+      </p:sp>
+      <p:sp>
+        <p:nvSpPr>
+          <p:cNvPr id="35" name="R8 fix"/>
+          <p:cNvSpPr txBox="1"/>
+          <p:nvPr/>
+        </p:nvSpPr>
+        <p:spPr>
+          <a:xfrm>
+            <a:off x="4480560" y="3374136"/>
+            <a:ext cx="4206240" cy="338328"/>
+          </a:xfrm>
+          <a:prstGeom prst="rect">
+            <a:avLst/>
+          </a:prstGeom>
+          <a:noFill/>
+        </p:spPr>
+        <p:txBody>
+          <a:bodyPr wrap="square" rtlCol="0" anchor="ctr"/>
+          <a:lstStyle/>
+          <a:p>
+            <a:pPr indent="0" marL="0">
+              <a:buNone/>
+            </a:pPr>
+            <a:r>
+              <a:rPr lang="en-GB" sz="1150" b="1" dirty="0">
+                <a:solidFill>
+                  <a:schemeClr val="accent1"/>
+                </a:solidFill>
+              </a:rPr>
+              <a:t>Validate each item; 11 of 12 now kept from the LLM</a:t>
+            </a:r>
+          </a:p>
+        </p:txBody>
+      </p:sp>
+      <p:sp>
+        <p:nvSpPr>
+          <p:cNvPr id="36" name="R9 badge"/>
+          <p:cNvSpPr/>
+          <p:nvPr/>
+        </p:nvSpPr>
+        <p:spPr>
+          <a:xfrm>
+            <a:off x="457200" y="3739896"/>
+            <a:ext cx="283464" cy="283464"/>
+          </a:xfrm>
+          <a:prstGeom prst="ellipse">
+            <a:avLst/>
+          </a:prstGeom>
+          <a:solidFill>
+            <a:schemeClr val="accent1"/>
+          </a:solidFill>
+          <a:ln w="12700">
+            <a:solidFill>
+              <a:schemeClr val="accent1"/>
+            </a:solidFill>
+          </a:ln>
+        </p:spPr>
+      </p:sp>
+      <p:sp>
+        <p:nvSpPr>
+          <p:cNvPr id="37" name="R9 label"/>
+          <p:cNvSpPr txBox="1"/>
+          <p:nvPr/>
+        </p:nvSpPr>
+        <p:spPr>
+          <a:xfrm>
+            <a:off x="457200" y="3739896"/>
+            <a:ext cx="283464" cy="283464"/>
+          </a:xfrm>
+          <a:prstGeom prst="rect">
+            <a:avLst/>
+          </a:prstGeom>
+          <a:noFill/>
+        </p:spPr>
+        <p:txBody>
+          <a:bodyPr wrap="square" lIns="0" tIns="0" rIns="0" bIns="0" rtlCol="0" anchor="ctr"/>
+          <a:lstStyle/>
+          <a:p>
+            <a:pPr algn="ctr" indent="0" marL="0">
+              <a:buNone/>
+            </a:pPr>
+            <a:r>
+              <a:rPr lang="en-GB" sz="1000" b="1" dirty="0">
+                <a:solidFill>
+                  <a:schemeClr val="bg1"/>
+                </a:solidFill>
+              </a:rPr>
+              <a:t>R9</a:t>
+            </a:r>
+          </a:p>
+        </p:txBody>
+      </p:sp>
+      <p:sp>
+        <p:nvSpPr>
+          <p:cNvPr id="38" name="R9 problem"/>
+          <p:cNvSpPr txBox="1"/>
+          <p:nvPr/>
+        </p:nvSpPr>
+        <p:spPr>
+          <a:xfrm>
+            <a:off x="868680" y="3712464"/>
+            <a:ext cx="3566160" cy="338328"/>
+          </a:xfrm>
+          <a:prstGeom prst="rect">
+            <a:avLst/>
+          </a:prstGeom>
+          <a:noFill/>
+        </p:spPr>
+        <p:txBody>
+          <a:bodyPr wrap="square" rtlCol="0" anchor="ctr"/>
+          <a:lstStyle/>
+          <a:p>
+            <a:pPr indent="0" marL="0">
+              <a:buNone/>
+            </a:pPr>
+            <a:r>
+              <a:rPr lang="en-GB" sz="1150" dirty="0">
+                <a:solidFill>
+                  <a:schemeClr val="tx1"/>
+                </a:solidFill>
+              </a:rPr>
+              <a:t>Live: briefing JSON missing a comma</a:t>
+            </a:r>
+          </a:p>
+        </p:txBody>
+      </p:sp>
+      <p:sp>
+        <p:nvSpPr>
+          <p:cNvPr id="39" name="R9 fix"/>
+          <p:cNvSpPr txBox="1"/>
+          <p:nvPr/>
+        </p:nvSpPr>
+        <p:spPr>
+          <a:xfrm>
+            <a:off x="4480560" y="3712464"/>
+            <a:ext cx="4206240" cy="338328"/>
+          </a:xfrm>
+          <a:prstGeom prst="rect">
+            <a:avLst/>
+          </a:prstGeom>
+          <a:noFill/>
+        </p:spPr>
+        <p:txBody>
+          <a:bodyPr wrap="square" rtlCol="0" anchor="ctr"/>
+          <a:lstStyle/>
+          <a:p>
+            <a:pPr indent="0" marL="0">
+              <a:buNone/>
+            </a:pPr>
+            <a:r>
+              <a:rPr lang="en-GB" sz="1150" b="1" dirty="0">
+                <a:solidFill>
+                  <a:schemeClr val="accent1"/>
+                </a:solidFill>
+              </a:rPr>
+              <a:t>Opt-in JSON mode constrains output to valid JSON</a:t>
+            </a:r>
+          </a:p>
+        </p:txBody>
+      </p:sp>
+      <p:sp>
+        <p:nvSpPr>
+          <p:cNvPr id="40" name="Footnote"/>
+          <p:cNvSpPr txBox="1"/>
+          <p:nvPr/>
+        </p:nvSpPr>
+        <p:spPr>
+          <a:xfrm>
+            <a:off x="457200" y="4078224"/>
+            <a:ext cx="8229600" cy="457200"/>
+          </a:xfrm>
+          <a:prstGeom prst="rect">
+            <a:avLst/>
+          </a:prstGeom>
+          <a:noFill/>
+        </p:spPr>
+        <p:txBody>
+          <a:bodyPr wrap="square" rtlCol="0" anchor="ctr"/>
+          <a:lstStyle/>
+          <a:p>
+            <a:pPr indent="0" marL="0">
+              <a:buNone/>
+            </a:pPr>
+            <a:r>
+              <a:rPr lang="en-GB" sz="1100" i="1" dirty="0">
                 <a:solidFill>
                   <a:schemeClr val="accent5"/>
                 </a:solidFill>
               </a:rPr>
-              <a:t>Development history in Git: incremental commits from schemas, to sources, to agents, to interface, to tests, to fixes, to documentation. Each fix has a regression test (docs/TESTING.md).</a:t>
-            </a:r>
-            <a:endParaRPr lang="en-US" sz="1200" dirty="0"/>
-          </a:p>
-        </p:txBody>
-      </p:sp>
-      <p:sp>
-        <p:nvSpPr>
-          <p:cNvPr id="25" name="Slide Number Placeholder 0"/>
+              <a:t>R1 to R5 came from offline testing; R6 to R9 came from the live run on Windows 11 with Qwen2.5-7B under Ollama. Each fix has a regression test (docs/TESTING.md), and the Git history shows every step.</a:t>
+            </a:r>
+          </a:p>
+        </p:txBody>
+      </p:sp>
+      <p:sp>
+        <p:nvSpPr>
+          <p:cNvPr id="99" name="Slide Number Placeholder 0"/>
           <p:cNvSpPr>
             <a:spLocks noGrp="1"/>
           </p:cNvSpPr>

</xml_diff>

<commit_message>
Show the routing code on the re-planning demo slide
The brief asks the demonstration to highlight important sections of the
code. Slide 7 now shows route_after_critic and the conditional edge above
a condensed version of the re-planning log. The route function gains the
why-comment shown on the slide. README notes local model run times.

Co-Authored-By: Claude Opus 5.5 (1M context) <noreply@anthropic.com>
Claude-Session: https://claude.ai/code/session_01Mez8dJTBQNaNNdQEmFVTYu
</commit_message>
<xml_diff>
--- a/presentation/Academic_Evidence_Investigator.pptx
+++ b/presentation/Academic_Evidence_Investigator.pptx
@@ -1430,7 +1430,7 @@
           <a:p>
             <a:r>
               <a:rPr lang="en-US" dirty="0"/>
-              <a:t>This log shows the autonomous loop. For the question "Does retrieval reduce hallucination?" the first cycle retrieves only two relevant papers, both experimental. The Critic judges this insufficient and unbalanced, and suggests targeted searches. The Planner re-plans with queries for randomised controlled trials and meta-analyses. When that still finds little, it broadens the query in the third cycle. At the cycle limit the Reporter writes the briefing anyway, but labels it provisional and says why. By contrast, a question about how LLM agents plan, act and reflect was judged sufficient and balanced after one cycle. So the agent's behaviour depends on what it finds, not on a fixed script.</a:t>
+              <a:t>This is the code that makes the system an agent rather than a fixed pipeline. After every cycle, LangGraph calls route_after_critic. If the Critic's verdict is sufficient, or the cycle limit is reached, the graph goes to the Reporter; otherwise it loops back to the Planner. The comment explains why: the stop decision is a rule, not the model judging its own work, because self-reflection reduces but does not remove hallucination (Ji et al., 2023). Below is what that code did in an offline run of "Does retrieval reduce hallucination?". The Critic found only two relevant papers, so the Planner re-planned with queries for trials and meta-analyses, then broadened the search. At the cycle limit the Reporter wrote the briefing anyway, but labelled it provisional. By contrast, the live generative AI question was judged sufficient after one cycle. So the agent's behaviour depends on what it finds, not on a fixed script.</a:t>
             </a:r>
             <a:endParaRPr lang="en-US" dirty="0"/>
           </a:p>
@@ -7235,18 +7235,18 @@
       </p:sp>
       <p:sp>
         <p:nvSpPr>
-          <p:cNvPr id="3" name="Log panel"/>
+          <p:cNvPr id="4" name="Code panel"/>
           <p:cNvSpPr/>
           <p:nvPr/>
         </p:nvSpPr>
         <p:spPr>
           <a:xfrm>
-            <a:off x="457200" y="1097280"/>
-            <a:ext cx="8229600" cy="2697480"/>
+            <a:off x="457200" y="932688"/>
+            <a:ext cx="8229600" cy="1700784"/>
           </a:xfrm>
           <a:prstGeom prst="roundRect">
             <a:avLst>
-              <a:gd name="adj" fmla="val 2712"/>
+              <a:gd name="adj" fmla="val 3000"/>
             </a:avLst>
           </a:prstGeom>
           <a:solidFill>
@@ -7256,50 +7256,48 @@
             <a:solidFill>
               <a:schemeClr val="tx2"/>
             </a:solidFill>
-            <a:prstDash val="solid"/>
           </a:ln>
         </p:spPr>
       </p:sp>
       <p:sp>
         <p:nvSpPr>
-          <p:cNvPr id="4" name="Text 2"/>
+          <p:cNvPr id="5" name="Code"/>
           <p:cNvSpPr txBox="1"/>
           <p:nvPr/>
         </p:nvSpPr>
         <p:spPr>
           <a:xfrm>
-            <a:off x="640080" y="1188720"/>
-            <a:ext cx="7863840" cy="292608"/>
+            <a:off x="548640" y="978408"/>
+            <a:ext cx="8046720" cy="1609344"/>
           </a:xfrm>
           <a:prstGeom prst="rect">
             <a:avLst/>
           </a:prstGeom>
           <a:noFill/>
-          <a:ln/>
-        </p:spPr>
-        <p:txBody>
-          <a:bodyPr wrap="square" rtlCol="0" anchor="ctr"/>
+        </p:spPr>
+        <p:txBody>
+          <a:bodyPr wrap="square" lIns="45720" tIns="45720" rIns="45720" bIns="45720" rtlCol="0" anchor="t"/>
           <a:lstStyle/>
           <a:p>
             <a:pPr indent="0" marL="0">
-              <a:buNone/>
-            </a:pPr>
-            <a:r>
-              <a:rPr lang="en-US" sz="1200" dirty="0">
-                <a:solidFill>
-                  <a:schemeClr val="accent6"/>
+              <a:lnSpc>
+                <a:spcPct val="100000"/>
+              </a:lnSpc>
+              <a:buNone/>
+            </a:pPr>
+            <a:r>
+              <a:rPr lang="en-GB" sz="1000" b="1" dirty="0">
+                <a:solidFill>
+                  <a:schemeClr val="accent2"/>
                 </a:solidFill>
                 <a:latin typeface="Courier New" pitchFamily="34" charset="0"/>
                 <a:ea typeface="Courier New" pitchFamily="34" charset="-122"/>
                 <a:cs typeface="Courier New" pitchFamily="34" charset="-120"/>
               </a:rPr>
-              <a:t>cycle 1  </a:t>
-            </a:r>
-            <a:pPr indent="0" marL="0">
-              <a:buNone/>
-            </a:pPr>
-            <a:r>
-              <a:rPr lang="en-US" sz="1200" b="1" dirty="0">
+              <a:t xml:space="preserve">def </a:t>
+            </a:r>
+            <a:r>
+              <a:rPr lang="en-GB" sz="1000" b="1" dirty="0">
                 <a:solidFill>
                   <a:schemeClr val="bg1"/>
                 </a:solidFill>
@@ -7307,13 +7305,10 @@
                 <a:ea typeface="Courier New" pitchFamily="34" charset="-122"/>
                 <a:cs typeface="Courier New" pitchFamily="34" charset="-120"/>
               </a:rPr>
-              <a:t>planner    </a:t>
-            </a:r>
-            <a:pPr indent="0" marL="0">
-              <a:buNone/>
-            </a:pPr>
-            <a:r>
-              <a:rPr lang="en-US" sz="1200" dirty="0">
+              <a:t xml:space="preserve">route_after_critic</a:t>
+            </a:r>
+            <a:r>
+              <a:rPr lang="en-GB" sz="1000" dirty="0">
                 <a:solidFill>
                   <a:schemeClr val="bg1"/>
                 </a:solidFill>
@@ -7321,38 +7316,19 @@
                 <a:ea typeface="Courier New" pitchFamily="34" charset="-122"/>
                 <a:cs typeface="Courier New" pitchFamily="34" charset="-120"/>
               </a:rPr>
-              <a:t>plan: 3 keyword queries</a:t>
-            </a:r>
-            <a:endParaRPr lang="en-US" sz="1200" dirty="0"/>
-          </a:p>
-        </p:txBody>
-      </p:sp>
-      <p:sp>
-        <p:nvSpPr>
-          <p:cNvPr id="5" name="Text 3"/>
-          <p:cNvSpPr txBox="1"/>
-          <p:nvPr/>
-        </p:nvSpPr>
-        <p:spPr>
-          <a:xfrm>
-            <a:off x="640080" y="1499616"/>
-            <a:ext cx="7863840" cy="292608"/>
-          </a:xfrm>
-          <a:prstGeom prst="rect">
-            <a:avLst/>
-          </a:prstGeom>
-          <a:noFill/>
-          <a:ln/>
-        </p:spPr>
-        <p:txBody>
-          <a:bodyPr wrap="square" rtlCol="0" anchor="ctr"/>
-          <a:lstStyle/>
+              <a:t xml:space="preserve">(state: ResearchState) -&gt; str:</a:t>
+            </a:r>
+            <a:endParaRPr lang="en-GB" sz="1000" dirty="0"/>
+          </a:p>
           <a:p>
             <a:pPr indent="0" marL="0">
-              <a:buNone/>
-            </a:pPr>
-            <a:r>
-              <a:rPr lang="en-US" sz="1200" dirty="0">
+              <a:lnSpc>
+                <a:spcPct val="100000"/>
+              </a:lnSpc>
+              <a:buNone/>
+            </a:pPr>
+            <a:r>
+              <a:rPr lang="en-GB" sz="1000" dirty="0">
                 <a:solidFill>
                   <a:schemeClr val="accent6"/>
                 </a:solidFill>
@@ -7360,27 +7336,39 @@
                 <a:ea typeface="Courier New" pitchFamily="34" charset="-122"/>
                 <a:cs typeface="Courier New" pitchFamily="34" charset="-120"/>
               </a:rPr>
-              <a:t>cycle 1  </a:t>
-            </a:r>
+              <a:t xml:space="preserve">    # The stop decision is a rule, not the model's opinion of its own work:</a:t>
+            </a:r>
+            <a:endParaRPr lang="en-GB" sz="1000" dirty="0"/>
+          </a:p>
+          <a:p>
             <a:pPr indent="0" marL="0">
-              <a:buNone/>
-            </a:pPr>
-            <a:r>
-              <a:rPr lang="en-US" sz="1200" b="1" dirty="0">
-                <a:solidFill>
-                  <a:schemeClr val="bg1"/>
+              <a:lnSpc>
+                <a:spcPct val="100000"/>
+              </a:lnSpc>
+              <a:buNone/>
+            </a:pPr>
+            <a:r>
+              <a:rPr lang="en-GB" sz="1000" dirty="0">
+                <a:solidFill>
+                  <a:schemeClr val="accent6"/>
                 </a:solidFill>
                 <a:latin typeface="Courier New" pitchFamily="34" charset="0"/>
                 <a:ea typeface="Courier New" pitchFamily="34" charset="-122"/>
                 <a:cs typeface="Courier New" pitchFamily="34" charset="-120"/>
               </a:rPr>
-              <a:t>processing </a:t>
-            </a:r>
+              <a:t xml:space="preserve">    # self-reflection reduces but does not remove hallucination (Ji et al., 2023).</a:t>
+            </a:r>
+            <a:endParaRPr lang="en-GB" sz="1000" dirty="0"/>
+          </a:p>
+          <a:p>
             <a:pPr indent="0" marL="0">
-              <a:buNone/>
-            </a:pPr>
-            <a:r>
-              <a:rPr lang="en-US" sz="1200" dirty="0">
+              <a:lnSpc>
+                <a:spcPct val="100000"/>
+              </a:lnSpc>
+              <a:buNone/>
+            </a:pPr>
+            <a:r>
+              <a:rPr lang="en-GB" sz="1000" dirty="0">
                 <a:solidFill>
                   <a:schemeClr val="bg1"/>
                 </a:solidFill>
@@ -7388,133 +7376,83 @@
                 <a:ea typeface="Courier New" pitchFamily="34" charset="-122"/>
                 <a:cs typeface="Courier New" pitchFamily="34" charset="-120"/>
               </a:rPr>
-              <a:t>6 received, 4 duplicates removed, 2 retained</a:t>
-            </a:r>
-            <a:endParaRPr lang="en-US" sz="1200" dirty="0"/>
-          </a:p>
-        </p:txBody>
-      </p:sp>
-      <p:sp>
-        <p:nvSpPr>
-          <p:cNvPr id="6" name="Text 4"/>
-          <p:cNvSpPr txBox="1"/>
-          <p:nvPr/>
-        </p:nvSpPr>
-        <p:spPr>
-          <a:xfrm>
-            <a:off x="640080" y="1810512"/>
-            <a:ext cx="7863840" cy="292608"/>
-          </a:xfrm>
-          <a:prstGeom prst="rect">
-            <a:avLst/>
-          </a:prstGeom>
-          <a:noFill/>
-          <a:ln/>
-        </p:spPr>
-        <p:txBody>
-          <a:bodyPr wrap="square" rtlCol="0" anchor="ctr"/>
-          <a:lstStyle/>
+              <a:t xml:space="preserve">    verdict = state["verdict"]</a:t>
+            </a:r>
+            <a:endParaRPr lang="en-GB" sz="1000" dirty="0"/>
+          </a:p>
           <a:p>
             <a:pPr indent="0" marL="0">
-              <a:buNone/>
-            </a:pPr>
-            <a:r>
-              <a:rPr lang="en-US" sz="1200" dirty="0">
-                <a:solidFill>
-                  <a:schemeClr val="accent6"/>
+              <a:lnSpc>
+                <a:spcPct val="100000"/>
+              </a:lnSpc>
+              <a:buNone/>
+            </a:pPr>
+            <a:r>
+              <a:rPr lang="en-GB" sz="1000" b="1" dirty="0">
+                <a:solidFill>
+                  <a:schemeClr val="accent2"/>
                 </a:solidFill>
                 <a:latin typeface="Courier New" pitchFamily="34" charset="0"/>
                 <a:ea typeface="Courier New" pitchFamily="34" charset="-122"/>
                 <a:cs typeface="Courier New" pitchFamily="34" charset="-120"/>
               </a:rPr>
-              <a:t>cycle 1  </a:t>
-            </a:r>
-            <a:pPr indent="0" marL="0">
-              <a:buNone/>
-            </a:pPr>
-            <a:r>
-              <a:rPr lang="en-US" sz="1200" b="1" dirty="0">
-                <a:solidFill>
-                  <a:schemeClr val="accent2"/>
+              <a:t xml:space="preserve">    if </a:t>
+            </a:r>
+            <a:r>
+              <a:rPr lang="en-GB" sz="1000" dirty="0">
+                <a:solidFill>
+                  <a:schemeClr val="bg1"/>
                 </a:solidFill>
                 <a:latin typeface="Courier New" pitchFamily="34" charset="0"/>
                 <a:ea typeface="Courier New" pitchFamily="34" charset="-122"/>
                 <a:cs typeface="Courier New" pitchFamily="34" charset="-120"/>
               </a:rPr>
-              <a:t>critic     </a:t>
-            </a:r>
-            <a:pPr indent="0" marL="0">
-              <a:buNone/>
-            </a:pPr>
-            <a:r>
-              <a:rPr lang="en-US" sz="1200" dirty="0">
-                <a:solidFill>
-                  <a:schemeClr val="bg1"/>
+              <a:t xml:space="preserve">verdict.sufficient </a:t>
+            </a:r>
+            <a:r>
+              <a:rPr lang="en-GB" sz="1000" b="1" dirty="0">
+                <a:solidFill>
+                  <a:schemeClr val="accent2"/>
                 </a:solidFill>
                 <a:latin typeface="Courier New" pitchFamily="34" charset="0"/>
                 <a:ea typeface="Courier New" pitchFamily="34" charset="-122"/>
                 <a:cs typeface="Courier New" pitchFamily="34" charset="-120"/>
               </a:rPr>
-              <a:t>insufficient: 2 relevant papers (need 5); designs not varied</a:t>
-            </a:r>
-            <a:endParaRPr lang="en-US" sz="1200" dirty="0"/>
-          </a:p>
-        </p:txBody>
-      </p:sp>
-      <p:sp>
-        <p:nvSpPr>
-          <p:cNvPr id="7" name="Text 5"/>
-          <p:cNvSpPr txBox="1"/>
-          <p:nvPr/>
-        </p:nvSpPr>
-        <p:spPr>
-          <a:xfrm>
-            <a:off x="640080" y="2121408"/>
-            <a:ext cx="7863840" cy="292608"/>
-          </a:xfrm>
-          <a:prstGeom prst="rect">
-            <a:avLst/>
-          </a:prstGeom>
-          <a:noFill/>
-          <a:ln/>
-        </p:spPr>
-        <p:txBody>
-          <a:bodyPr wrap="square" rtlCol="0" anchor="ctr"/>
-          <a:lstStyle/>
-          <a:p>
-            <a:pPr indent="0" marL="0">
-              <a:buNone/>
-            </a:pPr>
-            <a:r>
-              <a:rPr lang="en-US" sz="1200" dirty="0">
-                <a:solidFill>
-                  <a:schemeClr val="accent6"/>
+              <a:t xml:space="preserve">or </a:t>
+            </a:r>
+            <a:r>
+              <a:rPr lang="en-GB" sz="1000" dirty="0">
+                <a:solidFill>
+                  <a:schemeClr val="bg1"/>
                 </a:solidFill>
                 <a:latin typeface="Courier New" pitchFamily="34" charset="0"/>
                 <a:ea typeface="Courier New" pitchFamily="34" charset="-122"/>
                 <a:cs typeface="Courier New" pitchFamily="34" charset="-120"/>
               </a:rPr>
-              <a:t>cycle 2  </a:t>
-            </a:r>
+              <a:t xml:space="preserve">state["cycle"] &gt;= max_cycles:</a:t>
+            </a:r>
+            <a:endParaRPr lang="en-GB" sz="1000" dirty="0"/>
+          </a:p>
+          <a:p>
             <a:pPr indent="0" marL="0">
-              <a:buNone/>
-            </a:pPr>
-            <a:r>
-              <a:rPr lang="en-US" sz="1200" b="1" dirty="0">
-                <a:solidFill>
-                  <a:schemeClr val="bg1"/>
+              <a:lnSpc>
+                <a:spcPct val="100000"/>
+              </a:lnSpc>
+              <a:buNone/>
+            </a:pPr>
+            <a:r>
+              <a:rPr lang="en-GB" sz="1000" b="1" dirty="0">
+                <a:solidFill>
+                  <a:schemeClr val="accent2"/>
                 </a:solidFill>
                 <a:latin typeface="Courier New" pitchFamily="34" charset="0"/>
                 <a:ea typeface="Courier New" pitchFamily="34" charset="-122"/>
                 <a:cs typeface="Courier New" pitchFamily="34" charset="-120"/>
               </a:rPr>
-              <a:t>planner    </a:t>
-            </a:r>
-            <a:pPr indent="0" marL="0">
-              <a:buNone/>
-            </a:pPr>
-            <a:r>
-              <a:rPr lang="en-US" sz="1200" dirty="0">
+              <a:t xml:space="preserve">        return </a:t>
+            </a:r>
+            <a:r>
+              <a:rPr lang="en-GB" sz="1000" dirty="0">
                 <a:solidFill>
                   <a:schemeClr val="bg1"/>
                 </a:solidFill>
@@ -7522,66 +7460,50 @@
                 <a:ea typeface="Courier New" pitchFamily="34" charset="-122"/>
                 <a:cs typeface="Courier New" pitchFamily="34" charset="-120"/>
               </a:rPr>
-              <a:t>re-plan: '... randomised controlled trial', '... meta-analysis'</a:t>
-            </a:r>
-            <a:endParaRPr lang="en-US" sz="1200" dirty="0"/>
-          </a:p>
-        </p:txBody>
-      </p:sp>
-      <p:sp>
-        <p:nvSpPr>
-          <p:cNvPr id="8" name="Text 6"/>
-          <p:cNvSpPr txBox="1"/>
-          <p:nvPr/>
-        </p:nvSpPr>
-        <p:spPr>
-          <a:xfrm>
-            <a:off x="640080" y="2432304"/>
-            <a:ext cx="7863840" cy="292608"/>
-          </a:xfrm>
-          <a:prstGeom prst="rect">
-            <a:avLst/>
-          </a:prstGeom>
-          <a:noFill/>
-          <a:ln/>
-        </p:spPr>
-        <p:txBody>
-          <a:bodyPr wrap="square" rtlCol="0" anchor="ctr"/>
-          <a:lstStyle/>
+              <a:t xml:space="preserve">"report"</a:t>
+            </a:r>
+            <a:endParaRPr lang="en-GB" sz="1000" dirty="0"/>
+          </a:p>
           <a:p>
             <a:pPr indent="0" marL="0">
-              <a:buNone/>
-            </a:pPr>
-            <a:r>
-              <a:rPr lang="en-US" sz="1200" dirty="0">
-                <a:solidFill>
-                  <a:schemeClr val="accent6"/>
+              <a:lnSpc>
+                <a:spcPct val="100000"/>
+              </a:lnSpc>
+              <a:buNone/>
+            </a:pPr>
+            <a:r>
+              <a:rPr lang="en-GB" sz="1000" b="1" dirty="0">
+                <a:solidFill>
+                  <a:schemeClr val="accent2"/>
                 </a:solidFill>
                 <a:latin typeface="Courier New" pitchFamily="34" charset="0"/>
                 <a:ea typeface="Courier New" pitchFamily="34" charset="-122"/>
                 <a:cs typeface="Courier New" pitchFamily="34" charset="-120"/>
               </a:rPr>
-              <a:t>cycle 2  </a:t>
-            </a:r>
-            <a:pPr indent="0" marL="0">
-              <a:buNone/>
-            </a:pPr>
-            <a:r>
-              <a:rPr lang="en-US" sz="1200" b="1" dirty="0">
-                <a:solidFill>
-                  <a:schemeClr val="accent2"/>
+              <a:t xml:space="preserve">    return </a:t>
+            </a:r>
+            <a:r>
+              <a:rPr lang="en-GB" sz="1000" dirty="0">
+                <a:solidFill>
+                  <a:schemeClr val="bg1"/>
                 </a:solidFill>
                 <a:latin typeface="Courier New" pitchFamily="34" charset="0"/>
                 <a:ea typeface="Courier New" pitchFamily="34" charset="-122"/>
                 <a:cs typeface="Courier New" pitchFamily="34" charset="-120"/>
               </a:rPr>
-              <a:t>critic     </a:t>
-            </a:r>
+              <a:t xml:space="preserve">"replan"</a:t>
+            </a:r>
+            <a:endParaRPr lang="en-GB" sz="1000" dirty="0"/>
+          </a:p>
+          <a:p>
             <a:pPr indent="0" marL="0">
-              <a:buNone/>
-            </a:pPr>
-            <a:r>
-              <a:rPr lang="en-US" sz="1200" dirty="0">
+              <a:lnSpc>
+                <a:spcPct val="100000"/>
+              </a:lnSpc>
+              <a:buNone/>
+            </a:pPr>
+            <a:r>
+              <a:rPr lang="en-GB" sz="1000" dirty="0">
                 <a:solidFill>
                   <a:schemeClr val="bg1"/>
                 </a:solidFill>
@@ -7589,52 +7511,39 @@
                 <a:ea typeface="Courier New" pitchFamily="34" charset="-122"/>
                 <a:cs typeface="Courier New" pitchFamily="34" charset="-120"/>
               </a:rPr>
-              <a:t>insufficient: still 2 relevant papers</a:t>
-            </a:r>
-            <a:endParaRPr lang="en-US" sz="1200" dirty="0"/>
-          </a:p>
-        </p:txBody>
-      </p:sp>
-      <p:sp>
-        <p:nvSpPr>
-          <p:cNvPr id="9" name="Text 7"/>
-          <p:cNvSpPr txBox="1"/>
-          <p:nvPr/>
-        </p:nvSpPr>
-        <p:spPr>
-          <a:xfrm>
-            <a:off x="640080" y="2743200"/>
-            <a:ext cx="7863840" cy="292608"/>
-          </a:xfrm>
-          <a:prstGeom prst="rect">
-            <a:avLst/>
-          </a:prstGeom>
-          <a:noFill/>
-          <a:ln/>
-        </p:spPr>
-        <p:txBody>
-          <a:bodyPr wrap="square" rtlCol="0" anchor="ctr"/>
-          <a:lstStyle/>
+              <a:t xml:space="preserve"> </a:t>
+            </a:r>
+            <a:endParaRPr lang="en-GB" sz="1000" dirty="0"/>
+          </a:p>
           <a:p>
             <a:pPr indent="0" marL="0">
-              <a:buNone/>
-            </a:pPr>
-            <a:r>
-              <a:rPr lang="en-US" sz="1200" dirty="0">
-                <a:solidFill>
-                  <a:schemeClr val="accent6"/>
+              <a:lnSpc>
+                <a:spcPct val="100000"/>
+              </a:lnSpc>
+              <a:buNone/>
+            </a:pPr>
+            <a:r>
+              <a:rPr lang="en-GB" sz="1000" dirty="0">
+                <a:solidFill>
+                  <a:schemeClr val="bg1"/>
                 </a:solidFill>
                 <a:latin typeface="Courier New" pitchFamily="34" charset="0"/>
                 <a:ea typeface="Courier New" pitchFamily="34" charset="-122"/>
                 <a:cs typeface="Courier New" pitchFamily="34" charset="-120"/>
               </a:rPr>
-              <a:t>cycle 3  </a:t>
-            </a:r>
+              <a:t xml:space="preserve">graph.add_conditional_edges("critic", make_router(max_cycles),</a:t>
+            </a:r>
+            <a:endParaRPr lang="en-GB" sz="1000" dirty="0"/>
+          </a:p>
+          <a:p>
             <a:pPr indent="0" marL="0">
-              <a:buNone/>
-            </a:pPr>
-            <a:r>
-              <a:rPr lang="en-US" sz="1200" b="1" dirty="0">
+              <a:lnSpc>
+                <a:spcPct val="100000"/>
+              </a:lnSpc>
+              <a:buNone/>
+            </a:pPr>
+            <a:r>
+              <a:rPr lang="en-GB" sz="1000" dirty="0">
                 <a:solidFill>
                   <a:schemeClr val="bg1"/>
                 </a:solidFill>
@@ -7642,240 +7551,350 @@
                 <a:ea typeface="Courier New" pitchFamily="34" charset="-122"/>
                 <a:cs typeface="Courier New" pitchFamily="34" charset="-120"/>
               </a:rPr>
-              <a:t>planner    </a:t>
-            </a:r>
+              <a:t xml:space="preserve">                            {"replan": "planner", "report": "reporter"})</a:t>
+            </a:r>
+            <a:endParaRPr lang="en-GB" sz="1000" dirty="0"/>
+          </a:p>
+        </p:txBody>
+      </p:sp>
+      <p:sp>
+        <p:nvSpPr>
+          <p:cNvPr id="6" name="Code caption"/>
+          <p:cNvSpPr txBox="1"/>
+          <p:nvPr/>
+        </p:nvSpPr>
+        <p:spPr>
+          <a:xfrm>
+            <a:off x="457200" y="2642616"/>
+            <a:ext cx="8229600" cy="219456"/>
+          </a:xfrm>
+          <a:prstGeom prst="rect">
+            <a:avLst/>
+          </a:prstGeom>
+          <a:noFill/>
+        </p:spPr>
+        <p:txBody>
+          <a:bodyPr wrap="square" rtlCol="0" anchor="ctr"/>
+          <a:lstStyle/>
+          <a:p>
             <a:pPr indent="0" marL="0">
-              <a:buNone/>
-            </a:pPr>
-            <a:r>
-              <a:rPr lang="en-US" sz="1200" dirty="0">
-                <a:solidFill>
-                  <a:schemeClr val="bg1"/>
+              <a:lnSpc>
+                <a:spcPct val="100000"/>
+              </a:lnSpc>
+              <a:buNone/>
+            </a:pPr>
+            <a:r>
+              <a:rPr lang="en-GB" sz="1000" i="1" dirty="0">
+                <a:solidFill>
+                  <a:schemeClr val="accent5"/>
+                </a:solidFill>
+              </a:rPr>
+              <a:t xml:space="preserve">evidence_investigator/graph.py: the conditional edge is the agent's decision point</a:t>
+            </a:r>
+            <a:endParaRPr lang="en-GB" sz="1000" dirty="0"/>
+          </a:p>
+        </p:txBody>
+      </p:sp>
+      <p:sp>
+        <p:nvSpPr>
+          <p:cNvPr id="7" name="Log panel"/>
+          <p:cNvSpPr/>
+          <p:nvPr/>
+        </p:nvSpPr>
+        <p:spPr>
+          <a:xfrm>
+            <a:off x="457200" y="2889504"/>
+            <a:ext cx="8229600" cy="969264"/>
+          </a:xfrm>
+          <a:prstGeom prst="roundRect">
+            <a:avLst>
+              <a:gd name="adj" fmla="val 3000"/>
+            </a:avLst>
+          </a:prstGeom>
+          <a:solidFill>
+            <a:schemeClr val="bg2"/>
+          </a:solidFill>
+          <a:ln w="12700">
+            <a:solidFill>
+              <a:schemeClr val="bg2"/>
+            </a:solidFill>
+          </a:ln>
+        </p:spPr>
+      </p:sp>
+      <p:sp>
+        <p:nvSpPr>
+          <p:cNvPr id="8" name="Log"/>
+          <p:cNvSpPr txBox="1"/>
+          <p:nvPr/>
+        </p:nvSpPr>
+        <p:spPr>
+          <a:xfrm>
+            <a:off x="548640" y="2916936"/>
+            <a:ext cx="8046720" cy="914400"/>
+          </a:xfrm>
+          <a:prstGeom prst="rect">
+            <a:avLst/>
+          </a:prstGeom>
+          <a:noFill/>
+        </p:spPr>
+        <p:txBody>
+          <a:bodyPr wrap="square" lIns="45720" tIns="45720" rIns="45720" bIns="45720" rtlCol="0" anchor="ctr"/>
+          <a:lstStyle/>
+          <a:p>
+            <a:pPr indent="0" marL="0">
+              <a:lnSpc>
+                <a:spcPct val="100000"/>
+              </a:lnSpc>
+              <a:buNone/>
+            </a:pPr>
+            <a:r>
+              <a:rPr lang="en-GB" sz="1050" dirty="0">
+                <a:solidFill>
+                  <a:schemeClr val="accent5"/>
                 </a:solidFill>
                 <a:latin typeface="Courier New" pitchFamily="34" charset="0"/>
                 <a:ea typeface="Courier New" pitchFamily="34" charset="-122"/>
                 <a:cs typeface="Courier New" pitchFamily="34" charset="-120"/>
               </a:rPr>
-              <a:t>re-plan: broadened to 'retrieval reduce'</a:t>
-            </a:r>
-            <a:endParaRPr lang="en-US" sz="1200" dirty="0"/>
-          </a:p>
-        </p:txBody>
-      </p:sp>
-      <p:sp>
-        <p:nvSpPr>
-          <p:cNvPr id="10" name="Text 8"/>
-          <p:cNvSpPr txBox="1"/>
-          <p:nvPr/>
-        </p:nvSpPr>
-        <p:spPr>
-          <a:xfrm>
-            <a:off x="640080" y="3054096"/>
-            <a:ext cx="7863840" cy="292608"/>
-          </a:xfrm>
-          <a:prstGeom prst="rect">
-            <a:avLst/>
-          </a:prstGeom>
-          <a:noFill/>
-          <a:ln/>
-        </p:spPr>
-        <p:txBody>
-          <a:bodyPr wrap="square" rtlCol="0" anchor="ctr"/>
-          <a:lstStyle/>
-          <a:p>
-            <a:pPr indent="0" marL="0">
-              <a:buNone/>
-            </a:pPr>
-            <a:r>
-              <a:rPr lang="en-US" sz="1200" dirty="0">
-                <a:solidFill>
-                  <a:schemeClr val="accent6"/>
+              <a:t xml:space="preserve">cycle 1  </a:t>
+            </a:r>
+            <a:r>
+              <a:rPr lang="en-GB" sz="1050" b="1" dirty="0">
+                <a:solidFill>
+                  <a:schemeClr val="accent1"/>
                 </a:solidFill>
                 <a:latin typeface="Courier New" pitchFamily="34" charset="0"/>
                 <a:ea typeface="Courier New" pitchFamily="34" charset="-122"/>
                 <a:cs typeface="Courier New" pitchFamily="34" charset="-120"/>
               </a:rPr>
-              <a:t>cycle 3  </a:t>
-            </a:r>
-            <a:pPr indent="0" marL="0">
-              <a:buNone/>
-            </a:pPr>
-            <a:r>
-              <a:rPr lang="en-US" sz="1200" b="1" dirty="0">
-                <a:solidFill>
-                  <a:schemeClr val="accent2"/>
+              <a:t xml:space="preserve">critic    </a:t>
+            </a:r>
+            <a:r>
+              <a:rPr lang="en-GB" sz="1050" dirty="0">
+                <a:solidFill>
+                  <a:schemeClr val="tx1"/>
                 </a:solidFill>
                 <a:latin typeface="Courier New" pitchFamily="34" charset="0"/>
                 <a:ea typeface="Courier New" pitchFamily="34" charset="-122"/>
                 <a:cs typeface="Courier New" pitchFamily="34" charset="-120"/>
               </a:rPr>
-              <a:t>critic     </a:t>
-            </a:r>
+              <a:t xml:space="preserve">insufficient: 2 relevant papers (need 5); designs not varied</a:t>
+            </a:r>
+            <a:endParaRPr lang="en-GB" sz="1050" dirty="0"/>
+          </a:p>
+          <a:p>
             <a:pPr indent="0" marL="0">
-              <a:buNone/>
-            </a:pPr>
-            <a:r>
-              <a:rPr lang="en-US" sz="1200" dirty="0">
-                <a:solidFill>
-                  <a:schemeClr val="bg1"/>
+              <a:lnSpc>
+                <a:spcPct val="100000"/>
+              </a:lnSpc>
+              <a:buNone/>
+            </a:pPr>
+            <a:r>
+              <a:rPr lang="en-GB" sz="1050" dirty="0">
+                <a:solidFill>
+                  <a:schemeClr val="accent5"/>
                 </a:solidFill>
                 <a:latin typeface="Courier New" pitchFamily="34" charset="0"/>
                 <a:ea typeface="Courier New" pitchFamily="34" charset="-122"/>
                 <a:cs typeface="Courier New" pitchFamily="34" charset="-120"/>
               </a:rPr>
-              <a:t>insufficient: 3 relevant papers</a:t>
-            </a:r>
-            <a:endParaRPr lang="en-US" sz="1200" dirty="0"/>
-          </a:p>
-        </p:txBody>
-      </p:sp>
-      <p:sp>
-        <p:nvSpPr>
-          <p:cNvPr id="11" name="Text 9"/>
-          <p:cNvSpPr txBox="1"/>
-          <p:nvPr/>
-        </p:nvSpPr>
-        <p:spPr>
-          <a:xfrm>
-            <a:off x="640080" y="3364992"/>
-            <a:ext cx="7863840" cy="292608"/>
-          </a:xfrm>
-          <a:prstGeom prst="rect">
-            <a:avLst/>
-          </a:prstGeom>
-          <a:noFill/>
-          <a:ln/>
-        </p:spPr>
-        <p:txBody>
-          <a:bodyPr wrap="square" rtlCol="0" anchor="ctr"/>
-          <a:lstStyle/>
-          <a:p>
-            <a:pPr indent="0" marL="0">
-              <a:buNone/>
-            </a:pPr>
-            <a:r>
-              <a:rPr lang="en-US" sz="1200" dirty="0">
-                <a:solidFill>
-                  <a:schemeClr val="accent6"/>
+              <a:t xml:space="preserve">cycle 2  </a:t>
+            </a:r>
+            <a:r>
+              <a:rPr lang="en-GB" sz="1050" b="1" dirty="0">
+                <a:solidFill>
+                  <a:schemeClr val="accent1"/>
                 </a:solidFill>
                 <a:latin typeface="Courier New" pitchFamily="34" charset="0"/>
                 <a:ea typeface="Courier New" pitchFamily="34" charset="-122"/>
                 <a:cs typeface="Courier New" pitchFamily="34" charset="-120"/>
               </a:rPr>
-              <a:t>cycle 3  </a:t>
-            </a:r>
-            <a:pPr indent="0" marL="0">
-              <a:buNone/>
-            </a:pPr>
-            <a:r>
-              <a:rPr lang="en-US" sz="1200" b="1" dirty="0">
-                <a:solidFill>
-                  <a:schemeClr val="bg1"/>
+              <a:t xml:space="preserve">planner   </a:t>
+            </a:r>
+            <a:r>
+              <a:rPr lang="en-GB" sz="1050" dirty="0">
+                <a:solidFill>
+                  <a:schemeClr val="tx1"/>
                 </a:solidFill>
                 <a:latin typeface="Courier New" pitchFamily="34" charset="0"/>
                 <a:ea typeface="Courier New" pitchFamily="34" charset="-122"/>
                 <a:cs typeface="Courier New" pitchFamily="34" charset="-120"/>
               </a:rPr>
-              <a:t>reporter   </a:t>
-            </a:r>
+              <a:t xml:space="preserve">re-plan: '... randomised controlled trial', '... meta-analysis'</a:t>
+            </a:r>
+            <a:endParaRPr lang="en-GB" sz="1050" dirty="0"/>
+          </a:p>
+          <a:p>
             <a:pPr indent="0" marL="0">
-              <a:buNone/>
-            </a:pPr>
-            <a:r>
-              <a:rPr lang="en-US" sz="1200" dirty="0">
-                <a:solidFill>
-                  <a:schemeClr val="bg1"/>
+              <a:lnSpc>
+                <a:spcPct val="100000"/>
+              </a:lnSpc>
+              <a:buNone/>
+            </a:pPr>
+            <a:r>
+              <a:rPr lang="en-GB" sz="1050" dirty="0">
+                <a:solidFill>
+                  <a:schemeClr val="accent5"/>
                 </a:solidFill>
                 <a:latin typeface="Courier New" pitchFamily="34" charset="0"/>
                 <a:ea typeface="Courier New" pitchFamily="34" charset="-122"/>
                 <a:cs typeface="Courier New" pitchFamily="34" charset="-120"/>
               </a:rPr>
-              <a:t>cycle limit reached: briefing marked provisional</a:t>
-            </a:r>
-            <a:endParaRPr lang="en-US" sz="1200" dirty="0"/>
-          </a:p>
-        </p:txBody>
-      </p:sp>
-      <p:sp>
-        <p:nvSpPr>
-          <p:cNvPr id="12" name="Text 10"/>
+              <a:t xml:space="preserve">cycle 2  </a:t>
+            </a:r>
+            <a:r>
+              <a:rPr lang="en-GB" sz="1050" b="1" dirty="0">
+                <a:solidFill>
+                  <a:schemeClr val="accent1"/>
+                </a:solidFill>
+                <a:latin typeface="Courier New" pitchFamily="34" charset="0"/>
+                <a:ea typeface="Courier New" pitchFamily="34" charset="-122"/>
+                <a:cs typeface="Courier New" pitchFamily="34" charset="-120"/>
+              </a:rPr>
+              <a:t xml:space="preserve">critic    </a:t>
+            </a:r>
+            <a:r>
+              <a:rPr lang="en-GB" sz="1050" dirty="0">
+                <a:solidFill>
+                  <a:schemeClr val="tx1"/>
+                </a:solidFill>
+                <a:latin typeface="Courier New" pitchFamily="34" charset="0"/>
+                <a:ea typeface="Courier New" pitchFamily="34" charset="-122"/>
+                <a:cs typeface="Courier New" pitchFamily="34" charset="-120"/>
+              </a:rPr>
+              <a:t xml:space="preserve">insufficient: still 2 relevant papers</a:t>
+            </a:r>
+            <a:endParaRPr lang="en-GB" sz="1050" dirty="0"/>
+          </a:p>
+          <a:p>
+            <a:pPr indent="0" marL="0">
+              <a:lnSpc>
+                <a:spcPct val="100000"/>
+              </a:lnSpc>
+              <a:buNone/>
+            </a:pPr>
+            <a:r>
+              <a:rPr lang="en-GB" sz="1050" dirty="0">
+                <a:solidFill>
+                  <a:schemeClr val="accent5"/>
+                </a:solidFill>
+                <a:latin typeface="Courier New" pitchFamily="34" charset="0"/>
+                <a:ea typeface="Courier New" pitchFamily="34" charset="-122"/>
+                <a:cs typeface="Courier New" pitchFamily="34" charset="-120"/>
+              </a:rPr>
+              <a:t xml:space="preserve">cycle 3  </a:t>
+            </a:r>
+            <a:r>
+              <a:rPr lang="en-GB" sz="1050" b="1" dirty="0">
+                <a:solidFill>
+                  <a:schemeClr val="accent1"/>
+                </a:solidFill>
+                <a:latin typeface="Courier New" pitchFamily="34" charset="0"/>
+                <a:ea typeface="Courier New" pitchFamily="34" charset="-122"/>
+                <a:cs typeface="Courier New" pitchFamily="34" charset="-120"/>
+              </a:rPr>
+              <a:t xml:space="preserve">planner   </a:t>
+            </a:r>
+            <a:r>
+              <a:rPr lang="en-GB" sz="1050" dirty="0">
+                <a:solidFill>
+                  <a:schemeClr val="tx1"/>
+                </a:solidFill>
+                <a:latin typeface="Courier New" pitchFamily="34" charset="0"/>
+                <a:ea typeface="Courier New" pitchFamily="34" charset="-122"/>
+                <a:cs typeface="Courier New" pitchFamily="34" charset="-120"/>
+              </a:rPr>
+              <a:t xml:space="preserve">re-plan: broadened to 'retrieval reduce'</a:t>
+            </a:r>
+            <a:endParaRPr lang="en-GB" sz="1050" dirty="0"/>
+          </a:p>
+          <a:p>
+            <a:pPr indent="0" marL="0">
+              <a:lnSpc>
+                <a:spcPct val="100000"/>
+              </a:lnSpc>
+              <a:buNone/>
+            </a:pPr>
+            <a:r>
+              <a:rPr lang="en-GB" sz="1050" dirty="0">
+                <a:solidFill>
+                  <a:schemeClr val="accent5"/>
+                </a:solidFill>
+                <a:latin typeface="Courier New" pitchFamily="34" charset="0"/>
+                <a:ea typeface="Courier New" pitchFamily="34" charset="-122"/>
+                <a:cs typeface="Courier New" pitchFamily="34" charset="-120"/>
+              </a:rPr>
+              <a:t xml:space="preserve">cycle 3  </a:t>
+            </a:r>
+            <a:r>
+              <a:rPr lang="en-GB" sz="1050" b="1" dirty="0">
+                <a:solidFill>
+                  <a:schemeClr val="accent1"/>
+                </a:solidFill>
+                <a:latin typeface="Courier New" pitchFamily="34" charset="0"/>
+                <a:ea typeface="Courier New" pitchFamily="34" charset="-122"/>
+                <a:cs typeface="Courier New" pitchFamily="34" charset="-120"/>
+              </a:rPr>
+              <a:t xml:space="preserve">reporter  </a:t>
+            </a:r>
+            <a:r>
+              <a:rPr lang="en-GB" sz="1050" dirty="0">
+                <a:solidFill>
+                  <a:schemeClr val="tx1"/>
+                </a:solidFill>
+                <a:latin typeface="Courier New" pitchFamily="34" charset="0"/>
+                <a:ea typeface="Courier New" pitchFamily="34" charset="-122"/>
+                <a:cs typeface="Courier New" pitchFamily="34" charset="-120"/>
+              </a:rPr>
+              <a:t xml:space="preserve">cycle limit reached: briefing marked provisional</a:t>
+            </a:r>
+            <a:endParaRPr lang="en-GB" sz="1050" dirty="0"/>
+          </a:p>
+        </p:txBody>
+      </p:sp>
+      <p:sp>
+        <p:nvSpPr>
+          <p:cNvPr id="9" name="Contrast"/>
           <p:cNvSpPr txBox="1"/>
           <p:nvPr/>
         </p:nvSpPr>
         <p:spPr>
           <a:xfrm>
-            <a:off x="457200" y="3840480"/>
-            <a:ext cx="8229600" cy="274320"/>
+            <a:off x="457200" y="3867912"/>
+            <a:ext cx="8229600" cy="384048"/>
           </a:xfrm>
           <a:prstGeom prst="rect">
             <a:avLst/>
           </a:prstGeom>
           <a:noFill/>
-          <a:ln/>
-        </p:spPr>
-        <p:txBody>
-          <a:bodyPr wrap="square" rtlCol="0" anchor="ctr"/>
+        </p:spPr>
+        <p:txBody>
+          <a:bodyPr wrap="square" rtlCol="0" anchor="t"/>
           <a:lstStyle/>
           <a:p>
             <a:pPr indent="0" marL="0">
-              <a:buNone/>
-            </a:pPr>
-            <a:r>
-              <a:rPr lang="en-US" sz="1100" i="1" dirty="0">
-                <a:solidFill>
-                  <a:schemeClr val="accent5"/>
-                </a:solidFill>
-              </a:rPr>
-              <a:t>Offline run of "Does retrieval reduce hallucination?" (evidence/run-offline-max-cycles.log)</a:t>
-            </a:r>
-            <a:endParaRPr lang="en-US" sz="1100" dirty="0"/>
-          </a:p>
-        </p:txBody>
-      </p:sp>
-      <p:sp>
-        <p:nvSpPr>
-          <p:cNvPr id="13" name="Text 11"/>
-          <p:cNvSpPr txBox="1"/>
-          <p:nvPr/>
-        </p:nvSpPr>
-        <p:spPr>
-          <a:xfrm>
-            <a:off x="457200" y="4114800"/>
-            <a:ext cx="8229600" cy="502920"/>
-          </a:xfrm>
-          <a:prstGeom prst="rect">
-            <a:avLst/>
-          </a:prstGeom>
-          <a:noFill/>
-          <a:ln/>
-        </p:spPr>
-        <p:txBody>
-          <a:bodyPr wrap="square" rtlCol="0" anchor="ctr"/>
-          <a:lstStyle/>
-          <a:p>
-            <a:pPr indent="0" marL="0">
-              <a:buNone/>
-            </a:pPr>
-            <a:r>
-              <a:rPr lang="en-US" sz="1300" b="1" dirty="0">
+              <a:lnSpc>
+                <a:spcPct val="100000"/>
+              </a:lnSpc>
+              <a:buNone/>
+            </a:pPr>
+            <a:r>
+              <a:rPr lang="en-GB" sz="1100" b="1" dirty="0">
                 <a:solidFill>
                   <a:schemeClr val="tx2"/>
                 </a:solidFill>
               </a:rPr>
-              <a:t>Contrast: </a:t>
-            </a:r>
-            <a:pPr indent="0" marL="0">
-              <a:buNone/>
-            </a:pPr>
-            <a:r>
-              <a:rPr lang="en-US" sz="1300" dirty="0">
+              <a:t xml:space="preserve">What it did: </a:t>
+            </a:r>
+            <a:r>
+              <a:rPr lang="en-GB" sz="1100" dirty="0">
                 <a:solidFill>
                   <a:schemeClr val="tx1"/>
                 </a:solidFill>
               </a:rPr>
-              <a:t>"How do LLM-based agents plan, act and reflect?" was judged sufficient and balanced after one cycle (10 papers, 4 designs).</a:t>
-            </a:r>
-            <a:endParaRPr lang="en-US" sz="1300" dirty="0"/>
+              <a:t xml:space="preserve">offline run of "Does retrieval reduce hallucination?" (evidence/run-offline-max-cycles.log). By contrast, the live generative AI question was judged sufficient after one cycle.</a:t>
+            </a:r>
+            <a:endParaRPr lang="en-GB" sz="1100" dirty="0"/>
           </a:p>
         </p:txBody>
       </p:sp>

</xml_diff>

<commit_message>
Cover the four demonstration points in the deck; fix README clone URL
Slide 5 is a new Code and executables slide (module map plus the CLI,
web and test commands). Slide 9 is now a development timeline from
design through offline build, R1-R5 and the live run's R6-R9. The four
design decisions are folded into slide 4 to stay within ten slides.
Notes and transcript.md follow the new order. README install steps
now give the real repository URL and folder name.

Co-Authored-By: Claude Opus 5.5 (1M context) <noreply@anthropic.com>
Claude-Session: https://claude.ai/code/session_01Mez8dJTBQNaNNdQEmFVTYu
</commit_message>
<xml_diff>
--- a/presentation/Academic_Evidence_Investigator.pptx
+++ b/presentation/Academic_Evidence_Investigator.pptx
@@ -9,7 +9,7 @@
     <p:sldId id="257" r:id="rId3"/>
     <p:sldId id="258" r:id="rId4"/>
     <p:sldId id="259" r:id="rId5"/>
-    <p:sldId id="260" r:id="rId6"/>
+    <p:sldId id="266" r:id="rId17"/>
     <p:sldId id="261" r:id="rId7"/>
     <p:sldId id="262" r:id="rId8"/>
     <p:sldId id="263" r:id="rId9"/>
@@ -944,6 +944,94 @@
 </p:notes>
 </file>
 
+<file path=ppt/notesSlides/notesSlide11.xml><?xml version="1.0" encoding="utf-8"?>
+<p:notes xmlns:a="http://schemas.openxmlformats.org/drawingml/2006/main" xmlns:r="http://schemas.openxmlformats.org/officeDocument/2006/relationships" xmlns:p="http://schemas.openxmlformats.org/presentationml/2006/main">
+  <p:cSld>
+    <p:spTree>
+      <p:nvGrpSpPr>
+        <p:cNvPr id="1" name=""/>
+        <p:cNvGrpSpPr/>
+        <p:nvPr/>
+      </p:nvGrpSpPr>
+      <p:grpSpPr>
+        <a:xfrm>
+          <a:off x="0" y="0"/>
+          <a:ext cx="0" cy="0"/>
+          <a:chOff x="0" y="0"/>
+          <a:chExt cx="0" cy="0"/>
+        </a:xfrm>
+      </p:grpSpPr>
+      <p:sp>
+        <p:nvSpPr>
+          <p:cNvPr id="2" name="Slide Image Placeholder 1"/>
+          <p:cNvSpPr>
+            <a:spLocks noGrp="1" noRot="1" noChangeAspect="1"/>
+          </p:cNvSpPr>
+          <p:nvPr>
+            <p:ph type="sldImg"/>
+          </p:nvPr>
+        </p:nvSpPr>
+        <p:spPr/>
+      </p:sp>
+      <p:sp>
+        <p:nvSpPr>
+          <p:cNvPr id="3" name="Notes Placeholder 2"/>
+          <p:cNvSpPr>
+            <a:spLocks noGrp="1"/>
+          </p:cNvSpPr>
+          <p:nvPr>
+            <p:ph type="body" idx="1"/>
+          </p:nvPr>
+        </p:nvSpPr>
+        <p:spPr/>
+        <p:txBody>
+          <a:bodyPr/>
+          <a:lstStyle/>
+          <a:p>
+            <a:r>
+              <a:rPr lang="en-US" dirty="0"/>
+              <a:t>Here is how the code is organised and how it is run. graph.py wires the agents together, state.py holds the shared research state, each agent has its own module, and the sources, the LLM client, processing and storage are kept separate, so each can be tested on its own. There are three ways to run it. The command line takes a question and prints the briefing with the audit trail of every agent step. The web interface offers the same run in a browser, with the run history. And the test suite runs 83 tests, all passing, with 96 percent coverage. Live mode uses Qwen running locally under Ollama; offline mode runs the same code on a bundled corpus. The README gives the full setup.</a:t>
+            </a:r>
+            <a:endParaRPr lang="en-US" dirty="0"/>
+          </a:p>
+        </p:txBody>
+      </p:sp>
+      <p:sp>
+        <p:nvSpPr>
+          <p:cNvPr id="4" name="Slide Number Placeholder 3"/>
+          <p:cNvSpPr>
+            <a:spLocks noGrp="1"/>
+          </p:cNvSpPr>
+          <p:nvPr>
+            <p:ph type="sldNum" sz="quarter" idx="10"/>
+          </p:nvPr>
+        </p:nvSpPr>
+        <p:spPr/>
+        <p:txBody>
+          <a:bodyPr/>
+          <a:lstStyle/>
+          <a:p>
+            <a:fld id="{F7021451-1387-4CA6-816F-3879F97B5CBC}" type="slidenum">
+              <a:rPr lang="en-US"/>
+              <a:t>9</a:t>
+            </a:fld>
+            <a:endParaRPr lang="en-US"/>
+          </a:p>
+        </p:txBody>
+      </p:sp>
+    </p:spTree>
+    <p:extLst>
+      <p:ext uri="{BB962C8B-B14F-4D97-AF65-F5344CB8AC3E}">
+        <p14:creationId xmlns:p14="http://schemas.microsoft.com/office/powerpoint/2010/main" val="1024086991"/>
+      </p:ext>
+    </p:extLst>
+  </p:cSld>
+  <p:clrMapOvr>
+    <a:masterClrMapping/>
+  </p:clrMapOvr>
+</p:notes>
+</file>
+
 <file path=ppt/notesSlides/notesSlide2.xml><?xml version="1.0" encoding="utf-8"?>
 <p:notes xmlns:a="http://schemas.openxmlformats.org/drawingml/2006/main" xmlns:r="http://schemas.openxmlformats.org/officeDocument/2006/relationships" xmlns:p="http://schemas.openxmlformats.org/presentationml/2006/main">
   <p:cSld>
@@ -1166,7 +1254,7 @@
           <a:p>
             <a:r>
               <a:rPr lang="en-US" dirty="0"/>
-              <a:t>The guiding principle, taken from the proposal, is that the LLM only does work that needs language understanding. Qwen2.5-7B-Instruct proposes a plan, appraises abstracts and drafts the briefing. For the live demonstration it ran locally under Ollama, through the same OpenAI-style interface the code uses for Hugging Face. Python handles everything with one correct answer: deduplication by DOI and then by title and first author, ranking, rate limiting, and retries. Every LLM output crosses a Pydantic schema before anything else uses it. The Critic sends all new papers to the model in one batched call, and only new papers, which keeps token cost in line with new evidence.</a:t>
+              <a:t>The guiding principle, taken from the proposal, is that the LLM only does work that needs language understanding. Qwen2.5-7B-Instruct, running locally under Ollama for the live demonstration, proposes a plan, appraises abstracts and drafts the briefing. Python handles everything with one correct answer: deduplication, ranking, rate limiting and retries, and every LLM output crosses a Pydantic schema first. Four decisions along the bottom are where most of the critical thinking sits. Whether to search again is decided by thresholds, not by asking the model, because self-reflection reduces but does not remove hallucination (Ji et al., 2023). Retrieval-augmented generation helps (Lewis et al., 2020) but can still fail (Huang et al., 2025), so citations to papers that were never retrieved are stripped. Every LLM step has a deterministic fallback, so a rate limit lowers quality but never stops the run. And offline mode is explicit, never a silent fallback, because mixing demo data into a live briefing would misrepresent the evidence.</a:t>
             </a:r>
             <a:endParaRPr lang="en-US" dirty="0"/>
           </a:p>
@@ -1190,94 +1278,6 @@
             <a:fld id="{F7021451-1387-4CA6-816F-3879F97B5CBC}" type="slidenum">
               <a:rPr lang="en-US"/>
               <a:t>4</a:t>
-            </a:fld>
-            <a:endParaRPr lang="en-US"/>
-          </a:p>
-        </p:txBody>
-      </p:sp>
-    </p:spTree>
-    <p:extLst>
-      <p:ext uri="{BB962C8B-B14F-4D97-AF65-F5344CB8AC3E}">
-        <p14:creationId xmlns:p14="http://schemas.microsoft.com/office/powerpoint/2010/main" val="1024086991"/>
-      </p:ext>
-    </p:extLst>
-  </p:cSld>
-  <p:clrMapOvr>
-    <a:masterClrMapping/>
-  </p:clrMapOvr>
-</p:notes>
-</file>
-
-<file path=ppt/notesSlides/notesSlide5.xml><?xml version="1.0" encoding="utf-8"?>
-<p:notes xmlns:a="http://schemas.openxmlformats.org/drawingml/2006/main" xmlns:r="http://schemas.openxmlformats.org/officeDocument/2006/relationships" xmlns:p="http://schemas.openxmlformats.org/presentationml/2006/main">
-  <p:cSld>
-    <p:spTree>
-      <p:nvGrpSpPr>
-        <p:cNvPr id="1" name=""/>
-        <p:cNvGrpSpPr/>
-        <p:nvPr/>
-      </p:nvGrpSpPr>
-      <p:grpSpPr>
-        <a:xfrm>
-          <a:off x="0" y="0"/>
-          <a:ext cx="0" cy="0"/>
-          <a:chOff x="0" y="0"/>
-          <a:chExt cx="0" cy="0"/>
-        </a:xfrm>
-      </p:grpSpPr>
-      <p:sp>
-        <p:nvSpPr>
-          <p:cNvPr id="2" name="Slide Image Placeholder 1"/>
-          <p:cNvSpPr>
-            <a:spLocks noGrp="1" noRot="1" noChangeAspect="1"/>
-          </p:cNvSpPr>
-          <p:nvPr>
-            <p:ph type="sldImg"/>
-          </p:nvPr>
-        </p:nvSpPr>
-        <p:spPr/>
-      </p:sp>
-      <p:sp>
-        <p:nvSpPr>
-          <p:cNvPr id="3" name="Notes Placeholder 2"/>
-          <p:cNvSpPr>
-            <a:spLocks noGrp="1"/>
-          </p:cNvSpPr>
-          <p:nvPr>
-            <p:ph type="body" idx="1"/>
-          </p:nvPr>
-        </p:nvSpPr>
-        <p:spPr/>
-        <p:txBody>
-          <a:bodyPr/>
-          <a:lstStyle/>
-          <a:p>
-            <a:r>
-              <a:rPr lang="en-US" dirty="0"/>
-              <a:t>These four decisions are where most of the critical thinking in the code sits. First, the decision to stop or keep searching is made by explicit thresholds, not by asking the model whether it is satisfied. Self-reflection reduces hallucination but does not remove it (Ji et al., 2023), and a rule can be tested and explained. Second, reporting is grounded: retrieval-augmented generation helps (Lewis et al., 2020), but it can still fail (Huang et al., 2025), so any citation to a paper that was never retrieved is stripped. Third, every LLM step has a deterministic fallback, so a free-tier rate limit lowers quality but never stops the run, and the audit trail records which path was used. Fourth, offline mode is explicit and never a silent fallback, because mixing demo data into a live briefing would misrepresent the evidence.</a:t>
-            </a:r>
-            <a:endParaRPr lang="en-US" dirty="0"/>
-          </a:p>
-        </p:txBody>
-      </p:sp>
-      <p:sp>
-        <p:nvSpPr>
-          <p:cNvPr id="4" name="Slide Number Placeholder 3"/>
-          <p:cNvSpPr>
-            <a:spLocks noGrp="1"/>
-          </p:cNvSpPr>
-          <p:nvPr>
-            <p:ph type="sldNum" sz="quarter" idx="10"/>
-          </p:nvPr>
-        </p:nvSpPr>
-        <p:spPr/>
-        <p:txBody>
-          <a:bodyPr/>
-          <a:lstStyle/>
-          <a:p>
-            <a:fld id="{F7021451-1387-4CA6-816F-3879F97B5CBC}" type="slidenum">
-              <a:rPr lang="en-US"/>
-              <a:t>5</a:t>
             </a:fld>
             <a:endParaRPr lang="en-US"/>
           </a:p>
@@ -1606,7 +1606,7 @@
           <a:p>
             <a:r>
               <a:rPr lang="en-US" dirty="0"/>
-              <a:t>Testing changed the code. Offline, the first smoke run showed that "LLM-based" never matched abstracts that say "large language models", so the agent wasted all three cycles; synonym folding and light stemming took it from two papers in three cycles to ten in one. Other tests caught all-neutral evidence being called biased, leaked database connections, a 404 being retried like a rate limit, and references in the wrong order. Running live on Windows found four more problems. The hosted Qwen model was no longer served and the free credit ran out, so I made the endpoint configurable and ran Qwen locally. Semantic Scholar throttled requests, so retries now back off longer. One malformed appraisal discarded all twelve, so each is now validated separately, and eleven of twelve were then kept. And the model once wrote invalid JSON, so an optional JSON mode now constrains its output. In every case the fallbacks kept the run going and the audit trail showed what happened. Each fix has a regression test, and the full log is in docs/TESTING.md.</a:t>
+              <a:t>This slide shows how the system developed over the module. It started from our Unit 6 group design. I then built it offline-first in incremental commits: the schemas and shared state, the sources and LLM client, the agents in a LangGraph graph, the Flask interface, and the tests. Testing drove five refinements. For example, "LLM-based" never matched "large language models", and synonym folding took the same question from two relevant papers to ten. Running live on Windows found four more. The hosted Qwen model was withdrawn, so I made the endpoint configurable and ran Qwen locally. Semantic Scholar throttled requests, so retries back off longer. One bad appraisal discarded all twelve, so each is now validated on its own. And the model once wrote invalid JSON, so JSON mode now constrains its output. The suite grew from 76 to 83 tests, and every step is a commit or pull request on GitHub.</a:t>
             </a:r>
             <a:endParaRPr lang="en-US" dirty="0"/>
           </a:p>
@@ -2996,6 +2996,846 @@
 </p:sld>
 </file>
 
+<file path=ppt/slides/slide11.xml><?xml version="1.0" encoding="utf-8"?>
+<p:sld xmlns:a="http://schemas.openxmlformats.org/drawingml/2006/main" xmlns:r="http://schemas.openxmlformats.org/officeDocument/2006/relationships" xmlns:p="http://schemas.openxmlformats.org/presentationml/2006/main">
+  <p:cSld name="Slide 9">
+    <p:spTree>
+      <p:nvGrpSpPr>
+        <p:cNvPr id="1" name=""/>
+        <p:cNvGrpSpPr/>
+        <p:nvPr/>
+      </p:nvGrpSpPr>
+      <p:grpSpPr>
+        <a:xfrm>
+          <a:off x="0" y="0"/>
+          <a:ext cx="0" cy="0"/>
+          <a:chOff x="0" y="0"/>
+          <a:chExt cx="0" cy="0"/>
+        </a:xfrm>
+      </p:grpSpPr>
+      <p:sp>
+        <p:nvSpPr>
+          <p:cNvPr id="2" name="Text 0"/>
+          <p:cNvSpPr/>
+          <p:nvPr>
+            <p:ph idx="100" type="title" hasCustomPrompt="1"/>
+          </p:nvPr>
+        </p:nvSpPr>
+        <p:spPr>
+          <a:xfrm>
+            <a:off x="457200" y="274320"/>
+            <a:ext cx="8229600" cy="685800"/>
+          </a:xfrm>
+          <a:prstGeom prst="rect">
+            <a:avLst/>
+          </a:prstGeom>
+          <a:noFill/>
+          <a:ln/>
+        </p:spPr>
+        <p:txBody>
+          <a:bodyPr wrap="square" rtlCol="0" anchor="ctr"/>
+          <a:lstStyle/>
+          <a:p>
+            <a:pPr indent="0" marL="0">
+              <a:buNone/>
+            </a:pPr>
+            <a:r>
+              <a:rPr lang="en-US" sz="3000" b="1" dirty="0">
+                <a:solidFill>
+                  <a:schemeClr val="tx2"/>
+                </a:solidFill>
+                <a:latin typeface="Cambria" pitchFamily="34" charset="0"/>
+                <a:ea typeface="Cambria" pitchFamily="34" charset="-122"/>
+                <a:cs typeface="Cambria" pitchFamily="34" charset="-120"/>
+              </a:rPr>
+              <a:t>Code and executables</a:t>
+            </a:r>
+            <a:endParaRPr lang="en-US" sz="3000" dirty="0"/>
+          </a:p>
+        </p:txBody>
+      </p:sp>
+      <p:sp>
+        <p:nvSpPr>
+          <p:cNvPr id="4" name="Code tree panel"/>
+          <p:cNvSpPr/>
+          <p:nvPr/>
+        </p:nvSpPr>
+        <p:spPr>
+          <a:xfrm>
+            <a:off x="457200" y="960120"/>
+            <a:ext cx="3794760" cy="3063240"/>
+          </a:xfrm>
+          <a:prstGeom prst="roundRect">
+            <a:avLst>
+              <a:gd name="adj" fmla="val 3000"/>
+            </a:avLst>
+          </a:prstGeom>
+          <a:solidFill>
+            <a:schemeClr val="tx2"/>
+          </a:solidFill>
+          <a:ln w="12700">
+            <a:solidFill>
+              <a:schemeClr val="tx2"/>
+            </a:solidFill>
+          </a:ln>
+        </p:spPr>
+      </p:sp>
+      <p:sp>
+        <p:nvSpPr>
+          <p:cNvPr id="5" name="Code tree"/>
+          <p:cNvSpPr txBox="1"/>
+          <p:nvPr/>
+        </p:nvSpPr>
+        <p:spPr>
+          <a:xfrm>
+            <a:off x="521208" y="1005840"/>
+            <a:ext cx="3666744" cy="2971800"/>
+          </a:xfrm>
+          <a:prstGeom prst="rect">
+            <a:avLst/>
+          </a:prstGeom>
+          <a:noFill/>
+        </p:spPr>
+        <p:txBody>
+          <a:bodyPr wrap="square" lIns="45720" tIns="45720" rIns="45720" bIns="45720" rtlCol="0" anchor="ctr"/>
+          <a:lstStyle/>
+          <a:p>
+            <a:pPr indent="0" marL="0">
+              <a:spcAft>
+                <a:spcPts val="250"/>
+              </a:spcAft>
+              <a:buNone/>
+            </a:pPr>
+            <a:r>
+              <a:rPr lang="en-GB" sz="950" b="1" dirty="0">
+                <a:solidFill>
+                  <a:schemeClr val="bg1"/>
+                </a:solidFill>
+                <a:latin typeface="Courier New" pitchFamily="34" charset="0"/>
+                <a:ea typeface="Courier New" pitchFamily="34" charset="-122"/>
+                <a:cs typeface="Courier New" pitchFamily="34" charset="-120"/>
+              </a:rPr>
+              <a:t xml:space="preserve">evidence_investigator/</a:t>
+            </a:r>
+            <a:r>
+              <a:rPr lang="en-GB" sz="950" dirty="0">
+                <a:solidFill>
+                  <a:schemeClr val="accent6"/>
+                </a:solidFill>
+                <a:latin typeface="Courier New" pitchFamily="34" charset="0"/>
+                <a:ea typeface="Courier New" pitchFamily="34" charset="-122"/>
+                <a:cs typeface="Courier New" pitchFamily="34" charset="-120"/>
+              </a:rPr>
+              <a:t xml:space="preserve"/>
+            </a:r>
+            <a:endParaRPr lang="en-GB" sz="950" dirty="0"/>
+          </a:p>
+          <a:p>
+            <a:pPr indent="0" marL="0">
+              <a:spcAft>
+                <a:spcPts val="250"/>
+              </a:spcAft>
+              <a:buNone/>
+            </a:pPr>
+            <a:r>
+              <a:rPr lang="en-GB" sz="950" dirty="0">
+                <a:solidFill>
+                  <a:schemeClr val="accent2"/>
+                </a:solidFill>
+                <a:latin typeface="Courier New" pitchFamily="34" charset="0"/>
+                <a:ea typeface="Courier New" pitchFamily="34" charset="-122"/>
+                <a:cs typeface="Courier New" pitchFamily="34" charset="-120"/>
+              </a:rPr>
+              <a:t xml:space="preserve">  graph.py      </a:t>
+            </a:r>
+            <a:r>
+              <a:rPr lang="en-GB" sz="950" dirty="0">
+                <a:solidFill>
+                  <a:schemeClr val="accent6"/>
+                </a:solidFill>
+                <a:latin typeface="Courier New" pitchFamily="34" charset="0"/>
+                <a:ea typeface="Courier New" pitchFamily="34" charset="-122"/>
+                <a:cs typeface="Courier New" pitchFamily="34" charset="-120"/>
+              </a:rPr>
+              <a:t xml:space="preserve">LangGraph wiring, re-plan loop</a:t>
+            </a:r>
+            <a:endParaRPr lang="en-GB" sz="950" dirty="0"/>
+          </a:p>
+          <a:p>
+            <a:pPr indent="0" marL="0">
+              <a:spcAft>
+                <a:spcPts val="250"/>
+              </a:spcAft>
+              <a:buNone/>
+            </a:pPr>
+            <a:r>
+              <a:rPr lang="en-GB" sz="950" dirty="0">
+                <a:solidFill>
+                  <a:schemeClr val="accent2"/>
+                </a:solidFill>
+                <a:latin typeface="Courier New" pitchFamily="34" charset="0"/>
+                <a:ea typeface="Courier New" pitchFamily="34" charset="-122"/>
+                <a:cs typeface="Courier New" pitchFamily="34" charset="-120"/>
+              </a:rPr>
+              <a:t xml:space="preserve">  state.py      </a:t>
+            </a:r>
+            <a:r>
+              <a:rPr lang="en-GB" sz="950" dirty="0">
+                <a:solidFill>
+                  <a:schemeClr val="accent6"/>
+                </a:solidFill>
+                <a:latin typeface="Courier New" pitchFamily="34" charset="0"/>
+                <a:ea typeface="Courier New" pitchFamily="34" charset="-122"/>
+                <a:cs typeface="Courier New" pitchFamily="34" charset="-120"/>
+              </a:rPr>
+              <a:t xml:space="preserve">shared ResearchState</a:t>
+            </a:r>
+            <a:endParaRPr lang="en-GB" sz="950" dirty="0"/>
+          </a:p>
+          <a:p>
+            <a:pPr indent="0" marL="0">
+              <a:spcAft>
+                <a:spcPts val="250"/>
+              </a:spcAft>
+              <a:buNone/>
+            </a:pPr>
+            <a:r>
+              <a:rPr lang="en-GB" sz="950" dirty="0">
+                <a:solidFill>
+                  <a:schemeClr val="accent2"/>
+                </a:solidFill>
+                <a:latin typeface="Courier New" pitchFamily="34" charset="0"/>
+                <a:ea typeface="Courier New" pitchFamily="34" charset="-122"/>
+                <a:cs typeface="Courier New" pitchFamily="34" charset="-120"/>
+              </a:rPr>
+              <a:t xml:space="preserve">  agents/       </a:t>
+            </a:r>
+            <a:r>
+              <a:rPr lang="en-GB" sz="950" dirty="0">
+                <a:solidFill>
+                  <a:schemeClr val="accent6"/>
+                </a:solidFill>
+                <a:latin typeface="Courier New" pitchFamily="34" charset="0"/>
+                <a:ea typeface="Courier New" pitchFamily="34" charset="-122"/>
+                <a:cs typeface="Courier New" pitchFamily="34" charset="-120"/>
+              </a:rPr>
+              <a:t xml:space="preserve">the four agents</a:t>
+            </a:r>
+            <a:endParaRPr lang="en-GB" sz="950" dirty="0"/>
+          </a:p>
+          <a:p>
+            <a:pPr indent="0" marL="0">
+              <a:spcAft>
+                <a:spcPts val="250"/>
+              </a:spcAft>
+              <a:buNone/>
+            </a:pPr>
+            <a:r>
+              <a:rPr lang="en-GB" sz="950" dirty="0">
+                <a:solidFill>
+                  <a:schemeClr val="accent2"/>
+                </a:solidFill>
+                <a:latin typeface="Courier New" pitchFamily="34" charset="0"/>
+                <a:ea typeface="Courier New" pitchFamily="34" charset="-122"/>
+                <a:cs typeface="Courier New" pitchFamily="34" charset="-120"/>
+              </a:rPr>
+              <a:t xml:space="preserve">  sources/      </a:t>
+            </a:r>
+            <a:r>
+              <a:rPr lang="en-GB" sz="950" dirty="0">
+                <a:solidFill>
+                  <a:schemeClr val="accent6"/>
+                </a:solidFill>
+                <a:latin typeface="Courier New" pitchFamily="34" charset="0"/>
+                <a:ea typeface="Courier New" pitchFamily="34" charset="-122"/>
+                <a:cs typeface="Courier New" pitchFamily="34" charset="-120"/>
+              </a:rPr>
+              <a:t xml:space="preserve">Semantic Scholar, Crossref</a:t>
+            </a:r>
+            <a:endParaRPr lang="en-GB" sz="950" dirty="0"/>
+          </a:p>
+          <a:p>
+            <a:pPr indent="0" marL="0">
+              <a:spcAft>
+                <a:spcPts val="250"/>
+              </a:spcAft>
+              <a:buNone/>
+            </a:pPr>
+            <a:r>
+              <a:rPr lang="en-GB" sz="950" dirty="0">
+                <a:solidFill>
+                  <a:schemeClr val="accent2"/>
+                </a:solidFill>
+                <a:latin typeface="Courier New" pitchFamily="34" charset="0"/>
+                <a:ea typeface="Courier New" pitchFamily="34" charset="-122"/>
+                <a:cs typeface="Courier New" pitchFamily="34" charset="-120"/>
+              </a:rPr>
+              <a:t xml:space="preserve">  llm.py        </a:t>
+            </a:r>
+            <a:r>
+              <a:rPr lang="en-GB" sz="950" dirty="0">
+                <a:solidFill>
+                  <a:schemeClr val="accent6"/>
+                </a:solidFill>
+                <a:latin typeface="Courier New" pitchFamily="34" charset="0"/>
+                <a:ea typeface="Courier New" pitchFamily="34" charset="-122"/>
+                <a:cs typeface="Courier New" pitchFamily="34" charset="-120"/>
+              </a:rPr>
+              <a:t xml:space="preserve">Qwen client, JSON validation</a:t>
+            </a:r>
+            <a:endParaRPr lang="en-GB" sz="950" dirty="0"/>
+          </a:p>
+          <a:p>
+            <a:pPr indent="0" marL="0">
+              <a:spcAft>
+                <a:spcPts val="250"/>
+              </a:spcAft>
+              <a:buNone/>
+            </a:pPr>
+            <a:r>
+              <a:rPr lang="en-GB" sz="950" dirty="0">
+                <a:solidFill>
+                  <a:schemeClr val="accent2"/>
+                </a:solidFill>
+                <a:latin typeface="Courier New" pitchFamily="34" charset="0"/>
+                <a:ea typeface="Courier New" pitchFamily="34" charset="-122"/>
+                <a:cs typeface="Courier New" pitchFamily="34" charset="-120"/>
+              </a:rPr>
+              <a:t xml:space="preserve">  processing.py </a:t>
+            </a:r>
+            <a:r>
+              <a:rPr lang="en-GB" sz="950" dirty="0">
+                <a:solidFill>
+                  <a:schemeClr val="accent6"/>
+                </a:solidFill>
+                <a:latin typeface="Courier New" pitchFamily="34" charset="0"/>
+                <a:ea typeface="Courier New" pitchFamily="34" charset="-122"/>
+                <a:cs typeface="Courier New" pitchFamily="34" charset="-120"/>
+              </a:rPr>
+              <a:t xml:space="preserve">dedupe, filter, rank</a:t>
+            </a:r>
+            <a:endParaRPr lang="en-GB" sz="950" dirty="0"/>
+          </a:p>
+          <a:p>
+            <a:pPr indent="0" marL="0">
+              <a:spcAft>
+                <a:spcPts val="250"/>
+              </a:spcAft>
+              <a:buNone/>
+            </a:pPr>
+            <a:r>
+              <a:rPr lang="en-GB" sz="950" dirty="0">
+                <a:solidFill>
+                  <a:schemeClr val="accent2"/>
+                </a:solidFill>
+                <a:latin typeface="Courier New" pitchFamily="34" charset="0"/>
+                <a:ea typeface="Courier New" pitchFamily="34" charset="-122"/>
+                <a:cs typeface="Courier New" pitchFamily="34" charset="-120"/>
+              </a:rPr>
+              <a:t xml:space="preserve">  storage.py    </a:t>
+            </a:r>
+            <a:r>
+              <a:rPr lang="en-GB" sz="950" dirty="0">
+                <a:solidFill>
+                  <a:schemeClr val="accent6"/>
+                </a:solidFill>
+                <a:latin typeface="Courier New" pitchFamily="34" charset="0"/>
+                <a:ea typeface="Courier New" pitchFamily="34" charset="-122"/>
+                <a:cs typeface="Courier New" pitchFamily="34" charset="-120"/>
+              </a:rPr>
+              <a:t xml:space="preserve">SQLite run history</a:t>
+            </a:r>
+            <a:endParaRPr lang="en-GB" sz="950" dirty="0"/>
+          </a:p>
+          <a:p>
+            <a:pPr indent="0" marL="0">
+              <a:spcAft>
+                <a:spcPts val="250"/>
+              </a:spcAft>
+              <a:buNone/>
+            </a:pPr>
+            <a:r>
+              <a:rPr lang="en-GB" sz="950" dirty="0">
+                <a:solidFill>
+                  <a:schemeClr val="accent2"/>
+                </a:solidFill>
+                <a:latin typeface="Courier New" pitchFamily="34" charset="0"/>
+                <a:ea typeface="Courier New" pitchFamily="34" charset="-122"/>
+                <a:cs typeface="Courier New" pitchFamily="34" charset="-120"/>
+              </a:rPr>
+              <a:t xml:space="preserve">  web/          </a:t>
+            </a:r>
+            <a:r>
+              <a:rPr lang="en-GB" sz="950" dirty="0">
+                <a:solidFill>
+                  <a:schemeClr val="accent6"/>
+                </a:solidFill>
+                <a:latin typeface="Courier New" pitchFamily="34" charset="0"/>
+                <a:ea typeface="Courier New" pitchFamily="34" charset="-122"/>
+                <a:cs typeface="Courier New" pitchFamily="34" charset="-120"/>
+              </a:rPr>
+              <a:t xml:space="preserve">Flask interface</a:t>
+            </a:r>
+            <a:endParaRPr lang="en-GB" sz="950" dirty="0"/>
+          </a:p>
+          <a:p>
+            <a:pPr indent="0" marL="0">
+              <a:spcAft>
+                <a:spcPts val="250"/>
+              </a:spcAft>
+              <a:buNone/>
+            </a:pPr>
+            <a:r>
+              <a:rPr lang="en-GB" sz="950" b="1" dirty="0">
+                <a:solidFill>
+                  <a:schemeClr val="bg1"/>
+                </a:solidFill>
+                <a:latin typeface="Courier New" pitchFamily="34" charset="0"/>
+                <a:ea typeface="Courier New" pitchFamily="34" charset="-122"/>
+                <a:cs typeface="Courier New" pitchFamily="34" charset="-120"/>
+              </a:rPr>
+              <a:t xml:space="preserve">tests/          </a:t>
+            </a:r>
+            <a:r>
+              <a:rPr lang="en-GB" sz="950" dirty="0">
+                <a:solidFill>
+                  <a:schemeClr val="accent6"/>
+                </a:solidFill>
+                <a:latin typeface="Courier New" pitchFamily="34" charset="0"/>
+                <a:ea typeface="Courier New" pitchFamily="34" charset="-122"/>
+                <a:cs typeface="Courier New" pitchFamily="34" charset="-120"/>
+              </a:rPr>
+              <a:t xml:space="preserve">83 tests at four levels</a:t>
+            </a:r>
+            <a:endParaRPr lang="en-GB" sz="950" dirty="0"/>
+          </a:p>
+          <a:p>
+            <a:pPr indent="0" marL="0">
+              <a:spcAft>
+                <a:spcPts val="250"/>
+              </a:spcAft>
+              <a:buNone/>
+            </a:pPr>
+            <a:r>
+              <a:rPr lang="en-GB" sz="950" b="1" dirty="0">
+                <a:solidFill>
+                  <a:schemeClr val="bg1"/>
+                </a:solidFill>
+                <a:latin typeface="Courier New" pitchFamily="34" charset="0"/>
+                <a:ea typeface="Courier New" pitchFamily="34" charset="-122"/>
+                <a:cs typeface="Courier New" pitchFamily="34" charset="-120"/>
+              </a:rPr>
+              <a:t xml:space="preserve">evidence/       </a:t>
+            </a:r>
+            <a:r>
+              <a:rPr lang="en-GB" sz="950" dirty="0">
+                <a:solidFill>
+                  <a:schemeClr val="accent6"/>
+                </a:solidFill>
+                <a:latin typeface="Courier New" pitchFamily="34" charset="0"/>
+                <a:ea typeface="Courier New" pitchFamily="34" charset="-122"/>
+                <a:cs typeface="Courier New" pitchFamily="34" charset="-120"/>
+              </a:rPr>
+              <a:t xml:space="preserve">logs, screenshots, briefings</a:t>
+            </a:r>
+            <a:endParaRPr lang="en-GB" sz="950" dirty="0"/>
+          </a:p>
+        </p:txBody>
+      </p:sp>
+      <p:sp>
+        <p:nvSpPr>
+          <p:cNvPr id="6" name="Run card 1"/>
+          <p:cNvSpPr/>
+          <p:nvPr/>
+        </p:nvSpPr>
+        <p:spPr>
+          <a:xfrm>
+            <a:off x="4416552" y="960120"/>
+            <a:ext cx="4270248" cy="941832"/>
+          </a:xfrm>
+          <a:prstGeom prst="roundRect">
+            <a:avLst>
+              <a:gd name="adj" fmla="val 3000"/>
+            </a:avLst>
+          </a:prstGeom>
+          <a:solidFill>
+            <a:schemeClr val="bg2"/>
+          </a:solidFill>
+          <a:ln w="12700">
+            <a:solidFill>
+              <a:schemeClr val="bg2"/>
+            </a:solidFill>
+          </a:ln>
+        </p:spPr>
+      </p:sp>
+      <p:sp>
+        <p:nvSpPr>
+          <p:cNvPr id="7" name="Run card 1 text"/>
+          <p:cNvSpPr txBox="1"/>
+          <p:nvPr/>
+        </p:nvSpPr>
+        <p:spPr>
+          <a:xfrm>
+            <a:off x="4462272" y="978408"/>
+            <a:ext cx="4178808" cy="905256"/>
+          </a:xfrm>
+          <a:prstGeom prst="rect">
+            <a:avLst/>
+          </a:prstGeom>
+          <a:noFill/>
+        </p:spPr>
+        <p:txBody>
+          <a:bodyPr wrap="square" lIns="45720" tIns="45720" rIns="45720" bIns="45720" rtlCol="0" anchor="ctr"/>
+          <a:lstStyle/>
+          <a:p>
+            <a:pPr indent="0" marL="0">
+              <a:spcAft>
+                <a:spcPts val="300"/>
+              </a:spcAft>
+              <a:buNone/>
+            </a:pPr>
+            <a:r>
+              <a:rPr lang="en-GB" sz="1150" b="1" dirty="0">
+                <a:solidFill>
+                  <a:schemeClr val="accent1"/>
+                </a:solidFill>
+              </a:rPr>
+              <a:t xml:space="preserve">Command line</a:t>
+            </a:r>
+            <a:endParaRPr lang="en-GB" sz="1150" dirty="0"/>
+          </a:p>
+          <a:p>
+            <a:pPr indent="0" marL="0">
+              <a:spcAft>
+                <a:spcPts val="300"/>
+              </a:spcAft>
+              <a:buNone/>
+            </a:pPr>
+            <a:r>
+              <a:rPr lang="en-GB" sz="950" dirty="0">
+                <a:solidFill>
+                  <a:schemeClr val="tx2"/>
+                </a:solidFill>
+                <a:latin typeface="Courier New" pitchFamily="34" charset="0"/>
+                <a:ea typeface="Courier New" pitchFamily="34" charset="-122"/>
+                <a:cs typeface="Courier New" pitchFamily="34" charset="-120"/>
+              </a:rPr>
+              <a:t xml:space="preserve">python -m evidence_investigator "&lt;question&gt;" -v</a:t>
+            </a:r>
+            <a:endParaRPr lang="en-GB" sz="950" dirty="0"/>
+          </a:p>
+          <a:p>
+            <a:pPr indent="0" marL="0">
+              <a:spcAft>
+                <a:spcPts val="0"/>
+              </a:spcAft>
+              <a:buNone/>
+            </a:pPr>
+            <a:r>
+              <a:rPr lang="en-GB" sz="1050" dirty="0">
+                <a:solidFill>
+                  <a:schemeClr val="tx1"/>
+                </a:solidFill>
+              </a:rPr>
+              <a:t xml:space="preserve">Briefing plus the audit trail of every agent step</a:t>
+            </a:r>
+            <a:endParaRPr lang="en-GB" sz="1050" dirty="0"/>
+          </a:p>
+        </p:txBody>
+      </p:sp>
+      <p:sp>
+        <p:nvSpPr>
+          <p:cNvPr id="8" name="Run card 2"/>
+          <p:cNvSpPr/>
+          <p:nvPr/>
+        </p:nvSpPr>
+        <p:spPr>
+          <a:xfrm>
+            <a:off x="4416552" y="2020824"/>
+            <a:ext cx="4270248" cy="941832"/>
+          </a:xfrm>
+          <a:prstGeom prst="roundRect">
+            <a:avLst>
+              <a:gd name="adj" fmla="val 3000"/>
+            </a:avLst>
+          </a:prstGeom>
+          <a:solidFill>
+            <a:schemeClr val="bg2"/>
+          </a:solidFill>
+          <a:ln w="12700">
+            <a:solidFill>
+              <a:schemeClr val="bg2"/>
+            </a:solidFill>
+          </a:ln>
+        </p:spPr>
+      </p:sp>
+      <p:sp>
+        <p:nvSpPr>
+          <p:cNvPr id="9" name="Run card 2 text"/>
+          <p:cNvSpPr txBox="1"/>
+          <p:nvPr/>
+        </p:nvSpPr>
+        <p:spPr>
+          <a:xfrm>
+            <a:off x="4462272" y="2039112"/>
+            <a:ext cx="4178808" cy="905256"/>
+          </a:xfrm>
+          <a:prstGeom prst="rect">
+            <a:avLst/>
+          </a:prstGeom>
+          <a:noFill/>
+        </p:spPr>
+        <p:txBody>
+          <a:bodyPr wrap="square" lIns="45720" tIns="45720" rIns="45720" bIns="45720" rtlCol="0" anchor="ctr"/>
+          <a:lstStyle/>
+          <a:p>
+            <a:pPr indent="0" marL="0">
+              <a:spcAft>
+                <a:spcPts val="300"/>
+              </a:spcAft>
+              <a:buNone/>
+            </a:pPr>
+            <a:r>
+              <a:rPr lang="en-GB" sz="1150" b="1" dirty="0">
+                <a:solidFill>
+                  <a:schemeClr val="accent1"/>
+                </a:solidFill>
+              </a:rPr>
+              <a:t xml:space="preserve">Web interface</a:t>
+            </a:r>
+            <a:endParaRPr lang="en-GB" sz="1150" dirty="0"/>
+          </a:p>
+          <a:p>
+            <a:pPr indent="0" marL="0">
+              <a:spcAft>
+                <a:spcPts val="300"/>
+              </a:spcAft>
+              <a:buNone/>
+            </a:pPr>
+            <a:r>
+              <a:rPr lang="en-GB" sz="950" dirty="0">
+                <a:solidFill>
+                  <a:schemeClr val="tx2"/>
+                </a:solidFill>
+                <a:latin typeface="Courier New" pitchFamily="34" charset="0"/>
+                <a:ea typeface="Courier New" pitchFamily="34" charset="-122"/>
+                <a:cs typeface="Courier New" pitchFamily="34" charset="-120"/>
+              </a:rPr>
+              <a:t xml:space="preserve">python -m evidence_investigator.web.app</a:t>
+            </a:r>
+            <a:endParaRPr lang="en-GB" sz="950" dirty="0"/>
+          </a:p>
+          <a:p>
+            <a:pPr indent="0" marL="0">
+              <a:spcAft>
+                <a:spcPts val="0"/>
+              </a:spcAft>
+              <a:buNone/>
+            </a:pPr>
+            <a:r>
+              <a:rPr lang="en-GB" sz="1050" dirty="0">
+                <a:solidFill>
+                  <a:schemeClr val="tx1"/>
+                </a:solidFill>
+              </a:rPr>
+              <a:t xml:space="preserve">Form, briefing, evidence table and run history</a:t>
+            </a:r>
+            <a:endParaRPr lang="en-GB" sz="1050" dirty="0"/>
+          </a:p>
+        </p:txBody>
+      </p:sp>
+      <p:sp>
+        <p:nvSpPr>
+          <p:cNvPr id="10" name="Run card 3"/>
+          <p:cNvSpPr/>
+          <p:nvPr/>
+        </p:nvSpPr>
+        <p:spPr>
+          <a:xfrm>
+            <a:off x="4416552" y="3081528"/>
+            <a:ext cx="4270248" cy="941832"/>
+          </a:xfrm>
+          <a:prstGeom prst="roundRect">
+            <a:avLst>
+              <a:gd name="adj" fmla="val 3000"/>
+            </a:avLst>
+          </a:prstGeom>
+          <a:solidFill>
+            <a:schemeClr val="bg2"/>
+          </a:solidFill>
+          <a:ln w="12700">
+            <a:solidFill>
+              <a:schemeClr val="bg2"/>
+            </a:solidFill>
+          </a:ln>
+        </p:spPr>
+      </p:sp>
+      <p:sp>
+        <p:nvSpPr>
+          <p:cNvPr id="11" name="Run card 3 text"/>
+          <p:cNvSpPr txBox="1"/>
+          <p:nvPr/>
+        </p:nvSpPr>
+        <p:spPr>
+          <a:xfrm>
+            <a:off x="4462272" y="3099816"/>
+            <a:ext cx="4178808" cy="905256"/>
+          </a:xfrm>
+          <a:prstGeom prst="rect">
+            <a:avLst/>
+          </a:prstGeom>
+          <a:noFill/>
+        </p:spPr>
+        <p:txBody>
+          <a:bodyPr wrap="square" lIns="45720" tIns="45720" rIns="45720" bIns="45720" rtlCol="0" anchor="ctr"/>
+          <a:lstStyle/>
+          <a:p>
+            <a:pPr indent="0" marL="0">
+              <a:spcAft>
+                <a:spcPts val="300"/>
+              </a:spcAft>
+              <a:buNone/>
+            </a:pPr>
+            <a:r>
+              <a:rPr lang="en-GB" sz="1150" b="1" dirty="0">
+                <a:solidFill>
+                  <a:schemeClr val="accent1"/>
+                </a:solidFill>
+              </a:rPr>
+              <a:t xml:space="preserve">Tests</a:t>
+            </a:r>
+            <a:endParaRPr lang="en-GB" sz="1150" dirty="0"/>
+          </a:p>
+          <a:p>
+            <a:pPr indent="0" marL="0">
+              <a:spcAft>
+                <a:spcPts val="300"/>
+              </a:spcAft>
+              <a:buNone/>
+            </a:pPr>
+            <a:r>
+              <a:rPr lang="en-GB" sz="950" dirty="0">
+                <a:solidFill>
+                  <a:schemeClr val="tx2"/>
+                </a:solidFill>
+                <a:latin typeface="Courier New" pitchFamily="34" charset="0"/>
+                <a:ea typeface="Courier New" pitchFamily="34" charset="-122"/>
+                <a:cs typeface="Courier New" pitchFamily="34" charset="-120"/>
+              </a:rPr>
+              <a:t xml:space="preserve">python -m pytest --cov=evidence_investigator</a:t>
+            </a:r>
+            <a:endParaRPr lang="en-GB" sz="950" dirty="0"/>
+          </a:p>
+          <a:p>
+            <a:pPr indent="0" marL="0">
+              <a:spcAft>
+                <a:spcPts val="0"/>
+              </a:spcAft>
+              <a:buNone/>
+            </a:pPr>
+            <a:r>
+              <a:rPr lang="en-GB" sz="1050" dirty="0">
+                <a:solidFill>
+                  <a:schemeClr val="tx1"/>
+                </a:solidFill>
+              </a:rPr>
+              <a:t xml:space="preserve">83 passed, 0 failed, 96% coverage</a:t>
+            </a:r>
+            <a:endParaRPr lang="en-GB" sz="1050" dirty="0"/>
+          </a:p>
+        </p:txBody>
+      </p:sp>
+      <p:sp>
+        <p:nvSpPr>
+          <p:cNvPr id="12" name="Footnote"/>
+          <p:cNvSpPr txBox="1"/>
+          <p:nvPr/>
+        </p:nvSpPr>
+        <p:spPr>
+          <a:xfrm>
+            <a:off x="457200" y="4050792"/>
+            <a:ext cx="8229600" cy="274320"/>
+          </a:xfrm>
+          <a:prstGeom prst="rect">
+            <a:avLst/>
+          </a:prstGeom>
+          <a:noFill/>
+        </p:spPr>
+        <p:txBody>
+          <a:bodyPr wrap="square" lIns="45720" tIns="45720" rIns="45720" bIns="45720" rtlCol="0" anchor="ctr"/>
+          <a:lstStyle/>
+          <a:p>
+            <a:pPr indent="0" marL="0">
+              <a:spcAft>
+                <a:spcPts val="0"/>
+              </a:spcAft>
+              <a:buNone/>
+            </a:pPr>
+            <a:r>
+              <a:rPr lang="en-GB" sz="1050" i="1" dirty="0">
+                <a:solidFill>
+                  <a:schemeClr val="accent5"/>
+                </a:solidFill>
+              </a:rPr>
+              <a:t xml:space="preserve">Live mode uses Qwen2.5-7B under Ollama (LLM_BASE_URL); --offline runs the same code on a bundled corpus. Setup in README.md, sections 3 and 4.</a:t>
+            </a:r>
+            <a:endParaRPr lang="en-GB" sz="1050" dirty="0"/>
+          </a:p>
+        </p:txBody>
+      </p:sp>
+      <p:sp>
+        <p:nvSpPr>
+          <p:cNvPr id="99" name="Slide Number Placeholder 0"/>
+          <p:cNvSpPr>
+            <a:spLocks noGrp="1"/>
+          </p:cNvSpPr>
+          <p:nvPr>
+            <p:ph type="sldNum" sz="quarter" idx="4294967295"/>
+          </p:nvPr>
+        </p:nvSpPr>
+        <p:spPr>
+          <a:xfrm>
+            <a:off x="8229600" y="4754880"/>
+            <a:ext cx="457200" cy="274320"/>
+          </a:xfrm>
+          <a:prstGeom prst="rect">
+            <a:avLst/>
+          </a:prstGeom>
+          <a:extLst>
+            <a:ext uri="{C572A759-6A51-4108-AA02-DFA0A04FC94B}">
+              <ma14:wrappingTextBoxFlag xmlns:ma14="http://schemas.microsoft.com/office/mac/drawingml/2011/main" val="0"/>
+            </a:ext>
+          </a:extLst>
+        </p:spPr>
+        <p:txBody>
+          <a:bodyPr/>
+          <a:lstStyle>
+            <a:lvl1pPr>
+              <a:defRPr sz="1000">
+                <a:solidFill>
+                  <a:schemeClr val="accent5"/>
+                </a:solidFill>
+              </a:defRPr>
+            </a:lvl1pPr>
+          </a:lstStyle>
+          <a:p>
+            <a:pPr algn="r"/>
+            <a:fld id="{F7021451-1387-4CA6-816F-3879F97B5CBC}" type="slidenum">
+              <a:rPr b="0" lang="en-US"/>
+              <a:t>9</a:t>
+            </a:fld>
+            <a:endParaRPr lang="en-US"/>
+          </a:p>
+        </p:txBody>
+      </p:sp>
+    </p:spTree>
+  </p:cSld>
+  <p:clrMapOvr>
+    <a:masterClrMapping/>
+  </p:clrMapOvr>
+</p:sld>
+</file>
+
 <file path=ppt/slides/slide2.xml><?xml version="1.0" encoding="utf-8"?>
 <p:sld xmlns:a="http://schemas.openxmlformats.org/drawingml/2006/main" xmlns:r="http://schemas.openxmlformats.org/officeDocument/2006/relationships" xmlns:p="http://schemas.openxmlformats.org/presentationml/2006/main">
   <p:cSld name="Slide 2">
@@ -4901,7 +5741,7 @@
         </p:nvGraphicFramePr>
         <p:xfrm>
           <a:off x="457200" y="1143000"/>
-          <a:ext cx="8229600" cy="914400"/>
+          <a:ext cx="8229600" cy="2249424"/>
         </p:xfrm>
         <a:graphic>
           <a:graphicData uri="http://schemas.openxmlformats.org/drawingml/2006/table">
@@ -4912,7 +5752,7 @@
                 <a:gridCol w="3108960"/>
                 <a:gridCol w="3840480"/>
               </a:tblGrid>
-              <a:tr h="475488">
+              <a:tr h="374904">
                 <a:tc>
                   <a:txBody>
                     <a:bodyPr/>
@@ -4922,14 +5762,14 @@
                         <a:buNone/>
                       </a:pPr>
                       <a:r>
-                        <a:rPr lang="en-US" sz="1300" b="1" dirty="0">
+                        <a:rPr lang="en-US" sz="1150" b="1" dirty="0">
                           <a:solidFill>
                             <a:schemeClr val="bg1"/>
                           </a:solidFill>
                         </a:rPr>
                         <a:t>Agent</a:t>
                       </a:r>
-                      <a:endParaRPr lang="en-US" sz="1300" dirty="0"/>
+                      <a:endParaRPr lang="en-US" sz="1150" dirty="0"/>
                     </a:p>
                   </a:txBody>
                   <a:tcPr marL="91440" marR="91440" marT="45720" marB="45720" anchor="ctr">
@@ -4983,14 +5823,14 @@
                         <a:buNone/>
                       </a:pPr>
                       <a:r>
-                        <a:rPr lang="en-US" sz="1300" b="1" dirty="0">
+                        <a:rPr lang="en-US" sz="1150" b="1" dirty="0">
                           <a:solidFill>
                             <a:schemeClr val="bg1"/>
                           </a:solidFill>
                         </a:rPr>
                         <a:t>LLM does (Qwen2.5-7B-Instruct)</a:t>
                       </a:r>
-                      <a:endParaRPr lang="en-US" sz="1300" dirty="0"/>
+                      <a:endParaRPr lang="en-US" sz="1150" dirty="0"/>
                     </a:p>
                   </a:txBody>
                   <a:tcPr marL="91440" marR="91440" marT="45720" marB="45720" anchor="ctr">
@@ -5044,14 +5884,14 @@
                         <a:buNone/>
                       </a:pPr>
                       <a:r>
-                        <a:rPr lang="en-US" sz="1300" b="1" dirty="0">
+                        <a:rPr lang="en-US" sz="1150" b="1" dirty="0">
                           <a:solidFill>
                             <a:schemeClr val="bg1"/>
                           </a:solidFill>
                         </a:rPr>
                         <a:t>Python guarantees</a:t>
                       </a:r>
-                      <a:endParaRPr lang="en-US" sz="1300" dirty="0"/>
+                      <a:endParaRPr lang="en-US" sz="1150" dirty="0"/>
                     </a:p>
                   </a:txBody>
                   <a:tcPr marL="91440" marR="91440" marT="45720" marB="45720" anchor="ctr">
@@ -5097,7 +5937,7 @@
                   </a:tcPr>
                 </a:tc>
               </a:tr>
-              <a:tr h="475488">
+              <a:tr h="374904">
                 <a:tc>
                   <a:txBody>
                     <a:bodyPr/>
@@ -5107,14 +5947,14 @@
                         <a:buNone/>
                       </a:pPr>
                       <a:r>
-                        <a:rPr lang="en-US" sz="1300" dirty="0">
+                        <a:rPr lang="en-US" sz="1150" dirty="0">
                           <a:solidFill>
                             <a:schemeClr val="tx1"/>
                           </a:solidFill>
                         </a:rPr>
                         <a:t>Planner</a:t>
                       </a:r>
-                      <a:endParaRPr lang="en-US" sz="1300" dirty="0"/>
+                      <a:endParaRPr lang="en-US" sz="1150" dirty="0"/>
                     </a:p>
                   </a:txBody>
                   <a:tcPr marL="91440" marR="91440" marT="45720" marB="45720" anchor="ctr">
@@ -5168,14 +6008,14 @@
                         <a:buNone/>
                       </a:pPr>
                       <a:r>
-                        <a:rPr lang="en-US" sz="1300" dirty="0">
+                        <a:rPr lang="en-US" sz="1150" dirty="0">
                           <a:solidFill>
                             <a:schemeClr val="tx1"/>
                           </a:solidFill>
                         </a:rPr>
                         <a:t>Decomposes the question, writes queries</a:t>
                       </a:r>
-                      <a:endParaRPr lang="en-US" sz="1300" dirty="0"/>
+                      <a:endParaRPr lang="en-US" sz="1150" dirty="0"/>
                     </a:p>
                   </a:txBody>
                   <a:tcPr marL="91440" marR="91440" marT="45720" marB="45720" anchor="ctr">
@@ -5229,14 +6069,14 @@
                         <a:buNone/>
                       </a:pPr>
                       <a:r>
-                        <a:rPr lang="en-US" sz="1300" dirty="0">
+                        <a:rPr lang="en-US" sz="1150" dirty="0">
                           <a:solidFill>
                             <a:schemeClr val="tx1"/>
                           </a:solidFill>
                         </a:rPr>
                         <a:t>Schema check, no repeated queries, keyword fallback</a:t>
                       </a:r>
-                      <a:endParaRPr lang="en-US" sz="1300" dirty="0"/>
+                      <a:endParaRPr lang="en-US" sz="1150" dirty="0"/>
                     </a:p>
                   </a:txBody>
                   <a:tcPr marL="91440" marR="91440" marT="45720" marB="45720" anchor="ctr">
@@ -5282,7 +6122,7 @@
                   </a:tcPr>
                 </a:tc>
               </a:tr>
-              <a:tr h="475488">
+              <a:tr h="374904">
                 <a:tc>
                   <a:txBody>
                     <a:bodyPr/>
@@ -5292,14 +6132,14 @@
                         <a:buNone/>
                       </a:pPr>
                       <a:r>
-                        <a:rPr lang="en-US" sz="1300" dirty="0">
+                        <a:rPr lang="en-US" sz="1150" dirty="0">
                           <a:solidFill>
                             <a:schemeClr val="tx1"/>
                           </a:solidFill>
                         </a:rPr>
                         <a:t>Retrieval</a:t>
                       </a:r>
-                      <a:endParaRPr lang="en-US" sz="1300" dirty="0"/>
+                      <a:endParaRPr lang="en-US" sz="1150" dirty="0"/>
                     </a:p>
                   </a:txBody>
                   <a:tcPr marL="91440" marR="91440" marT="45720" marB="45720" anchor="ctr">
@@ -5353,14 +6193,14 @@
                         <a:buNone/>
                       </a:pPr>
                       <a:r>
-                        <a:rPr lang="en-US" sz="1300" dirty="0">
+                        <a:rPr lang="en-US" sz="1150" dirty="0">
                           <a:solidFill>
                             <a:schemeClr val="tx1"/>
                           </a:solidFill>
                         </a:rPr>
                         <a:t>Nothing</a:t>
                       </a:r>
-                      <a:endParaRPr lang="en-US" sz="1300" dirty="0"/>
+                      <a:endParaRPr lang="en-US" sz="1150" dirty="0"/>
                     </a:p>
                   </a:txBody>
                   <a:tcPr marL="91440" marR="91440" marT="45720" marB="45720" anchor="ctr">
@@ -5414,14 +6254,14 @@
                         <a:buNone/>
                       </a:pPr>
                       <a:r>
-                        <a:rPr lang="en-US" sz="1300" dirty="0">
+                        <a:rPr lang="en-US" sz="1150" dirty="0">
                           <a:solidFill>
                             <a:schemeClr val="tx1"/>
                           </a:solidFill>
                         </a:rPr>
                         <a:t>Rate limits, retries only transient errors, logs outages</a:t>
                       </a:r>
-                      <a:endParaRPr lang="en-US" sz="1300" dirty="0"/>
+                      <a:endParaRPr lang="en-US" sz="1150" dirty="0"/>
                     </a:p>
                   </a:txBody>
                   <a:tcPr marL="91440" marR="91440" marT="45720" marB="45720" anchor="ctr">
@@ -5467,7 +6307,7 @@
                   </a:tcPr>
                 </a:tc>
               </a:tr>
-              <a:tr h="475488">
+              <a:tr h="374904">
                 <a:tc>
                   <a:txBody>
                     <a:bodyPr/>
@@ -5477,14 +6317,14 @@
                         <a:buNone/>
                       </a:pPr>
                       <a:r>
-                        <a:rPr lang="en-US" sz="1300" dirty="0">
+                        <a:rPr lang="en-US" sz="1150" dirty="0">
                           <a:solidFill>
                             <a:schemeClr val="tx1"/>
                           </a:solidFill>
                         </a:rPr>
                         <a:t>Processing</a:t>
                       </a:r>
-                      <a:endParaRPr lang="en-US" sz="1300" dirty="0"/>
+                      <a:endParaRPr lang="en-US" sz="1150" dirty="0"/>
                     </a:p>
                   </a:txBody>
                   <a:tcPr marL="91440" marR="91440" marT="45720" marB="45720" anchor="ctr">
@@ -5538,14 +6378,14 @@
                         <a:buNone/>
                       </a:pPr>
                       <a:r>
-                        <a:rPr lang="en-US" sz="1300" dirty="0">
+                        <a:rPr lang="en-US" sz="1150" dirty="0">
                           <a:solidFill>
                             <a:schemeClr val="tx1"/>
                           </a:solidFill>
                         </a:rPr>
                         <a:t>Nothing, by design</a:t>
                       </a:r>
-                      <a:endParaRPr lang="en-US" sz="1300" dirty="0"/>
+                      <a:endParaRPr lang="en-US" sz="1150" dirty="0"/>
                     </a:p>
                   </a:txBody>
                   <a:tcPr marL="91440" marR="91440" marT="45720" marB="45720" anchor="ctr">
@@ -5599,14 +6439,14 @@
                         <a:buNone/>
                       </a:pPr>
                       <a:r>
-                        <a:rPr lang="en-US" sz="1300" dirty="0">
+                        <a:rPr lang="en-US" sz="1150" dirty="0">
                           <a:solidFill>
                             <a:schemeClr val="tx1"/>
                           </a:solidFill>
                         </a:rPr>
                         <a:t>DOI then title + author dedupe, relevance ranking</a:t>
                       </a:r>
-                      <a:endParaRPr lang="en-US" sz="1300" dirty="0"/>
+                      <a:endParaRPr lang="en-US" sz="1150" dirty="0"/>
                     </a:p>
                   </a:txBody>
                   <a:tcPr marL="91440" marR="91440" marT="45720" marB="45720" anchor="ctr">
@@ -5652,7 +6492,7 @@
                   </a:tcPr>
                 </a:tc>
               </a:tr>
-              <a:tr h="475488">
+              <a:tr h="374904">
                 <a:tc>
                   <a:txBody>
                     <a:bodyPr/>
@@ -5662,14 +6502,14 @@
                         <a:buNone/>
                       </a:pPr>
                       <a:r>
-                        <a:rPr lang="en-US" sz="1300" dirty="0">
+                        <a:rPr lang="en-US" sz="1150" dirty="0">
                           <a:solidFill>
                             <a:schemeClr val="tx1"/>
                           </a:solidFill>
                         </a:rPr>
                         <a:t>Critic</a:t>
                       </a:r>
-                      <a:endParaRPr lang="en-US" sz="1300" dirty="0"/>
+                      <a:endParaRPr lang="en-US" sz="1150" dirty="0"/>
                     </a:p>
                   </a:txBody>
                   <a:tcPr marL="91440" marR="91440" marT="45720" marB="45720" anchor="ctr">
@@ -5723,14 +6563,14 @@
                         <a:buNone/>
                       </a:pPr>
                       <a:r>
-                        <a:rPr lang="en-US" sz="1300" dirty="0">
+                        <a:rPr lang="en-US" sz="1150" dirty="0">
                           <a:solidFill>
                             <a:schemeClr val="tx1"/>
                           </a:solidFill>
                         </a:rPr>
                         <a:t>Appraises abstracts in one batched call</a:t>
                       </a:r>
-                      <a:endParaRPr lang="en-US" sz="1300" dirty="0"/>
+                      <a:endParaRPr lang="en-US" sz="1150" dirty="0"/>
                     </a:p>
                   </a:txBody>
                   <a:tcPr marL="91440" marR="91440" marT="45720" marB="45720" anchor="ctr">
@@ -5784,14 +6624,14 @@
                         <a:buNone/>
                       </a:pPr>
                       <a:r>
-                        <a:rPr lang="en-US" sz="1300" dirty="0">
+                        <a:rPr lang="en-US" sz="1150" dirty="0">
                           <a:solidFill>
                             <a:schemeClr val="tx1"/>
                           </a:solidFill>
                         </a:rPr>
                         <a:t>Drops invented paper ids; stop rule is explicit thresholds</a:t>
                       </a:r>
-                      <a:endParaRPr lang="en-US" sz="1300" dirty="0"/>
+                      <a:endParaRPr lang="en-US" sz="1150" dirty="0"/>
                     </a:p>
                   </a:txBody>
                   <a:tcPr marL="91440" marR="91440" marT="45720" marB="45720" anchor="ctr">
@@ -5837,7 +6677,7 @@
                   </a:tcPr>
                 </a:tc>
               </a:tr>
-              <a:tr h="475488">
+              <a:tr h="374904">
                 <a:tc>
                   <a:txBody>
                     <a:bodyPr/>
@@ -5847,14 +6687,14 @@
                         <a:buNone/>
                       </a:pPr>
                       <a:r>
-                        <a:rPr lang="en-US" sz="1300" dirty="0">
+                        <a:rPr lang="en-US" sz="1150" dirty="0">
                           <a:solidFill>
                             <a:schemeClr val="tx1"/>
                           </a:solidFill>
                         </a:rPr>
                         <a:t>Reporter</a:t>
                       </a:r>
-                      <a:endParaRPr lang="en-US" sz="1300" dirty="0"/>
+                      <a:endParaRPr lang="en-US" sz="1150" dirty="0"/>
                     </a:p>
                   </a:txBody>
                   <a:tcPr marL="91440" marR="91440" marT="45720" marB="45720" anchor="ctr">
@@ -5908,14 +6748,14 @@
                         <a:buNone/>
                       </a:pPr>
                       <a:r>
-                        <a:rPr lang="en-US" sz="1300" dirty="0">
+                        <a:rPr lang="en-US" sz="1150" dirty="0">
                           <a:solidFill>
                             <a:schemeClr val="tx1"/>
                           </a:solidFill>
                         </a:rPr>
                         <a:t>Drafts the briefing</a:t>
                       </a:r>
-                      <a:endParaRPr lang="en-US" sz="1300" dirty="0"/>
+                      <a:endParaRPr lang="en-US" sz="1150" dirty="0"/>
                     </a:p>
                   </a:txBody>
                   <a:tcPr marL="91440" marR="91440" marT="45720" marB="45720" anchor="ctr">
@@ -5969,14 +6809,14 @@
                         <a:buNone/>
                       </a:pPr>
                       <a:r>
-                        <a:rPr lang="en-US" sz="1300" dirty="0">
+                        <a:rPr lang="en-US" sz="1150" dirty="0">
                           <a:solidFill>
                             <a:schemeClr val="tx1"/>
                           </a:solidFill>
                         </a:rPr>
                         <a:t>Every finding must cite a retrieved paper</a:t>
                       </a:r>
-                      <a:endParaRPr lang="en-US" sz="1300" dirty="0"/>
+                      <a:endParaRPr lang="en-US" sz="1150" dirty="0"/>
                     </a:p>
                   </a:txBody>
                   <a:tcPr marL="91440" marR="91440" marT="45720" marB="45720" anchor="ctr">
@@ -6028,37 +6868,325 @@
       </p:graphicFrame>
       <p:sp>
         <p:nvSpPr>
-          <p:cNvPr id="4" name="Text 1"/>
+          <p:cNvPr id="21" name="Decision 1 card"/>
+          <p:cNvSpPr/>
+          <p:nvPr/>
+        </p:nvSpPr>
+        <p:spPr>
+          <a:xfrm>
+            <a:off x="457200" y="3456432"/>
+            <a:ext cx="1988820" cy="822960"/>
+          </a:xfrm>
+          <a:prstGeom prst="roundRect">
+            <a:avLst>
+              <a:gd name="adj" fmla="val 3000"/>
+            </a:avLst>
+          </a:prstGeom>
+          <a:solidFill>
+            <a:schemeClr val="bg2"/>
+          </a:solidFill>
+          <a:ln w="12700">
+            <a:solidFill>
+              <a:schemeClr val="bg2"/>
+            </a:solidFill>
+          </a:ln>
+        </p:spPr>
+      </p:sp>
+      <p:sp>
+        <p:nvSpPr>
+          <p:cNvPr id="22" name="Decision 1 text"/>
           <p:cNvSpPr txBox="1"/>
           <p:nvPr/>
         </p:nvSpPr>
         <p:spPr>
           <a:xfrm>
-            <a:off x="457200" y="4160520"/>
-            <a:ext cx="8229600" cy="411480"/>
+            <a:off x="502920" y="3483864"/>
+            <a:ext cx="1897380" cy="768096"/>
           </a:xfrm>
           <a:prstGeom prst="rect">
             <a:avLst/>
           </a:prstGeom>
           <a:noFill/>
-          <a:ln/>
-        </p:spPr>
-        <p:txBody>
-          <a:bodyPr wrap="square" rtlCol="0" anchor="ctr"/>
+        </p:spPr>
+        <p:txBody>
+          <a:bodyPr wrap="square" lIns="45720" tIns="45720" rIns="45720" bIns="45720" rtlCol="0" anchor="t"/>
           <a:lstStyle/>
           <a:p>
             <a:pPr indent="0" marL="0">
-              <a:buNone/>
-            </a:pPr>
-            <a:r>
-              <a:rPr lang="en-US" sz="1400" i="1" dirty="0">
+              <a:spcAft>
+                <a:spcPts val="300"/>
+              </a:spcAft>
+              <a:buNone/>
+            </a:pPr>
+            <a:r>
+              <a:rPr lang="en-GB" sz="1150" b="1" dirty="0">
                 <a:solidFill>
                   <a:schemeClr val="accent1"/>
                 </a:solidFill>
               </a:rPr>
-              <a:t>Language understanding goes to the model; anything with one correct answer stays in code (Unit 6 proposal, s.3).</a:t>
-            </a:r>
-            <a:endParaRPr lang="en-US" sz="1400" dirty="0"/>
+              <a:t xml:space="preserve">Rule-based stopping</a:t>
+            </a:r>
+            <a:endParaRPr lang="en-GB" sz="1150" dirty="0"/>
+          </a:p>
+          <a:p>
+            <a:pPr indent="0" marL="0">
+              <a:spcAft>
+                <a:spcPts val="0"/>
+              </a:spcAft>
+              <a:buNone/>
+            </a:pPr>
+            <a:r>
+              <a:rPr lang="en-GB" sz="1000" dirty="0">
+                <a:solidFill>
+                  <a:schemeClr val="tx1"/>
+                </a:solidFill>
+              </a:rPr>
+              <a:t xml:space="preserve">Thresholds, not the model, decide whether to search again (Ji et al., 2023)</a:t>
+            </a:r>
+            <a:endParaRPr lang="en-GB" sz="1000" dirty="0"/>
+          </a:p>
+        </p:txBody>
+      </p:sp>
+      <p:sp>
+        <p:nvSpPr>
+          <p:cNvPr id="23" name="Decision 2 card"/>
+          <p:cNvSpPr/>
+          <p:nvPr/>
+        </p:nvSpPr>
+        <p:spPr>
+          <a:xfrm>
+            <a:off x="2537460" y="3456432"/>
+            <a:ext cx="1988820" cy="822960"/>
+          </a:xfrm>
+          <a:prstGeom prst="roundRect">
+            <a:avLst>
+              <a:gd name="adj" fmla="val 3000"/>
+            </a:avLst>
+          </a:prstGeom>
+          <a:solidFill>
+            <a:schemeClr val="bg2"/>
+          </a:solidFill>
+          <a:ln w="12700">
+            <a:solidFill>
+              <a:schemeClr val="bg2"/>
+            </a:solidFill>
+          </a:ln>
+        </p:spPr>
+      </p:sp>
+      <p:sp>
+        <p:nvSpPr>
+          <p:cNvPr id="24" name="Decision 2 text"/>
+          <p:cNvSpPr txBox="1"/>
+          <p:nvPr/>
+        </p:nvSpPr>
+        <p:spPr>
+          <a:xfrm>
+            <a:off x="2583180" y="3483864"/>
+            <a:ext cx="1897380" cy="768096"/>
+          </a:xfrm>
+          <a:prstGeom prst="rect">
+            <a:avLst/>
+          </a:prstGeom>
+          <a:noFill/>
+        </p:spPr>
+        <p:txBody>
+          <a:bodyPr wrap="square" lIns="45720" tIns="45720" rIns="45720" bIns="45720" rtlCol="0" anchor="t"/>
+          <a:lstStyle/>
+          <a:p>
+            <a:pPr indent="0" marL="0">
+              <a:spcAft>
+                <a:spcPts val="300"/>
+              </a:spcAft>
+              <a:buNone/>
+            </a:pPr>
+            <a:r>
+              <a:rPr lang="en-GB" sz="1150" b="1" dirty="0">
+                <a:solidFill>
+                  <a:schemeClr val="accent1"/>
+                </a:solidFill>
+              </a:rPr>
+              <a:t xml:space="preserve">Grounded reporting</a:t>
+            </a:r>
+            <a:endParaRPr lang="en-GB" sz="1150" dirty="0"/>
+          </a:p>
+          <a:p>
+            <a:pPr indent="0" marL="0">
+              <a:spcAft>
+                <a:spcPts val="0"/>
+              </a:spcAft>
+              <a:buNone/>
+            </a:pPr>
+            <a:r>
+              <a:rPr lang="en-GB" sz="1000" dirty="0">
+                <a:solidFill>
+                  <a:schemeClr val="tx1"/>
+                </a:solidFill>
+              </a:rPr>
+              <a:t xml:space="preserve">Citations to papers never retrieved are stripped (Lewis et al., 2020; Huang et al., 2025)</a:t>
+            </a:r>
+            <a:endParaRPr lang="en-GB" sz="1000" dirty="0"/>
+          </a:p>
+        </p:txBody>
+      </p:sp>
+      <p:sp>
+        <p:nvSpPr>
+          <p:cNvPr id="25" name="Decision 3 card"/>
+          <p:cNvSpPr/>
+          <p:nvPr/>
+        </p:nvSpPr>
+        <p:spPr>
+          <a:xfrm>
+            <a:off x="4617720" y="3456432"/>
+            <a:ext cx="1988820" cy="822960"/>
+          </a:xfrm>
+          <a:prstGeom prst="roundRect">
+            <a:avLst>
+              <a:gd name="adj" fmla="val 3000"/>
+            </a:avLst>
+          </a:prstGeom>
+          <a:solidFill>
+            <a:schemeClr val="bg2"/>
+          </a:solidFill>
+          <a:ln w="12700">
+            <a:solidFill>
+              <a:schemeClr val="bg2"/>
+            </a:solidFill>
+          </a:ln>
+        </p:spPr>
+      </p:sp>
+      <p:sp>
+        <p:nvSpPr>
+          <p:cNvPr id="26" name="Decision 3 text"/>
+          <p:cNvSpPr txBox="1"/>
+          <p:nvPr/>
+        </p:nvSpPr>
+        <p:spPr>
+          <a:xfrm>
+            <a:off x="4663440" y="3483864"/>
+            <a:ext cx="1897380" cy="768096"/>
+          </a:xfrm>
+          <a:prstGeom prst="rect">
+            <a:avLst/>
+          </a:prstGeom>
+          <a:noFill/>
+        </p:spPr>
+        <p:txBody>
+          <a:bodyPr wrap="square" lIns="45720" tIns="45720" rIns="45720" bIns="45720" rtlCol="0" anchor="t"/>
+          <a:lstStyle/>
+          <a:p>
+            <a:pPr indent="0" marL="0">
+              <a:spcAft>
+                <a:spcPts val="300"/>
+              </a:spcAft>
+              <a:buNone/>
+            </a:pPr>
+            <a:r>
+              <a:rPr lang="en-GB" sz="1150" b="1" dirty="0">
+                <a:solidFill>
+                  <a:schemeClr val="accent1"/>
+                </a:solidFill>
+              </a:rPr>
+              <a:t xml:space="preserve">Graceful degradation</a:t>
+            </a:r>
+            <a:endParaRPr lang="en-GB" sz="1150" dirty="0"/>
+          </a:p>
+          <a:p>
+            <a:pPr indent="0" marL="0">
+              <a:spcAft>
+                <a:spcPts val="0"/>
+              </a:spcAft>
+              <a:buNone/>
+            </a:pPr>
+            <a:r>
+              <a:rPr lang="en-GB" sz="1000" dirty="0">
+                <a:solidFill>
+                  <a:schemeClr val="tx1"/>
+                </a:solidFill>
+              </a:rPr>
+              <a:t xml:space="preserve">Every LLM step has a fallback; the audit trail records which ran</a:t>
+            </a:r>
+            <a:endParaRPr lang="en-GB" sz="1000" dirty="0"/>
+          </a:p>
+        </p:txBody>
+      </p:sp>
+      <p:sp>
+        <p:nvSpPr>
+          <p:cNvPr id="27" name="Decision 4 card"/>
+          <p:cNvSpPr/>
+          <p:nvPr/>
+        </p:nvSpPr>
+        <p:spPr>
+          <a:xfrm>
+            <a:off x="6697980" y="3456432"/>
+            <a:ext cx="1988820" cy="822960"/>
+          </a:xfrm>
+          <a:prstGeom prst="roundRect">
+            <a:avLst>
+              <a:gd name="adj" fmla="val 3000"/>
+            </a:avLst>
+          </a:prstGeom>
+          <a:solidFill>
+            <a:schemeClr val="bg2"/>
+          </a:solidFill>
+          <a:ln w="12700">
+            <a:solidFill>
+              <a:schemeClr val="bg2"/>
+            </a:solidFill>
+          </a:ln>
+        </p:spPr>
+      </p:sp>
+      <p:sp>
+        <p:nvSpPr>
+          <p:cNvPr id="28" name="Decision 4 text"/>
+          <p:cNvSpPr txBox="1"/>
+          <p:nvPr/>
+        </p:nvSpPr>
+        <p:spPr>
+          <a:xfrm>
+            <a:off x="6743700" y="3483864"/>
+            <a:ext cx="1897380" cy="768096"/>
+          </a:xfrm>
+          <a:prstGeom prst="rect">
+            <a:avLst/>
+          </a:prstGeom>
+          <a:noFill/>
+        </p:spPr>
+        <p:txBody>
+          <a:bodyPr wrap="square" lIns="45720" tIns="45720" rIns="45720" bIns="45720" rtlCol="0" anchor="t"/>
+          <a:lstStyle/>
+          <a:p>
+            <a:pPr indent="0" marL="0">
+              <a:spcAft>
+                <a:spcPts val="300"/>
+              </a:spcAft>
+              <a:buNone/>
+            </a:pPr>
+            <a:r>
+              <a:rPr lang="en-GB" sz="1150" b="1" dirty="0">
+                <a:solidFill>
+                  <a:schemeClr val="accent1"/>
+                </a:solidFill>
+              </a:rPr>
+              <a:t xml:space="preserve">Explicit offline mode</a:t>
+            </a:r>
+            <a:endParaRPr lang="en-GB" sz="1150" dirty="0"/>
+          </a:p>
+          <a:p>
+            <a:pPr indent="0" marL="0">
+              <a:spcAft>
+                <a:spcPts val="0"/>
+              </a:spcAft>
+              <a:buNone/>
+            </a:pPr>
+            <a:r>
+              <a:rPr lang="en-GB" sz="1000" dirty="0">
+                <a:solidFill>
+                  <a:schemeClr val="tx1"/>
+                </a:solidFill>
+              </a:rPr>
+              <a:t xml:space="preserve">Reproducible demos and tests, never a silent fallback</a:t>
+            </a:r>
+            <a:endParaRPr lang="en-GB" sz="1000" dirty="0"/>
           </a:p>
         </p:txBody>
       </p:sp>
@@ -6102,709 +7230,6 @@
             <a:fld id="{F7021451-1387-4CA6-816F-3879F97B5CBC}" type="slidenum">
               <a:rPr b="0" lang="en-US"/>
               <a:t>4</a:t>
-            </a:fld>
-            <a:endParaRPr lang="en-US"/>
-          </a:p>
-        </p:txBody>
-      </p:sp>
-    </p:spTree>
-  </p:cSld>
-  <p:clrMapOvr>
-    <a:masterClrMapping/>
-  </p:clrMapOvr>
-</p:sld>
-</file>
-
-<file path=ppt/slides/slide5.xml><?xml version="1.0" encoding="utf-8"?>
-<p:sld xmlns:a="http://schemas.openxmlformats.org/drawingml/2006/main" xmlns:r="http://schemas.openxmlformats.org/officeDocument/2006/relationships" xmlns:p="http://schemas.openxmlformats.org/presentationml/2006/main">
-  <p:cSld name="Slide 5">
-    <p:spTree>
-      <p:nvGrpSpPr>
-        <p:cNvPr id="1" name=""/>
-        <p:cNvGrpSpPr/>
-        <p:nvPr/>
-      </p:nvGrpSpPr>
-      <p:grpSpPr>
-        <a:xfrm>
-          <a:off x="0" y="0"/>
-          <a:ext cx="0" cy="0"/>
-          <a:chOff x="0" y="0"/>
-          <a:chExt cx="0" cy="0"/>
-        </a:xfrm>
-      </p:grpSpPr>
-      <p:sp>
-        <p:nvSpPr>
-          <p:cNvPr id="2" name="Text 0"/>
-          <p:cNvSpPr/>
-          <p:nvPr>
-            <p:ph idx="100" type="title" hasCustomPrompt="1"/>
-          </p:nvPr>
-        </p:nvSpPr>
-        <p:spPr>
-          <a:xfrm>
-            <a:off x="457200" y="274320"/>
-            <a:ext cx="8229600" cy="685800"/>
-          </a:xfrm>
-          <a:prstGeom prst="rect">
-            <a:avLst/>
-          </a:prstGeom>
-          <a:noFill/>
-          <a:ln/>
-        </p:spPr>
-        <p:txBody>
-          <a:bodyPr wrap="square" rtlCol="0" anchor="ctr"/>
-          <a:lstStyle/>
-          <a:p>
-            <a:pPr indent="0" marL="0">
-              <a:buNone/>
-            </a:pPr>
-            <a:r>
-              <a:rPr lang="en-US" sz="3000" b="1" dirty="0">
-                <a:solidFill>
-                  <a:schemeClr val="tx2"/>
-                </a:solidFill>
-                <a:latin typeface="Cambria" pitchFamily="34" charset="0"/>
-                <a:ea typeface="Cambria" pitchFamily="34" charset="-122"/>
-                <a:cs typeface="Cambria" pitchFamily="34" charset="-120"/>
-              </a:rPr>
-              <a:t>Four decisions that make it trustworthy</a:t>
-            </a:r>
-            <a:endParaRPr lang="en-US" sz="3000" dirty="0"/>
-          </a:p>
-        </p:txBody>
-      </p:sp>
-      <p:sp>
-        <p:nvSpPr>
-          <p:cNvPr id="3" name="Rule-based stopping card"/>
-          <p:cNvSpPr/>
-          <p:nvPr/>
-        </p:nvSpPr>
-        <p:spPr>
-          <a:xfrm>
-            <a:off x="457200" y="1143000"/>
-            <a:ext cx="4023360" cy="1645920"/>
-          </a:xfrm>
-          <a:prstGeom prst="roundRect">
-            <a:avLst>
-              <a:gd name="adj" fmla="val 4444"/>
-            </a:avLst>
-          </a:prstGeom>
-          <a:solidFill>
-            <a:schemeClr val="bg2"/>
-          </a:solidFill>
-          <a:ln w="12700">
-            <a:solidFill>
-              <a:schemeClr val="bg2"/>
-            </a:solidFill>
-            <a:prstDash val="solid"/>
-          </a:ln>
-        </p:spPr>
-      </p:sp>
-      <p:sp>
-        <p:nvSpPr>
-          <p:cNvPr id="4" name="Rule-based stopping circle"/>
-          <p:cNvSpPr/>
-          <p:nvPr/>
-        </p:nvSpPr>
-        <p:spPr>
-          <a:xfrm>
-            <a:off x="640080" y="1325880"/>
-            <a:ext cx="548640" cy="548640"/>
-          </a:xfrm>
-          <a:prstGeom prst="ellipse">
-            <a:avLst/>
-          </a:prstGeom>
-          <a:solidFill>
-            <a:schemeClr val="accent1"/>
-          </a:solidFill>
-          <a:ln w="12700">
-            <a:solidFill>
-              <a:schemeClr val="accent1"/>
-            </a:solidFill>
-            <a:prstDash val="solid"/>
-          </a:ln>
-        </p:spPr>
-      </p:sp>
-      <p:pic>
-        <p:nvPicPr>
-          <p:cNvPr id="5" name="Rule-based stopping icon" descr="preencoded.png">    </p:cNvPr>
-          <p:cNvPicPr>
-            <a:picLocks noChangeAspect="1"/>
-          </p:cNvPicPr>
-          <p:nvPr/>
-        </p:nvPicPr>
-        <p:blipFill>
-          <a:blip r:embed="rId1"/>
-          <a:stretch>
-            <a:fillRect/>
-          </a:stretch>
-        </p:blipFill>
-        <p:spPr>
-          <a:xfrm>
-            <a:off x="771754" y="1457554"/>
-            <a:ext cx="285293" cy="285293"/>
-          </a:xfrm>
-          <a:prstGeom prst="rect">
-            <a:avLst/>
-          </a:prstGeom>
-        </p:spPr>
-      </p:pic>
-      <p:sp>
-        <p:nvSpPr>
-          <p:cNvPr id="6" name="Text 3"/>
-          <p:cNvSpPr txBox="1"/>
-          <p:nvPr/>
-        </p:nvSpPr>
-        <p:spPr>
-          <a:xfrm>
-            <a:off x="1325880" y="1344168"/>
-            <a:ext cx="3017520" cy="502920"/>
-          </a:xfrm>
-          <a:prstGeom prst="rect">
-            <a:avLst/>
-          </a:prstGeom>
-          <a:noFill/>
-          <a:ln/>
-        </p:spPr>
-        <p:txBody>
-          <a:bodyPr wrap="square" rtlCol="0" anchor="ctr"/>
-          <a:lstStyle/>
-          <a:p>
-            <a:pPr indent="0" marL="0">
-              <a:buNone/>
-            </a:pPr>
-            <a:r>
-              <a:rPr lang="en-US" sz="1700" b="1" dirty="0">
-                <a:solidFill>
-                  <a:schemeClr val="tx2"/>
-                </a:solidFill>
-              </a:rPr>
-              <a:t>Rule-based stopping</a:t>
-            </a:r>
-            <a:endParaRPr lang="en-US" sz="1700" dirty="0"/>
-          </a:p>
-        </p:txBody>
-      </p:sp>
-      <p:sp>
-        <p:nvSpPr>
-          <p:cNvPr id="7" name="Text 4"/>
-          <p:cNvSpPr txBox="1"/>
-          <p:nvPr/>
-        </p:nvSpPr>
-        <p:spPr>
-          <a:xfrm>
-            <a:off x="640080" y="1920240"/>
-            <a:ext cx="3703320" cy="822960"/>
-          </a:xfrm>
-          <a:prstGeom prst="rect">
-            <a:avLst/>
-          </a:prstGeom>
-          <a:noFill/>
-          <a:ln/>
-        </p:spPr>
-        <p:txBody>
-          <a:bodyPr wrap="square" rtlCol="0" anchor="t"/>
-          <a:lstStyle/>
-          <a:p>
-            <a:pPr indent="0" marL="0">
-              <a:buNone/>
-            </a:pPr>
-            <a:r>
-              <a:rPr lang="en-US" sz="1250" dirty="0">
-                <a:solidFill>
-                  <a:schemeClr val="tx1"/>
-                </a:solidFill>
-              </a:rPr>
-              <a:t>The Critic's sufficient / relevant / balanced verdict uses explicit thresholds. Self-reflection reduces but does not remove hallucination (Ji et al., 2023).</a:t>
-            </a:r>
-            <a:endParaRPr lang="en-US" sz="1250" dirty="0"/>
-          </a:p>
-        </p:txBody>
-      </p:sp>
-      <p:sp>
-        <p:nvSpPr>
-          <p:cNvPr id="8" name="Grounded reporting card"/>
-          <p:cNvSpPr/>
-          <p:nvPr/>
-        </p:nvSpPr>
-        <p:spPr>
-          <a:xfrm>
-            <a:off x="4663440" y="1143000"/>
-            <a:ext cx="4023360" cy="1645920"/>
-          </a:xfrm>
-          <a:prstGeom prst="roundRect">
-            <a:avLst>
-              <a:gd name="adj" fmla="val 4444"/>
-            </a:avLst>
-          </a:prstGeom>
-          <a:solidFill>
-            <a:schemeClr val="bg2"/>
-          </a:solidFill>
-          <a:ln w="12700">
-            <a:solidFill>
-              <a:schemeClr val="bg2"/>
-            </a:solidFill>
-            <a:prstDash val="solid"/>
-          </a:ln>
-        </p:spPr>
-      </p:sp>
-      <p:sp>
-        <p:nvSpPr>
-          <p:cNvPr id="9" name="Grounded reporting circle"/>
-          <p:cNvSpPr/>
-          <p:nvPr/>
-        </p:nvSpPr>
-        <p:spPr>
-          <a:xfrm>
-            <a:off x="4846320" y="1325880"/>
-            <a:ext cx="548640" cy="548640"/>
-          </a:xfrm>
-          <a:prstGeom prst="ellipse">
-            <a:avLst/>
-          </a:prstGeom>
-          <a:solidFill>
-            <a:schemeClr val="accent1"/>
-          </a:solidFill>
-          <a:ln w="12700">
-            <a:solidFill>
-              <a:schemeClr val="accent1"/>
-            </a:solidFill>
-            <a:prstDash val="solid"/>
-          </a:ln>
-        </p:spPr>
-      </p:sp>
-      <p:pic>
-        <p:nvPicPr>
-          <p:cNvPr id="10" name="Grounded reporting icon" descr="preencoded.png">    </p:cNvPr>
-          <p:cNvPicPr>
-            <a:picLocks noChangeAspect="1"/>
-          </p:cNvPicPr>
-          <p:nvPr/>
-        </p:nvPicPr>
-        <p:blipFill>
-          <a:blip r:embed="rId2"/>
-          <a:stretch>
-            <a:fillRect/>
-          </a:stretch>
-        </p:blipFill>
-        <p:spPr>
-          <a:xfrm>
-            <a:off x="4977994" y="1457554"/>
-            <a:ext cx="285293" cy="285293"/>
-          </a:xfrm>
-          <a:prstGeom prst="rect">
-            <a:avLst/>
-          </a:prstGeom>
-        </p:spPr>
-      </p:pic>
-      <p:sp>
-        <p:nvSpPr>
-          <p:cNvPr id="11" name="Text 7"/>
-          <p:cNvSpPr txBox="1"/>
-          <p:nvPr/>
-        </p:nvSpPr>
-        <p:spPr>
-          <a:xfrm>
-            <a:off x="5532120" y="1344168"/>
-            <a:ext cx="3017520" cy="502920"/>
-          </a:xfrm>
-          <a:prstGeom prst="rect">
-            <a:avLst/>
-          </a:prstGeom>
-          <a:noFill/>
-          <a:ln/>
-        </p:spPr>
-        <p:txBody>
-          <a:bodyPr wrap="square" rtlCol="0" anchor="ctr"/>
-          <a:lstStyle/>
-          <a:p>
-            <a:pPr indent="0" marL="0">
-              <a:buNone/>
-            </a:pPr>
-            <a:r>
-              <a:rPr lang="en-US" sz="1700" b="1" dirty="0">
-                <a:solidFill>
-                  <a:schemeClr val="tx2"/>
-                </a:solidFill>
-              </a:rPr>
-              <a:t>Grounded reporting</a:t>
-            </a:r>
-            <a:endParaRPr lang="en-US" sz="1700" dirty="0"/>
-          </a:p>
-        </p:txBody>
-      </p:sp>
-      <p:sp>
-        <p:nvSpPr>
-          <p:cNvPr id="12" name="Text 8"/>
-          <p:cNvSpPr txBox="1"/>
-          <p:nvPr/>
-        </p:nvSpPr>
-        <p:spPr>
-          <a:xfrm>
-            <a:off x="4846320" y="1920240"/>
-            <a:ext cx="3703320" cy="822960"/>
-          </a:xfrm>
-          <a:prstGeom prst="rect">
-            <a:avLst/>
-          </a:prstGeom>
-          <a:noFill/>
-          <a:ln/>
-        </p:spPr>
-        <p:txBody>
-          <a:bodyPr wrap="square" rtlCol="0" anchor="t"/>
-          <a:lstStyle/>
-          <a:p>
-            <a:pPr indent="0" marL="0">
-              <a:buNone/>
-            </a:pPr>
-            <a:r>
-              <a:rPr lang="en-US" sz="1250" dirty="0">
-                <a:solidFill>
-                  <a:schemeClr val="tx1"/>
-                </a:solidFill>
-              </a:rPr>
-              <a:t>Citations to papers that were never retrieved are stripped; findings left uncited are dropped (Lewis et al., 2020; Huang et al., 2025).</a:t>
-            </a:r>
-            <a:endParaRPr lang="en-US" sz="1250" dirty="0"/>
-          </a:p>
-        </p:txBody>
-      </p:sp>
-      <p:sp>
-        <p:nvSpPr>
-          <p:cNvPr id="13" name="Graceful degradation card"/>
-          <p:cNvSpPr/>
-          <p:nvPr/>
-        </p:nvSpPr>
-        <p:spPr>
-          <a:xfrm>
-            <a:off x="457200" y="2926080"/>
-            <a:ext cx="4023360" cy="1645920"/>
-          </a:xfrm>
-          <a:prstGeom prst="roundRect">
-            <a:avLst>
-              <a:gd name="adj" fmla="val 4444"/>
-            </a:avLst>
-          </a:prstGeom>
-          <a:solidFill>
-            <a:schemeClr val="bg2"/>
-          </a:solidFill>
-          <a:ln w="12700">
-            <a:solidFill>
-              <a:schemeClr val="bg2"/>
-            </a:solidFill>
-            <a:prstDash val="solid"/>
-          </a:ln>
-        </p:spPr>
-      </p:sp>
-      <p:sp>
-        <p:nvSpPr>
-          <p:cNvPr id="14" name="Graceful degradation circle"/>
-          <p:cNvSpPr/>
-          <p:nvPr/>
-        </p:nvSpPr>
-        <p:spPr>
-          <a:xfrm>
-            <a:off x="640080" y="3108960"/>
-            <a:ext cx="548640" cy="548640"/>
-          </a:xfrm>
-          <a:prstGeom prst="ellipse">
-            <a:avLst/>
-          </a:prstGeom>
-          <a:solidFill>
-            <a:schemeClr val="accent1"/>
-          </a:solidFill>
-          <a:ln w="12700">
-            <a:solidFill>
-              <a:schemeClr val="accent1"/>
-            </a:solidFill>
-            <a:prstDash val="solid"/>
-          </a:ln>
-        </p:spPr>
-      </p:sp>
-      <p:pic>
-        <p:nvPicPr>
-          <p:cNvPr id="15" name="Graceful degradation icon" descr="preencoded.png">    </p:cNvPr>
-          <p:cNvPicPr>
-            <a:picLocks noChangeAspect="1"/>
-          </p:cNvPicPr>
-          <p:nvPr/>
-        </p:nvPicPr>
-        <p:blipFill>
-          <a:blip r:embed="rId3"/>
-          <a:stretch>
-            <a:fillRect/>
-          </a:stretch>
-        </p:blipFill>
-        <p:spPr>
-          <a:xfrm>
-            <a:off x="771754" y="3240634"/>
-            <a:ext cx="285293" cy="285293"/>
-          </a:xfrm>
-          <a:prstGeom prst="rect">
-            <a:avLst/>
-          </a:prstGeom>
-        </p:spPr>
-      </p:pic>
-      <p:sp>
-        <p:nvSpPr>
-          <p:cNvPr id="16" name="Text 11"/>
-          <p:cNvSpPr txBox="1"/>
-          <p:nvPr/>
-        </p:nvSpPr>
-        <p:spPr>
-          <a:xfrm>
-            <a:off x="1325880" y="3127248"/>
-            <a:ext cx="3017520" cy="502920"/>
-          </a:xfrm>
-          <a:prstGeom prst="rect">
-            <a:avLst/>
-          </a:prstGeom>
-          <a:noFill/>
-          <a:ln/>
-        </p:spPr>
-        <p:txBody>
-          <a:bodyPr wrap="square" rtlCol="0" anchor="ctr"/>
-          <a:lstStyle/>
-          <a:p>
-            <a:pPr indent="0" marL="0">
-              <a:buNone/>
-            </a:pPr>
-            <a:r>
-              <a:rPr lang="en-US" sz="1700" b="1" dirty="0">
-                <a:solidFill>
-                  <a:schemeClr val="tx2"/>
-                </a:solidFill>
-              </a:rPr>
-              <a:t>Graceful degradation</a:t>
-            </a:r>
-            <a:endParaRPr lang="en-US" sz="1700" dirty="0"/>
-          </a:p>
-        </p:txBody>
-      </p:sp>
-      <p:sp>
-        <p:nvSpPr>
-          <p:cNvPr id="17" name="Text 12"/>
-          <p:cNvSpPr txBox="1"/>
-          <p:nvPr/>
-        </p:nvSpPr>
-        <p:spPr>
-          <a:xfrm>
-            <a:off x="640080" y="3703320"/>
-            <a:ext cx="3703320" cy="822960"/>
-          </a:xfrm>
-          <a:prstGeom prst="rect">
-            <a:avLst/>
-          </a:prstGeom>
-          <a:noFill/>
-          <a:ln/>
-        </p:spPr>
-        <p:txBody>
-          <a:bodyPr wrap="square" rtlCol="0" anchor="t"/>
-          <a:lstStyle/>
-          <a:p>
-            <a:pPr indent="0" marL="0">
-              <a:buNone/>
-            </a:pPr>
-            <a:r>
-              <a:rPr lang="en-US" sz="1250" dirty="0">
-                <a:solidFill>
-                  <a:schemeClr val="tx1"/>
-                </a:solidFill>
-              </a:rPr>
-              <a:t>Every LLM step has a deterministic fallback, so a rate limit lowers quality, not availability. The audit trail records which path ran.</a:t>
-            </a:r>
-            <a:endParaRPr lang="en-US" sz="1250" dirty="0"/>
-          </a:p>
-        </p:txBody>
-      </p:sp>
-      <p:sp>
-        <p:nvSpPr>
-          <p:cNvPr id="18" name="Explicit offline mode card"/>
-          <p:cNvSpPr/>
-          <p:nvPr/>
-        </p:nvSpPr>
-        <p:spPr>
-          <a:xfrm>
-            <a:off x="4663440" y="2926080"/>
-            <a:ext cx="4023360" cy="1645920"/>
-          </a:xfrm>
-          <a:prstGeom prst="roundRect">
-            <a:avLst>
-              <a:gd name="adj" fmla="val 4444"/>
-            </a:avLst>
-          </a:prstGeom>
-          <a:solidFill>
-            <a:schemeClr val="bg2"/>
-          </a:solidFill>
-          <a:ln w="12700">
-            <a:solidFill>
-              <a:schemeClr val="bg2"/>
-            </a:solidFill>
-            <a:prstDash val="solid"/>
-          </a:ln>
-        </p:spPr>
-      </p:sp>
-      <p:sp>
-        <p:nvSpPr>
-          <p:cNvPr id="19" name="Explicit offline mode circle"/>
-          <p:cNvSpPr/>
-          <p:nvPr/>
-        </p:nvSpPr>
-        <p:spPr>
-          <a:xfrm>
-            <a:off x="4846320" y="3108960"/>
-            <a:ext cx="548640" cy="548640"/>
-          </a:xfrm>
-          <a:prstGeom prst="ellipse">
-            <a:avLst/>
-          </a:prstGeom>
-          <a:solidFill>
-            <a:schemeClr val="accent1"/>
-          </a:solidFill>
-          <a:ln w="12700">
-            <a:solidFill>
-              <a:schemeClr val="accent1"/>
-            </a:solidFill>
-            <a:prstDash val="solid"/>
-          </a:ln>
-        </p:spPr>
-      </p:sp>
-      <p:pic>
-        <p:nvPicPr>
-          <p:cNvPr id="20" name="Explicit offline mode icon" descr="preencoded.png">    </p:cNvPr>
-          <p:cNvPicPr>
-            <a:picLocks noChangeAspect="1"/>
-          </p:cNvPicPr>
-          <p:nvPr/>
-        </p:nvPicPr>
-        <p:blipFill>
-          <a:blip r:embed="rId4"/>
-          <a:stretch>
-            <a:fillRect/>
-          </a:stretch>
-        </p:blipFill>
-        <p:spPr>
-          <a:xfrm>
-            <a:off x="4977994" y="3240634"/>
-            <a:ext cx="285293" cy="285293"/>
-          </a:xfrm>
-          <a:prstGeom prst="rect">
-            <a:avLst/>
-          </a:prstGeom>
-        </p:spPr>
-      </p:pic>
-      <p:sp>
-        <p:nvSpPr>
-          <p:cNvPr id="21" name="Text 15"/>
-          <p:cNvSpPr txBox="1"/>
-          <p:nvPr/>
-        </p:nvSpPr>
-        <p:spPr>
-          <a:xfrm>
-            <a:off x="5532120" y="3127248"/>
-            <a:ext cx="3017520" cy="502920"/>
-          </a:xfrm>
-          <a:prstGeom prst="rect">
-            <a:avLst/>
-          </a:prstGeom>
-          <a:noFill/>
-          <a:ln/>
-        </p:spPr>
-        <p:txBody>
-          <a:bodyPr wrap="square" rtlCol="0" anchor="ctr"/>
-          <a:lstStyle/>
-          <a:p>
-            <a:pPr indent="0" marL="0">
-              <a:buNone/>
-            </a:pPr>
-            <a:r>
-              <a:rPr lang="en-US" sz="1700" b="1" dirty="0">
-                <a:solidFill>
-                  <a:schemeClr val="tx2"/>
-                </a:solidFill>
-              </a:rPr>
-              <a:t>Explicit offline mode</a:t>
-            </a:r>
-            <a:endParaRPr lang="en-US" sz="1700" dirty="0"/>
-          </a:p>
-        </p:txBody>
-      </p:sp>
-      <p:sp>
-        <p:nvSpPr>
-          <p:cNvPr id="22" name="Text 16"/>
-          <p:cNvSpPr txBox="1"/>
-          <p:nvPr/>
-        </p:nvSpPr>
-        <p:spPr>
-          <a:xfrm>
-            <a:off x="4846320" y="3703320"/>
-            <a:ext cx="3703320" cy="822960"/>
-          </a:xfrm>
-          <a:prstGeom prst="rect">
-            <a:avLst/>
-          </a:prstGeom>
-          <a:noFill/>
-          <a:ln/>
-        </p:spPr>
-        <p:txBody>
-          <a:bodyPr wrap="square" rtlCol="0" anchor="t"/>
-          <a:lstStyle/>
-          <a:p>
-            <a:pPr indent="0" marL="0">
-              <a:buNone/>
-            </a:pPr>
-            <a:r>
-              <a:rPr lang="en-US" sz="1250" dirty="0">
-                <a:solidFill>
-                  <a:schemeClr val="tx1"/>
-                </a:solidFill>
-              </a:rPr>
-              <a:t>Reproducible demos and tests. Never a silent fallback: mixing demo data into a live briefing would misrepresent the evidence.</a:t>
-            </a:r>
-            <a:endParaRPr lang="en-US" sz="1250" dirty="0"/>
-          </a:p>
-        </p:txBody>
-      </p:sp>
-      <p:sp>
-        <p:nvSpPr>
-          <p:cNvPr id="25" name="Slide Number Placeholder 0"/>
-          <p:cNvSpPr>
-            <a:spLocks noGrp="1"/>
-          </p:cNvSpPr>
-          <p:nvPr>
-            <p:ph type="sldNum" sz="quarter" idx="4294967295"/>
-          </p:nvPr>
-        </p:nvSpPr>
-        <p:spPr>
-          <a:xfrm>
-            <a:off x="8229600" y="4754880"/>
-            <a:ext cx="457200" cy="274320"/>
-          </a:xfrm>
-          <a:prstGeom prst="rect">
-            <a:avLst/>
-          </a:prstGeom>
-          <a:extLst>
-            <a:ext uri="{C572A759-6A51-4108-AA02-DFA0A04FC94B}">
-              <ma14:wrappingTextBoxFlag xmlns:ma14="http://schemas.microsoft.com/office/mac/drawingml/2011/main" val="0"/>
-            </a:ext>
-          </a:extLst>
-        </p:spPr>
-        <p:txBody>
-          <a:bodyPr/>
-          <a:lstStyle>
-            <a:lvl1pPr>
-              <a:defRPr sz="1000">
-                <a:solidFill>
-                  <a:schemeClr val="accent5"/>
-                </a:solidFill>
-              </a:defRPr>
-            </a:lvl1pPr>
-          </a:lstStyle>
-          <a:p>
-            <a:pPr algn="r"/>
-            <a:fld id="{F7021451-1387-4CA6-816F-3879F97B5CBC}" type="slidenum">
-              <a:rPr b="0" lang="en-US"/>
-              <a:t>5</a:t>
             </a:fld>
             <a:endParaRPr lang="en-US"/>
           </a:p>
@@ -8619,7 +9044,7 @@
                 <a:ea typeface="Cambria" pitchFamily="34" charset="-122"/>
                 <a:cs typeface="Cambria" pitchFamily="34" charset="-120"/>
               </a:rPr>
-              <a:t>What testing found, and what changed</a:t>
+              <a:t>How it developed: build, test, refine, run live</a:t>
             </a:r>
             <a:endParaRPr lang="en-US" sz="3000" dirty="0"/>
           </a:p>
@@ -8627,14 +9052,40 @@
       </p:sp>
       <p:sp>
         <p:nvSpPr>
-          <p:cNvPr id="4" name="R1 badge"/>
+          <p:cNvPr id="4" name="Phase 1 card"/>
           <p:cNvSpPr/>
           <p:nvPr/>
         </p:nvSpPr>
         <p:spPr>
           <a:xfrm>
-            <a:off x="457200" y="1033272"/>
-            <a:ext cx="283464" cy="283464"/>
+            <a:off x="457200" y="960120"/>
+            <a:ext cx="1947672" cy="3017520"/>
+          </a:xfrm>
+          <a:prstGeom prst="roundRect">
+            <a:avLst>
+              <a:gd name="adj" fmla="val 3000"/>
+            </a:avLst>
+          </a:prstGeom>
+          <a:solidFill>
+            <a:schemeClr val="bg2"/>
+          </a:solidFill>
+          <a:ln w="12700">
+            <a:solidFill>
+              <a:schemeClr val="bg2"/>
+            </a:solidFill>
+          </a:ln>
+        </p:spPr>
+      </p:sp>
+      <p:sp>
+        <p:nvSpPr>
+          <p:cNvPr id="5" name="Phase 1 badge"/>
+          <p:cNvSpPr/>
+          <p:nvPr/>
+        </p:nvSpPr>
+        <p:spPr>
+          <a:xfrm>
+            <a:off x="521208" y="1033272"/>
+            <a:ext cx="310896" cy="310896"/>
           </a:xfrm>
           <a:prstGeom prst="ellipse">
             <a:avLst/>
@@ -8651,14 +9102,14 @@
       </p:sp>
       <p:sp>
         <p:nvSpPr>
-          <p:cNvPr id="5" name="R1 label"/>
+          <p:cNvPr id="6" name="Phase 1 number"/>
           <p:cNvSpPr txBox="1"/>
           <p:nvPr/>
         </p:nvSpPr>
         <p:spPr>
           <a:xfrm>
-            <a:off x="457200" y="1033272"/>
-            <a:ext cx="283464" cy="283464"/>
+            <a:off x="521208" y="1033272"/>
+            <a:ext cx="310896" cy="310896"/>
           </a:xfrm>
           <a:prstGeom prst="rect">
             <a:avLst/>
@@ -8670,29 +9121,33 @@
           <a:lstStyle/>
           <a:p>
             <a:pPr algn="ctr" indent="0" marL="0">
-              <a:buNone/>
-            </a:pPr>
-            <a:r>
-              <a:rPr lang="en-GB" sz="1000" b="1" dirty="0">
+              <a:spcAft>
+                <a:spcPts val="0"/>
+              </a:spcAft>
+              <a:buNone/>
+            </a:pPr>
+            <a:r>
+              <a:rPr lang="en-GB" sz="1200" b="1" dirty="0">
                 <a:solidFill>
                   <a:schemeClr val="bg1"/>
                 </a:solidFill>
               </a:rPr>
-              <a:t>R1</a:t>
-            </a:r>
-          </a:p>
-        </p:txBody>
-      </p:sp>
-      <p:sp>
-        <p:nvSpPr>
-          <p:cNvPr id="6" name="R1 problem"/>
+              <a:t xml:space="preserve">1</a:t>
+            </a:r>
+            <a:endParaRPr lang="en-GB" sz="1200" dirty="0"/>
+          </a:p>
+        </p:txBody>
+      </p:sp>
+      <p:sp>
+        <p:nvSpPr>
+          <p:cNvPr id="7" name="Phase 1 title"/>
           <p:cNvSpPr txBox="1"/>
           <p:nvPr/>
         </p:nvSpPr>
         <p:spPr>
           <a:xfrm>
-            <a:off x="868680" y="1005840"/>
-            <a:ext cx="3566160" cy="338328"/>
+            <a:off x="841248" y="1005840"/>
+            <a:ext cx="1527048" cy="384048"/>
           </a:xfrm>
           <a:prstGeom prst="rect">
             <a:avLst/>
@@ -8700,11 +9155,91 @@
           <a:noFill/>
         </p:spPr>
         <p:txBody>
-          <a:bodyPr wrap="square" rtlCol="0" anchor="ctr"/>
+          <a:bodyPr wrap="square" lIns="18288" tIns="18288" rIns="18288" bIns="18288" rtlCol="0" anchor="ctr"/>
           <a:lstStyle/>
           <a:p>
             <a:pPr indent="0" marL="0">
-              <a:buNone/>
+              <a:spcAft>
+                <a:spcPts val="0"/>
+              </a:spcAft>
+              <a:buNone/>
+            </a:pPr>
+            <a:r>
+              <a:rPr lang="en-GB" sz="1150" b="1" dirty="0">
+                <a:solidFill>
+                  <a:schemeClr val="tx2"/>
+                </a:solidFill>
+              </a:rPr>
+              <a:t xml:space="preserve">Design</a:t>
+            </a:r>
+            <a:endParaRPr lang="en-GB" sz="1150" dirty="0"/>
+          </a:p>
+        </p:txBody>
+      </p:sp>
+      <p:sp>
+        <p:nvSpPr>
+          <p:cNvPr id="8" name="Phase 1 subtitle"/>
+          <p:cNvSpPr txBox="1"/>
+          <p:nvPr/>
+        </p:nvSpPr>
+        <p:spPr>
+          <a:xfrm>
+            <a:off x="502920" y="1417320"/>
+            <a:ext cx="1856232" cy="274320"/>
+          </a:xfrm>
+          <a:prstGeom prst="rect">
+            <a:avLst/>
+          </a:prstGeom>
+          <a:noFill/>
+        </p:spPr>
+        <p:txBody>
+          <a:bodyPr wrap="square" lIns="45720" tIns="45720" rIns="45720" bIns="45720" rtlCol="0" anchor="t"/>
+          <a:lstStyle/>
+          <a:p>
+            <a:pPr indent="0" marL="0">
+              <a:spcAft>
+                <a:spcPts val="0"/>
+              </a:spcAft>
+              <a:buNone/>
+            </a:pPr>
+            <a:r>
+              <a:rPr lang="en-GB" sz="1050" i="1" dirty="0">
+                <a:solidFill>
+                  <a:schemeClr val="accent5"/>
+                </a:solidFill>
+              </a:rPr>
+              <a:t xml:space="preserve">Unit 6 group proposal</a:t>
+            </a:r>
+            <a:endParaRPr lang="en-GB" sz="1050" dirty="0"/>
+          </a:p>
+        </p:txBody>
+      </p:sp>
+      <p:sp>
+        <p:nvSpPr>
+          <p:cNvPr id="9" name="Phase 1 steps"/>
+          <p:cNvSpPr txBox="1"/>
+          <p:nvPr/>
+        </p:nvSpPr>
+        <p:spPr>
+          <a:xfrm>
+            <a:off x="502920" y="1691640"/>
+            <a:ext cx="1856232" cy="1691640"/>
+          </a:xfrm>
+          <a:prstGeom prst="rect">
+            <a:avLst/>
+          </a:prstGeom>
+          <a:noFill/>
+        </p:spPr>
+        <p:txBody>
+          <a:bodyPr wrap="square" lIns="45720" tIns="45720" rIns="45720" bIns="45720" rtlCol="0" anchor="t"/>
+          <a:lstStyle/>
+          <a:p>
+            <a:pPr marL="137160" indent="-137160">
+              <a:spcAft>
+                <a:spcPts val="500"/>
+              </a:spcAft>
+              <a:buFont typeface="Arial"/>
+              <a:buChar char="•"/>
             </a:pPr>
             <a:r>
               <a:rPr lang="en-GB" sz="1150" dirty="0">
@@ -8712,21 +9247,76 @@
                   <a:schemeClr val="tx1"/>
                 </a:solidFill>
               </a:rPr>
-              <a:t>"LLM-based" never matched "large language models"</a:t>
-            </a:r>
-          </a:p>
-        </p:txBody>
-      </p:sp>
-      <p:sp>
-        <p:nvSpPr>
-          <p:cNvPr id="7" name="R1 fix"/>
+              <a:t xml:space="preserve">LangGraph over CrewAI</a:t>
+            </a:r>
+            <a:endParaRPr lang="en-GB" sz="1150" dirty="0"/>
+          </a:p>
+          <a:p>
+            <a:pPr marL="137160" indent="-137160">
+              <a:spcAft>
+                <a:spcPts val="500"/>
+              </a:spcAft>
+              <a:buFont typeface="Arial"/>
+              <a:buChar char="•"/>
+            </a:pPr>
+            <a:r>
+              <a:rPr lang="en-GB" sz="1150" dirty="0">
+                <a:solidFill>
+                  <a:schemeClr val="tx1"/>
+                </a:solidFill>
+              </a:rPr>
+              <a:t xml:space="preserve">Qwen2.5-7B-Instruct</a:t>
+            </a:r>
+            <a:endParaRPr lang="en-GB" sz="1150" dirty="0"/>
+          </a:p>
+          <a:p>
+            <a:pPr marL="137160" indent="-137160">
+              <a:spcAft>
+                <a:spcPts val="500"/>
+              </a:spcAft>
+              <a:buFont typeface="Arial"/>
+              <a:buChar char="•"/>
+            </a:pPr>
+            <a:r>
+              <a:rPr lang="en-GB" sz="1150" dirty="0">
+                <a:solidFill>
+                  <a:schemeClr val="tx1"/>
+                </a:solidFill>
+              </a:rPr>
+              <a:t xml:space="preserve">Two literature sources</a:t>
+            </a:r>
+            <a:endParaRPr lang="en-GB" sz="1150" dirty="0"/>
+          </a:p>
+          <a:p>
+            <a:pPr marL="137160" indent="-137160">
+              <a:spcAft>
+                <a:spcPts val="500"/>
+              </a:spcAft>
+              <a:buFont typeface="Arial"/>
+              <a:buChar char="•"/>
+            </a:pPr>
+            <a:r>
+              <a:rPr lang="en-GB" sz="1150" dirty="0">
+                <a:solidFill>
+                  <a:schemeClr val="tx1"/>
+                </a:solidFill>
+              </a:rPr>
+              <a:t xml:space="preserve">Critic-driven re-planning</a:t>
+            </a:r>
+            <a:endParaRPr lang="en-GB" sz="1150" dirty="0"/>
+          </a:p>
+        </p:txBody>
+      </p:sp>
+      <p:sp>
+        <p:nvSpPr>
+          <p:cNvPr id="10" name="Phase 1 result"/>
           <p:cNvSpPr txBox="1"/>
           <p:nvPr/>
         </p:nvSpPr>
         <p:spPr>
           <a:xfrm>
-            <a:off x="4480560" y="1005840"/>
-            <a:ext cx="4206240" cy="338328"/>
+            <a:off x="502920" y="3429000"/>
+            <a:ext cx="1856232" cy="502920"/>
           </a:xfrm>
           <a:prstGeom prst="rect">
             <a:avLst/>
@@ -8734,33 +9324,87 @@
           <a:noFill/>
         </p:spPr>
         <p:txBody>
-          <a:bodyPr wrap="square" rtlCol="0" anchor="ctr"/>
+          <a:bodyPr wrap="square" lIns="45720" tIns="45720" rIns="45720" bIns="45720" rtlCol="0" anchor="ctr"/>
           <a:lstStyle/>
           <a:p>
             <a:pPr indent="0" marL="0">
-              <a:buNone/>
-            </a:pPr>
-            <a:r>
-              <a:rPr lang="en-GB" sz="1150" b="1" dirty="0">
+              <a:spcAft>
+                <a:spcPts val="0"/>
+              </a:spcAft>
+              <a:buNone/>
+            </a:pPr>
+            <a:r>
+              <a:rPr lang="en-GB" sz="1050" b="1" dirty="0">
                 <a:solidFill>
                   <a:schemeClr val="accent1"/>
                 </a:solidFill>
               </a:rPr>
-              <a:t>Synonym folding + stemming: 2 papers in 3 cycles became 10 in 1</a:t>
-            </a:r>
-          </a:p>
-        </p:txBody>
-      </p:sp>
-      <p:sp>
-        <p:nvSpPr>
-          <p:cNvPr id="8" name="R2 badge"/>
+              <a:t xml:space="preserve">Design agreed</a:t>
+            </a:r>
+            <a:endParaRPr lang="en-GB" sz="1050" dirty="0"/>
+          </a:p>
+        </p:txBody>
+      </p:sp>
+      <p:sp>
+        <p:nvSpPr>
+          <p:cNvPr id="11" name="Arrow 1"/>
           <p:cNvSpPr/>
           <p:nvPr/>
         </p:nvSpPr>
         <p:spPr>
           <a:xfrm>
-            <a:off x="457200" y="1371600"/>
-            <a:ext cx="283464" cy="283464"/>
+            <a:off x="2423160" y="2386584"/>
+            <a:ext cx="109728" cy="164592"/>
+          </a:xfrm>
+          <a:prstGeom prst="rightArrow">
+            <a:avLst/>
+          </a:prstGeom>
+          <a:solidFill>
+            <a:schemeClr val="accent5"/>
+          </a:solidFill>
+          <a:ln w="12700">
+            <a:solidFill>
+              <a:schemeClr val="accent5"/>
+            </a:solidFill>
+          </a:ln>
+        </p:spPr>
+      </p:sp>
+      <p:sp>
+        <p:nvSpPr>
+          <p:cNvPr id="12" name="Phase 2 card"/>
+          <p:cNvSpPr/>
+          <p:nvPr/>
+        </p:nvSpPr>
+        <p:spPr>
+          <a:xfrm>
+            <a:off x="2551176" y="960120"/>
+            <a:ext cx="1947672" cy="3017520"/>
+          </a:xfrm>
+          <a:prstGeom prst="roundRect">
+            <a:avLst>
+              <a:gd name="adj" fmla="val 3000"/>
+            </a:avLst>
+          </a:prstGeom>
+          <a:solidFill>
+            <a:schemeClr val="bg2"/>
+          </a:solidFill>
+          <a:ln w="12700">
+            <a:solidFill>
+              <a:schemeClr val="bg2"/>
+            </a:solidFill>
+          </a:ln>
+        </p:spPr>
+      </p:sp>
+      <p:sp>
+        <p:nvSpPr>
+          <p:cNvPr id="13" name="Phase 2 badge"/>
+          <p:cNvSpPr/>
+          <p:nvPr/>
+        </p:nvSpPr>
+        <p:spPr>
+          <a:xfrm>
+            <a:off x="2615184" y="1033272"/>
+            <a:ext cx="310896" cy="310896"/>
           </a:xfrm>
           <a:prstGeom prst="ellipse">
             <a:avLst/>
@@ -8777,14 +9421,14 @@
       </p:sp>
       <p:sp>
         <p:nvSpPr>
-          <p:cNvPr id="9" name="R2 label"/>
+          <p:cNvPr id="14" name="Phase 2 number"/>
           <p:cNvSpPr txBox="1"/>
           <p:nvPr/>
         </p:nvSpPr>
         <p:spPr>
           <a:xfrm>
-            <a:off x="457200" y="1371600"/>
-            <a:ext cx="283464" cy="283464"/>
+            <a:off x="2615184" y="1033272"/>
+            <a:ext cx="310896" cy="310896"/>
           </a:xfrm>
           <a:prstGeom prst="rect">
             <a:avLst/>
@@ -8796,29 +9440,33 @@
           <a:lstStyle/>
           <a:p>
             <a:pPr algn="ctr" indent="0" marL="0">
-              <a:buNone/>
-            </a:pPr>
-            <a:r>
-              <a:rPr lang="en-GB" sz="1000" b="1" dirty="0">
+              <a:spcAft>
+                <a:spcPts val="0"/>
+              </a:spcAft>
+              <a:buNone/>
+            </a:pPr>
+            <a:r>
+              <a:rPr lang="en-GB" sz="1200" b="1" dirty="0">
                 <a:solidFill>
                   <a:schemeClr val="bg1"/>
                 </a:solidFill>
               </a:rPr>
-              <a:t>R2</a:t>
-            </a:r>
-          </a:p>
-        </p:txBody>
-      </p:sp>
-      <p:sp>
-        <p:nvSpPr>
-          <p:cNvPr id="10" name="R2 problem"/>
+              <a:t xml:space="preserve">2</a:t>
+            </a:r>
+            <a:endParaRPr lang="en-GB" sz="1200" dirty="0"/>
+          </a:p>
+        </p:txBody>
+      </p:sp>
+      <p:sp>
+        <p:nvSpPr>
+          <p:cNvPr id="15" name="Phase 2 title"/>
           <p:cNvSpPr txBox="1"/>
           <p:nvPr/>
         </p:nvSpPr>
         <p:spPr>
           <a:xfrm>
-            <a:off x="868680" y="1344168"/>
-            <a:ext cx="3566160" cy="338328"/>
+            <a:off x="2935224" y="1005840"/>
+            <a:ext cx="1527048" cy="384048"/>
           </a:xfrm>
           <a:prstGeom prst="rect">
             <a:avLst/>
@@ -8826,11 +9474,91 @@
           <a:noFill/>
         </p:spPr>
         <p:txBody>
-          <a:bodyPr wrap="square" rtlCol="0" anchor="ctr"/>
+          <a:bodyPr wrap="square" lIns="18288" tIns="18288" rIns="18288" bIns="18288" rtlCol="0" anchor="ctr"/>
           <a:lstStyle/>
           <a:p>
             <a:pPr indent="0" marL="0">
-              <a:buNone/>
+              <a:spcAft>
+                <a:spcPts val="0"/>
+              </a:spcAft>
+              <a:buNone/>
+            </a:pPr>
+            <a:r>
+              <a:rPr lang="en-GB" sz="1150" b="1" dirty="0">
+                <a:solidFill>
+                  <a:schemeClr val="tx2"/>
+                </a:solidFill>
+              </a:rPr>
+              <a:t xml:space="preserve">Build offline-first</a:t>
+            </a:r>
+            <a:endParaRPr lang="en-GB" sz="1150" dirty="0"/>
+          </a:p>
+        </p:txBody>
+      </p:sp>
+      <p:sp>
+        <p:nvSpPr>
+          <p:cNvPr id="16" name="Phase 2 subtitle"/>
+          <p:cNvSpPr txBox="1"/>
+          <p:nvPr/>
+        </p:nvSpPr>
+        <p:spPr>
+          <a:xfrm>
+            <a:off x="2596896" y="1417320"/>
+            <a:ext cx="1856232" cy="274320"/>
+          </a:xfrm>
+          <a:prstGeom prst="rect">
+            <a:avLst/>
+          </a:prstGeom>
+          <a:noFill/>
+        </p:spPr>
+        <p:txBody>
+          <a:bodyPr wrap="square" lIns="45720" tIns="45720" rIns="45720" bIns="45720" rtlCol="0" anchor="t"/>
+          <a:lstStyle/>
+          <a:p>
+            <a:pPr indent="0" marL="0">
+              <a:spcAft>
+                <a:spcPts val="0"/>
+              </a:spcAft>
+              <a:buNone/>
+            </a:pPr>
+            <a:r>
+              <a:rPr lang="en-GB" sz="1050" i="1" dirty="0">
+                <a:solidFill>
+                  <a:schemeClr val="accent5"/>
+                </a:solidFill>
+              </a:rPr>
+              <a:t xml:space="preserve">Incremental commits</a:t>
+            </a:r>
+            <a:endParaRPr lang="en-GB" sz="1050" dirty="0"/>
+          </a:p>
+        </p:txBody>
+      </p:sp>
+      <p:sp>
+        <p:nvSpPr>
+          <p:cNvPr id="17" name="Phase 2 steps"/>
+          <p:cNvSpPr txBox="1"/>
+          <p:nvPr/>
+        </p:nvSpPr>
+        <p:spPr>
+          <a:xfrm>
+            <a:off x="2596896" y="1691640"/>
+            <a:ext cx="1856232" cy="1691640"/>
+          </a:xfrm>
+          <a:prstGeom prst="rect">
+            <a:avLst/>
+          </a:prstGeom>
+          <a:noFill/>
+        </p:spPr>
+        <p:txBody>
+          <a:bodyPr wrap="square" lIns="45720" tIns="45720" rIns="45720" bIns="45720" rtlCol="0" anchor="t"/>
+          <a:lstStyle/>
+          <a:p>
+            <a:pPr marL="137160" indent="-137160">
+              <a:spcAft>
+                <a:spcPts val="500"/>
+              </a:spcAft>
+              <a:buFont typeface="Arial"/>
+              <a:buChar char="•"/>
             </a:pPr>
             <a:r>
               <a:rPr lang="en-GB" sz="1150" dirty="0">
@@ -8838,21 +9566,94 @@
                   <a:schemeClr val="tx1"/>
                 </a:solidFill>
               </a:rPr>
-              <a:t>All-neutral evidence flagged as one-sided</a:t>
-            </a:r>
-          </a:p>
-        </p:txBody>
-      </p:sp>
-      <p:sp>
-        <p:nvSpPr>
-          <p:cNvPr id="11" name="R2 fix"/>
+              <a:t xml:space="preserve">Schemas and shared state</a:t>
+            </a:r>
+            <a:endParaRPr lang="en-GB" sz="1150" dirty="0"/>
+          </a:p>
+          <a:p>
+            <a:pPr marL="137160" indent="-137160">
+              <a:spcAft>
+                <a:spcPts val="500"/>
+              </a:spcAft>
+              <a:buFont typeface="Arial"/>
+              <a:buChar char="•"/>
+            </a:pPr>
+            <a:r>
+              <a:rPr lang="en-GB" sz="1150" dirty="0">
+                <a:solidFill>
+                  <a:schemeClr val="tx1"/>
+                </a:solidFill>
+              </a:rPr>
+              <a:t xml:space="preserve">Sources and LLM client</a:t>
+            </a:r>
+            <a:endParaRPr lang="en-GB" sz="1150" dirty="0"/>
+          </a:p>
+          <a:p>
+            <a:pPr marL="137160" indent="-137160">
+              <a:spcAft>
+                <a:spcPts val="500"/>
+              </a:spcAft>
+              <a:buFont typeface="Arial"/>
+              <a:buChar char="•"/>
+            </a:pPr>
+            <a:r>
+              <a:rPr lang="en-GB" sz="1150" dirty="0">
+                <a:solidFill>
+                  <a:schemeClr val="tx1"/>
+                </a:solidFill>
+              </a:rPr>
+              <a:t xml:space="preserve">Agents in a LangGraph graph</a:t>
+            </a:r>
+            <a:endParaRPr lang="en-GB" sz="1150" dirty="0"/>
+          </a:p>
+          <a:p>
+            <a:pPr marL="137160" indent="-137160">
+              <a:spcAft>
+                <a:spcPts val="500"/>
+              </a:spcAft>
+              <a:buFont typeface="Arial"/>
+              <a:buChar char="•"/>
+            </a:pPr>
+            <a:r>
+              <a:rPr lang="en-GB" sz="1150" dirty="0">
+                <a:solidFill>
+                  <a:schemeClr val="tx1"/>
+                </a:solidFill>
+              </a:rPr>
+              <a:t xml:space="preserve">Flask interface</a:t>
+            </a:r>
+            <a:endParaRPr lang="en-GB" sz="1150" dirty="0"/>
+          </a:p>
+          <a:p>
+            <a:pPr marL="137160" indent="-137160">
+              <a:spcAft>
+                <a:spcPts val="500"/>
+              </a:spcAft>
+              <a:buFont typeface="Arial"/>
+              <a:buChar char="•"/>
+            </a:pPr>
+            <a:r>
+              <a:rPr lang="en-GB" sz="1150" dirty="0">
+                <a:solidFill>
+                  <a:schemeClr val="tx1"/>
+                </a:solidFill>
+              </a:rPr>
+              <a:t xml:space="preserve">Tests and evidence</a:t>
+            </a:r>
+            <a:endParaRPr lang="en-GB" sz="1150" dirty="0"/>
+          </a:p>
+        </p:txBody>
+      </p:sp>
+      <p:sp>
+        <p:nvSpPr>
+          <p:cNvPr id="18" name="Phase 2 result"/>
           <p:cNvSpPr txBox="1"/>
           <p:nvPr/>
         </p:nvSpPr>
         <p:spPr>
           <a:xfrm>
-            <a:off x="4480560" y="1344168"/>
-            <a:ext cx="4206240" cy="338328"/>
+            <a:off x="2596896" y="3429000"/>
+            <a:ext cx="1856232" cy="502920"/>
           </a:xfrm>
           <a:prstGeom prst="rect">
             <a:avLst/>
@@ -8860,33 +9661,87 @@
           <a:noFill/>
         </p:spPr>
         <p:txBody>
-          <a:bodyPr wrap="square" rtlCol="0" anchor="ctr"/>
+          <a:bodyPr wrap="square" lIns="45720" tIns="45720" rIns="45720" bIns="45720" rtlCol="0" anchor="ctr"/>
           <a:lstStyle/>
           <a:p>
             <a:pPr indent="0" marL="0">
-              <a:buNone/>
-            </a:pPr>
-            <a:r>
-              <a:rPr lang="en-GB" sz="1150" b="1" dirty="0">
+              <a:spcAft>
+                <a:spcPts val="0"/>
+              </a:spcAft>
+              <a:buNone/>
+            </a:pPr>
+            <a:r>
+              <a:rPr lang="en-GB" sz="1050" b="1" dirty="0">
                 <a:solidFill>
                   <a:schemeClr val="accent1"/>
                 </a:solidFill>
               </a:rPr>
-              <a:t>Only uniform supports/opposes counts as bias</a:t>
-            </a:r>
-          </a:p>
-        </p:txBody>
-      </p:sp>
-      <p:sp>
-        <p:nvSpPr>
-          <p:cNvPr id="12" name="R3 badge"/>
+              <a:t xml:space="preserve">Runs end to end</a:t>
+            </a:r>
+            <a:endParaRPr lang="en-GB" sz="1050" dirty="0"/>
+          </a:p>
+        </p:txBody>
+      </p:sp>
+      <p:sp>
+        <p:nvSpPr>
+          <p:cNvPr id="19" name="Arrow 2"/>
           <p:cNvSpPr/>
           <p:nvPr/>
         </p:nvSpPr>
         <p:spPr>
           <a:xfrm>
-            <a:off x="457200" y="1709928"/>
-            <a:ext cx="283464" cy="283464"/>
+            <a:off x="4517136" y="2386584"/>
+            <a:ext cx="109728" cy="164592"/>
+          </a:xfrm>
+          <a:prstGeom prst="rightArrow">
+            <a:avLst/>
+          </a:prstGeom>
+          <a:solidFill>
+            <a:schemeClr val="accent5"/>
+          </a:solidFill>
+          <a:ln w="12700">
+            <a:solidFill>
+              <a:schemeClr val="accent5"/>
+            </a:solidFill>
+          </a:ln>
+        </p:spPr>
+      </p:sp>
+      <p:sp>
+        <p:nvSpPr>
+          <p:cNvPr id="20" name="Phase 3 card"/>
+          <p:cNvSpPr/>
+          <p:nvPr/>
+        </p:nvSpPr>
+        <p:spPr>
+          <a:xfrm>
+            <a:off x="4645152" y="960120"/>
+            <a:ext cx="1947672" cy="3017520"/>
+          </a:xfrm>
+          <a:prstGeom prst="roundRect">
+            <a:avLst>
+              <a:gd name="adj" fmla="val 3000"/>
+            </a:avLst>
+          </a:prstGeom>
+          <a:solidFill>
+            <a:schemeClr val="bg2"/>
+          </a:solidFill>
+          <a:ln w="12700">
+            <a:solidFill>
+              <a:schemeClr val="bg2"/>
+            </a:solidFill>
+          </a:ln>
+        </p:spPr>
+      </p:sp>
+      <p:sp>
+        <p:nvSpPr>
+          <p:cNvPr id="21" name="Phase 3 badge"/>
+          <p:cNvSpPr/>
+          <p:nvPr/>
+        </p:nvSpPr>
+        <p:spPr>
+          <a:xfrm>
+            <a:off x="4709160" y="1033272"/>
+            <a:ext cx="310896" cy="310896"/>
           </a:xfrm>
           <a:prstGeom prst="ellipse">
             <a:avLst/>
@@ -8903,14 +9758,14 @@
       </p:sp>
       <p:sp>
         <p:nvSpPr>
-          <p:cNvPr id="13" name="R3 label"/>
+          <p:cNvPr id="22" name="Phase 3 number"/>
           <p:cNvSpPr txBox="1"/>
           <p:nvPr/>
         </p:nvSpPr>
         <p:spPr>
           <a:xfrm>
-            <a:off x="457200" y="1709928"/>
-            <a:ext cx="283464" cy="283464"/>
+            <a:off x="4709160" y="1033272"/>
+            <a:ext cx="310896" cy="310896"/>
           </a:xfrm>
           <a:prstGeom prst="rect">
             <a:avLst/>
@@ -8922,29 +9777,33 @@
           <a:lstStyle/>
           <a:p>
             <a:pPr algn="ctr" indent="0" marL="0">
-              <a:buNone/>
-            </a:pPr>
-            <a:r>
-              <a:rPr lang="en-GB" sz="1000" b="1" dirty="0">
+              <a:spcAft>
+                <a:spcPts val="0"/>
+              </a:spcAft>
+              <a:buNone/>
+            </a:pPr>
+            <a:r>
+              <a:rPr lang="en-GB" sz="1200" b="1" dirty="0">
                 <a:solidFill>
                   <a:schemeClr val="bg1"/>
                 </a:solidFill>
               </a:rPr>
-              <a:t>R3</a:t>
-            </a:r>
-          </a:p>
-        </p:txBody>
-      </p:sp>
-      <p:sp>
-        <p:nvSpPr>
-          <p:cNvPr id="14" name="R3 problem"/>
+              <a:t xml:space="preserve">3</a:t>
+            </a:r>
+            <a:endParaRPr lang="en-GB" sz="1200" dirty="0"/>
+          </a:p>
+        </p:txBody>
+      </p:sp>
+      <p:sp>
+        <p:nvSpPr>
+          <p:cNvPr id="23" name="Phase 3 title"/>
           <p:cNvSpPr txBox="1"/>
           <p:nvPr/>
         </p:nvSpPr>
         <p:spPr>
           <a:xfrm>
-            <a:off x="868680" y="1682496"/>
-            <a:ext cx="3566160" cy="338328"/>
+            <a:off x="5029200" y="1005840"/>
+            <a:ext cx="1527048" cy="384048"/>
           </a:xfrm>
           <a:prstGeom prst="rect">
             <a:avLst/>
@@ -8952,11 +9811,91 @@
           <a:noFill/>
         </p:spPr>
         <p:txBody>
-          <a:bodyPr wrap="square" rtlCol="0" anchor="ctr"/>
+          <a:bodyPr wrap="square" lIns="18288" tIns="18288" rIns="18288" bIns="18288" rtlCol="0" anchor="ctr"/>
           <a:lstStyle/>
           <a:p>
             <a:pPr indent="0" marL="0">
-              <a:buNone/>
+              <a:spcAft>
+                <a:spcPts val="0"/>
+              </a:spcAft>
+              <a:buNone/>
+            </a:pPr>
+            <a:r>
+              <a:rPr lang="en-GB" sz="1150" b="1" dirty="0">
+                <a:solidFill>
+                  <a:schemeClr val="tx2"/>
+                </a:solidFill>
+              </a:rPr>
+              <a:t xml:space="preserve">Test and refine</a:t>
+            </a:r>
+            <a:endParaRPr lang="en-GB" sz="1150" dirty="0"/>
+          </a:p>
+        </p:txBody>
+      </p:sp>
+      <p:sp>
+        <p:nvSpPr>
+          <p:cNvPr id="24" name="Phase 3 subtitle"/>
+          <p:cNvSpPr txBox="1"/>
+          <p:nvPr/>
+        </p:nvSpPr>
+        <p:spPr>
+          <a:xfrm>
+            <a:off x="4690872" y="1417320"/>
+            <a:ext cx="1856232" cy="274320"/>
+          </a:xfrm>
+          <a:prstGeom prst="rect">
+            <a:avLst/>
+          </a:prstGeom>
+          <a:noFill/>
+        </p:spPr>
+        <p:txBody>
+          <a:bodyPr wrap="square" lIns="45720" tIns="45720" rIns="45720" bIns="45720" rtlCol="0" anchor="t"/>
+          <a:lstStyle/>
+          <a:p>
+            <a:pPr indent="0" marL="0">
+              <a:spcAft>
+                <a:spcPts val="0"/>
+              </a:spcAft>
+              <a:buNone/>
+            </a:pPr>
+            <a:r>
+              <a:rPr lang="en-GB" sz="1050" i="1" dirty="0">
+                <a:solidFill>
+                  <a:schemeClr val="accent5"/>
+                </a:solidFill>
+              </a:rPr>
+              <a:t xml:space="preserve">R1 to R5</a:t>
+            </a:r>
+            <a:endParaRPr lang="en-GB" sz="1050" dirty="0"/>
+          </a:p>
+        </p:txBody>
+      </p:sp>
+      <p:sp>
+        <p:nvSpPr>
+          <p:cNvPr id="25" name="Phase 3 steps"/>
+          <p:cNvSpPr txBox="1"/>
+          <p:nvPr/>
+        </p:nvSpPr>
+        <p:spPr>
+          <a:xfrm>
+            <a:off x="4690872" y="1691640"/>
+            <a:ext cx="1856232" cy="1691640"/>
+          </a:xfrm>
+          <a:prstGeom prst="rect">
+            <a:avLst/>
+          </a:prstGeom>
+          <a:noFill/>
+        </p:spPr>
+        <p:txBody>
+          <a:bodyPr wrap="square" lIns="45720" tIns="45720" rIns="45720" bIns="45720" rtlCol="0" anchor="t"/>
+          <a:lstStyle/>
+          <a:p>
+            <a:pPr marL="137160" indent="-137160">
+              <a:spcAft>
+                <a:spcPts val="500"/>
+              </a:spcAft>
+              <a:buFont typeface="Arial"/>
+              <a:buChar char="•"/>
             </a:pPr>
             <a:r>
               <a:rPr lang="en-GB" sz="1150" dirty="0">
@@ -8964,21 +9903,94 @@
                   <a:schemeClr val="tx1"/>
                 </a:solidFill>
               </a:rPr>
-              <a:t>Unclosed SQLite connections</a:t>
-            </a:r>
-          </a:p>
-        </p:txBody>
-      </p:sp>
-      <p:sp>
-        <p:nvSpPr>
-          <p:cNvPr id="15" name="R3 fix"/>
+              <a:t xml:space="preserve">R1 synonyms: 2 to 10 papers</a:t>
+            </a:r>
+            <a:endParaRPr lang="en-GB" sz="1150" dirty="0"/>
+          </a:p>
+          <a:p>
+            <a:pPr marL="137160" indent="-137160">
+              <a:spcAft>
+                <a:spcPts val="500"/>
+              </a:spcAft>
+              <a:buFont typeface="Arial"/>
+              <a:buChar char="•"/>
+            </a:pPr>
+            <a:r>
+              <a:rPr lang="en-GB" sz="1150" dirty="0">
+                <a:solidFill>
+                  <a:schemeClr val="tx1"/>
+                </a:solidFill>
+              </a:rPr>
+              <a:t xml:space="preserve">R2 neutral is not bias</a:t>
+            </a:r>
+            <a:endParaRPr lang="en-GB" sz="1150" dirty="0"/>
+          </a:p>
+          <a:p>
+            <a:pPr marL="137160" indent="-137160">
+              <a:spcAft>
+                <a:spcPts val="500"/>
+              </a:spcAft>
+              <a:buFont typeface="Arial"/>
+              <a:buChar char="•"/>
+            </a:pPr>
+            <a:r>
+              <a:rPr lang="en-GB" sz="1150" dirty="0">
+                <a:solidFill>
+                  <a:schemeClr val="tx1"/>
+                </a:solidFill>
+              </a:rPr>
+              <a:t xml:space="preserve">R3 SQLite leaks closed</a:t>
+            </a:r>
+            <a:endParaRPr lang="en-GB" sz="1150" dirty="0"/>
+          </a:p>
+          <a:p>
+            <a:pPr marL="137160" indent="-137160">
+              <a:spcAft>
+                <a:spcPts val="500"/>
+              </a:spcAft>
+              <a:buFont typeface="Arial"/>
+              <a:buChar char="•"/>
+            </a:pPr>
+            <a:r>
+              <a:rPr lang="en-GB" sz="1150" dirty="0">
+                <a:solidFill>
+                  <a:schemeClr val="tx1"/>
+                </a:solidFill>
+              </a:rPr>
+              <a:t xml:space="preserve">R4 no retry on 404</a:t>
+            </a:r>
+            <a:endParaRPr lang="en-GB" sz="1150" dirty="0"/>
+          </a:p>
+          <a:p>
+            <a:pPr marL="137160" indent="-137160">
+              <a:spcAft>
+                <a:spcPts val="500"/>
+              </a:spcAft>
+              <a:buFont typeface="Arial"/>
+              <a:buChar char="•"/>
+            </a:pPr>
+            <a:r>
+              <a:rPr lang="en-GB" sz="1150" dirty="0">
+                <a:solidFill>
+                  <a:schemeClr val="tx1"/>
+                </a:solidFill>
+              </a:rPr>
+              <a:t xml:space="preserve">R5 Harvard order</a:t>
+            </a:r>
+            <a:endParaRPr lang="en-GB" sz="1150" dirty="0"/>
+          </a:p>
+        </p:txBody>
+      </p:sp>
+      <p:sp>
+        <p:nvSpPr>
+          <p:cNvPr id="26" name="Phase 3 result"/>
           <p:cNvSpPr txBox="1"/>
           <p:nvPr/>
         </p:nvSpPr>
         <p:spPr>
           <a:xfrm>
-            <a:off x="4480560" y="1682496"/>
-            <a:ext cx="4206240" cy="338328"/>
+            <a:off x="4690872" y="3429000"/>
+            <a:ext cx="1856232" cy="502920"/>
           </a:xfrm>
           <a:prstGeom prst="rect">
             <a:avLst/>
@@ -8986,285 +9998,87 @@
           <a:noFill/>
         </p:spPr>
         <p:txBody>
-          <a:bodyPr wrap="square" rtlCol="0" anchor="ctr"/>
+          <a:bodyPr wrap="square" lIns="45720" tIns="45720" rIns="45720" bIns="45720" rtlCol="0" anchor="ctr"/>
           <a:lstStyle/>
           <a:p>
             <a:pPr indent="0" marL="0">
-              <a:buNone/>
-            </a:pPr>
-            <a:r>
-              <a:rPr lang="en-GB" sz="1150" b="1" dirty="0">
+              <a:spcAft>
+                <a:spcPts val="0"/>
+              </a:spcAft>
+              <a:buNone/>
+            </a:pPr>
+            <a:r>
+              <a:rPr lang="en-GB" sz="1050" b="1" dirty="0">
                 <a:solidFill>
                   <a:schemeClr val="accent1"/>
                 </a:solidFill>
               </a:rPr>
-              <a:t>Shared Storage; suite now fails on any leak</a:t>
-            </a:r>
-          </a:p>
-        </p:txBody>
-      </p:sp>
-      <p:sp>
-        <p:nvSpPr>
-          <p:cNvPr id="16" name="R4 badge"/>
+              <a:t xml:space="preserve">76 tests, 97% coverage</a:t>
+            </a:r>
+            <a:endParaRPr lang="en-GB" sz="1050" dirty="0"/>
+          </a:p>
+        </p:txBody>
+      </p:sp>
+      <p:sp>
+        <p:nvSpPr>
+          <p:cNvPr id="27" name="Arrow 3"/>
           <p:cNvSpPr/>
           <p:nvPr/>
         </p:nvSpPr>
         <p:spPr>
           <a:xfrm>
-            <a:off x="457200" y="2048256"/>
-            <a:ext cx="283464" cy="283464"/>
-          </a:xfrm>
-          <a:prstGeom prst="ellipse">
+            <a:off x="6611112" y="2386584"/>
+            <a:ext cx="109728" cy="164592"/>
+          </a:xfrm>
+          <a:prstGeom prst="rightArrow">
             <a:avLst/>
           </a:prstGeom>
           <a:solidFill>
-            <a:schemeClr val="accent2"/>
+            <a:schemeClr val="accent5"/>
           </a:solidFill>
           <a:ln w="12700">
             <a:solidFill>
-              <a:schemeClr val="accent2"/>
+              <a:schemeClr val="accent5"/>
             </a:solidFill>
           </a:ln>
         </p:spPr>
       </p:sp>
       <p:sp>
         <p:nvSpPr>
-          <p:cNvPr id="17" name="R4 label"/>
-          <p:cNvSpPr txBox="1"/>
-          <p:nvPr/>
-        </p:nvSpPr>
-        <p:spPr>
-          <a:xfrm>
-            <a:off x="457200" y="2048256"/>
-            <a:ext cx="283464" cy="283464"/>
-          </a:xfrm>
-          <a:prstGeom prst="rect">
-            <a:avLst/>
-          </a:prstGeom>
-          <a:noFill/>
-        </p:spPr>
-        <p:txBody>
-          <a:bodyPr wrap="square" lIns="0" tIns="0" rIns="0" bIns="0" rtlCol="0" anchor="ctr"/>
-          <a:lstStyle/>
-          <a:p>
-            <a:pPr algn="ctr" indent="0" marL="0">
-              <a:buNone/>
-            </a:pPr>
-            <a:r>
-              <a:rPr lang="en-GB" sz="1000" b="1" dirty="0">
-                <a:solidFill>
-                  <a:schemeClr val="bg1"/>
-                </a:solidFill>
-              </a:rPr>
-              <a:t>R4</a:t>
-            </a:r>
-          </a:p>
-        </p:txBody>
-      </p:sp>
-      <p:sp>
-        <p:nvSpPr>
-          <p:cNvPr id="18" name="R4 problem"/>
-          <p:cNvSpPr txBox="1"/>
-          <p:nvPr/>
-        </p:nvSpPr>
-        <p:spPr>
-          <a:xfrm>
-            <a:off x="868680" y="2020824"/>
-            <a:ext cx="3566160" cy="338328"/>
-          </a:xfrm>
-          <a:prstGeom prst="rect">
-            <a:avLst/>
-          </a:prstGeom>
-          <a:noFill/>
-        </p:spPr>
-        <p:txBody>
-          <a:bodyPr wrap="square" rtlCol="0" anchor="ctr"/>
-          <a:lstStyle/>
-          <a:p>
-            <a:pPr indent="0" marL="0">
-              <a:buNone/>
-            </a:pPr>
-            <a:r>
-              <a:rPr lang="en-GB" sz="1150" dirty="0">
-                <a:solidFill>
-                  <a:schemeClr val="tx1"/>
-                </a:solidFill>
-              </a:rPr>
-              <a:t>HTTP 404 retried like a rate limit</a:t>
-            </a:r>
-          </a:p>
-        </p:txBody>
-      </p:sp>
-      <p:sp>
-        <p:nvSpPr>
-          <p:cNvPr id="19" name="R4 fix"/>
-          <p:cNvSpPr txBox="1"/>
-          <p:nvPr/>
-        </p:nvSpPr>
-        <p:spPr>
-          <a:xfrm>
-            <a:off x="4480560" y="2020824"/>
-            <a:ext cx="4206240" cy="338328"/>
-          </a:xfrm>
-          <a:prstGeom prst="rect">
-            <a:avLst/>
-          </a:prstGeom>
-          <a:noFill/>
-        </p:spPr>
-        <p:txBody>
-          <a:bodyPr wrap="square" rtlCol="0" anchor="ctr"/>
-          <a:lstStyle/>
-          <a:p>
-            <a:pPr indent="0" marL="0">
-              <a:buNone/>
-            </a:pPr>
-            <a:r>
-              <a:rPr lang="en-GB" sz="1150" b="1" dirty="0">
-                <a:solidFill>
-                  <a:schemeClr val="accent1"/>
-                </a:solidFill>
-              </a:rPr>
-              <a:t>Retry only timeouts, 429 and 5xx</a:t>
-            </a:r>
-          </a:p>
-        </p:txBody>
-      </p:sp>
-      <p:sp>
-        <p:nvSpPr>
-          <p:cNvPr id="20" name="R5 badge"/>
+          <p:cNvPr id="28" name="Phase 4 card"/>
           <p:cNvSpPr/>
           <p:nvPr/>
         </p:nvSpPr>
         <p:spPr>
           <a:xfrm>
-            <a:off x="457200" y="2386584"/>
-            <a:ext cx="283464" cy="283464"/>
-          </a:xfrm>
-          <a:prstGeom prst="ellipse">
-            <a:avLst/>
+            <a:off x="6739128" y="960120"/>
+            <a:ext cx="1947672" cy="3017520"/>
+          </a:xfrm>
+          <a:prstGeom prst="roundRect">
+            <a:avLst>
+              <a:gd name="adj" fmla="val 3000"/>
+            </a:avLst>
           </a:prstGeom>
           <a:solidFill>
-            <a:schemeClr val="accent2"/>
+            <a:schemeClr val="bg2"/>
           </a:solidFill>
           <a:ln w="12700">
             <a:solidFill>
-              <a:schemeClr val="accent2"/>
+              <a:schemeClr val="bg2"/>
             </a:solidFill>
           </a:ln>
         </p:spPr>
       </p:sp>
       <p:sp>
         <p:nvSpPr>
-          <p:cNvPr id="21" name="R5 label"/>
-          <p:cNvSpPr txBox="1"/>
-          <p:nvPr/>
-        </p:nvSpPr>
-        <p:spPr>
-          <a:xfrm>
-            <a:off x="457200" y="2386584"/>
-            <a:ext cx="283464" cy="283464"/>
-          </a:xfrm>
-          <a:prstGeom prst="rect">
-            <a:avLst/>
-          </a:prstGeom>
-          <a:noFill/>
-        </p:spPr>
-        <p:txBody>
-          <a:bodyPr wrap="square" lIns="0" tIns="0" rIns="0" bIns="0" rtlCol="0" anchor="ctr"/>
-          <a:lstStyle/>
-          <a:p>
-            <a:pPr algn="ctr" indent="0" marL="0">
-              <a:buNone/>
-            </a:pPr>
-            <a:r>
-              <a:rPr lang="en-GB" sz="1000" b="1" dirty="0">
-                <a:solidFill>
-                  <a:schemeClr val="bg1"/>
-                </a:solidFill>
-              </a:rPr>
-              <a:t>R5</a:t>
-            </a:r>
-          </a:p>
-        </p:txBody>
-      </p:sp>
-      <p:sp>
-        <p:nvSpPr>
-          <p:cNvPr id="22" name="R5 problem"/>
-          <p:cNvSpPr txBox="1"/>
-          <p:nvPr/>
-        </p:nvSpPr>
-        <p:spPr>
-          <a:xfrm>
-            <a:off x="868680" y="2359152"/>
-            <a:ext cx="3566160" cy="338328"/>
-          </a:xfrm>
-          <a:prstGeom prst="rect">
-            <a:avLst/>
-          </a:prstGeom>
-          <a:noFill/>
-        </p:spPr>
-        <p:txBody>
-          <a:bodyPr wrap="square" rtlCol="0" anchor="ctr"/>
-          <a:lstStyle/>
-          <a:p>
-            <a:pPr indent="0" marL="0">
-              <a:buNone/>
-            </a:pPr>
-            <a:r>
-              <a:rPr lang="en-GB" sz="1150" dirty="0">
-                <a:solidFill>
-                  <a:schemeClr val="tx1"/>
-                </a:solidFill>
-              </a:rPr>
-              <a:t>References ordered by title</a:t>
-            </a:r>
-          </a:p>
-        </p:txBody>
-      </p:sp>
-      <p:sp>
-        <p:nvSpPr>
-          <p:cNvPr id="23" name="R5 fix"/>
-          <p:cNvSpPr txBox="1"/>
-          <p:nvPr/>
-        </p:nvSpPr>
-        <p:spPr>
-          <a:xfrm>
-            <a:off x="4480560" y="2359152"/>
-            <a:ext cx="4206240" cy="338328"/>
-          </a:xfrm>
-          <a:prstGeom prst="rect">
-            <a:avLst/>
-          </a:prstGeom>
-          <a:noFill/>
-        </p:spPr>
-        <p:txBody>
-          <a:bodyPr wrap="square" rtlCol="0" anchor="ctr"/>
-          <a:lstStyle/>
-          <a:p>
-            <a:pPr indent="0" marL="0">
-              <a:buNone/>
-            </a:pPr>
-            <a:r>
-              <a:rPr lang="en-GB" sz="1150" b="1" dirty="0">
-                <a:solidFill>
-                  <a:schemeClr val="accent1"/>
-                </a:solidFill>
-              </a:rPr>
-              <a:t>Alphabetical by first author, per Harvard</a:t>
-            </a:r>
-          </a:p>
-        </p:txBody>
-      </p:sp>
-      <p:sp>
-        <p:nvSpPr>
-          <p:cNvPr id="24" name="R6 badge"/>
+          <p:cNvPr id="29" name="Phase 4 badge"/>
           <p:cNvSpPr/>
           <p:nvPr/>
         </p:nvSpPr>
         <p:spPr>
           <a:xfrm>
-            <a:off x="457200" y="2724912"/>
-            <a:ext cx="283464" cy="283464"/>
+            <a:off x="6803136" y="1033272"/>
+            <a:ext cx="310896" cy="310896"/>
           </a:xfrm>
           <a:prstGeom prst="ellipse">
             <a:avLst/>
@@ -9281,14 +10095,14 @@
       </p:sp>
       <p:sp>
         <p:nvSpPr>
-          <p:cNvPr id="25" name="R6 label"/>
+          <p:cNvPr id="30" name="Phase 4 number"/>
           <p:cNvSpPr txBox="1"/>
           <p:nvPr/>
         </p:nvSpPr>
         <p:spPr>
           <a:xfrm>
-            <a:off x="457200" y="2724912"/>
-            <a:ext cx="283464" cy="283464"/>
+            <a:off x="6803136" y="1033272"/>
+            <a:ext cx="310896" cy="310896"/>
           </a:xfrm>
           <a:prstGeom prst="rect">
             <a:avLst/>
@@ -9300,29 +10114,33 @@
           <a:lstStyle/>
           <a:p>
             <a:pPr algn="ctr" indent="0" marL="0">
-              <a:buNone/>
-            </a:pPr>
-            <a:r>
-              <a:rPr lang="en-GB" sz="1000" b="1" dirty="0">
+              <a:spcAft>
+                <a:spcPts val="0"/>
+              </a:spcAft>
+              <a:buNone/>
+            </a:pPr>
+            <a:r>
+              <a:rPr lang="en-GB" sz="1200" b="1" dirty="0">
                 <a:solidFill>
                   <a:schemeClr val="bg1"/>
                 </a:solidFill>
               </a:rPr>
-              <a:t>R6</a:t>
-            </a:r>
-          </a:p>
-        </p:txBody>
-      </p:sp>
-      <p:sp>
-        <p:nvSpPr>
-          <p:cNvPr id="26" name="R6 problem"/>
+              <a:t xml:space="preserve">4</a:t>
+            </a:r>
+            <a:endParaRPr lang="en-GB" sz="1200" dirty="0"/>
+          </a:p>
+        </p:txBody>
+      </p:sp>
+      <p:sp>
+        <p:nvSpPr>
+          <p:cNvPr id="31" name="Phase 4 title"/>
           <p:cNvSpPr txBox="1"/>
           <p:nvPr/>
         </p:nvSpPr>
         <p:spPr>
           <a:xfrm>
-            <a:off x="868680" y="2697480"/>
-            <a:ext cx="3566160" cy="338328"/>
+            <a:off x="7123176" y="1005840"/>
+            <a:ext cx="1527048" cy="384048"/>
           </a:xfrm>
           <a:prstGeom prst="rect">
             <a:avLst/>
@@ -9330,11 +10148,91 @@
           <a:noFill/>
         </p:spPr>
         <p:txBody>
-          <a:bodyPr wrap="square" rtlCol="0" anchor="ctr"/>
+          <a:bodyPr wrap="square" lIns="18288" tIns="18288" rIns="18288" bIns="18288" rtlCol="0" anchor="ctr"/>
           <a:lstStyle/>
           <a:p>
             <a:pPr indent="0" marL="0">
-              <a:buNone/>
+              <a:spcAft>
+                <a:spcPts val="0"/>
+              </a:spcAft>
+              <a:buNone/>
+            </a:pPr>
+            <a:r>
+              <a:rPr lang="en-GB" sz="1150" b="1" dirty="0">
+                <a:solidFill>
+                  <a:schemeClr val="tx2"/>
+                </a:solidFill>
+              </a:rPr>
+              <a:t xml:space="preserve">Run live on Windows</a:t>
+            </a:r>
+            <a:endParaRPr lang="en-GB" sz="1150" dirty="0"/>
+          </a:p>
+        </p:txBody>
+      </p:sp>
+      <p:sp>
+        <p:nvSpPr>
+          <p:cNvPr id="32" name="Phase 4 subtitle"/>
+          <p:cNvSpPr txBox="1"/>
+          <p:nvPr/>
+        </p:nvSpPr>
+        <p:spPr>
+          <a:xfrm>
+            <a:off x="6784848" y="1417320"/>
+            <a:ext cx="1856232" cy="274320"/>
+          </a:xfrm>
+          <a:prstGeom prst="rect">
+            <a:avLst/>
+          </a:prstGeom>
+          <a:noFill/>
+        </p:spPr>
+        <p:txBody>
+          <a:bodyPr wrap="square" lIns="45720" tIns="45720" rIns="45720" bIns="45720" rtlCol="0" anchor="t"/>
+          <a:lstStyle/>
+          <a:p>
+            <a:pPr indent="0" marL="0">
+              <a:spcAft>
+                <a:spcPts val="0"/>
+              </a:spcAft>
+              <a:buNone/>
+            </a:pPr>
+            <a:r>
+              <a:rPr lang="en-GB" sz="1050" i="1" dirty="0">
+                <a:solidFill>
+                  <a:schemeClr val="accent5"/>
+                </a:solidFill>
+              </a:rPr>
+              <a:t xml:space="preserve">R6 to R9, via pull requests</a:t>
+            </a:r>
+            <a:endParaRPr lang="en-GB" sz="1050" dirty="0"/>
+          </a:p>
+        </p:txBody>
+      </p:sp>
+      <p:sp>
+        <p:nvSpPr>
+          <p:cNvPr id="33" name="Phase 4 steps"/>
+          <p:cNvSpPr txBox="1"/>
+          <p:nvPr/>
+        </p:nvSpPr>
+        <p:spPr>
+          <a:xfrm>
+            <a:off x="6784848" y="1691640"/>
+            <a:ext cx="1856232" cy="1691640"/>
+          </a:xfrm>
+          <a:prstGeom prst="rect">
+            <a:avLst/>
+          </a:prstGeom>
+          <a:noFill/>
+        </p:spPr>
+        <p:txBody>
+          <a:bodyPr wrap="square" lIns="45720" tIns="45720" rIns="45720" bIns="45720" rtlCol="0" anchor="t"/>
+          <a:lstStyle/>
+          <a:p>
+            <a:pPr marL="137160" indent="-137160">
+              <a:spcAft>
+                <a:spcPts val="500"/>
+              </a:spcAft>
+              <a:buFont typeface="Arial"/>
+              <a:buChar char="•"/>
             </a:pPr>
             <a:r>
               <a:rPr lang="en-GB" sz="1150" dirty="0">
@@ -9342,21 +10240,76 @@
                   <a:schemeClr val="tx1"/>
                 </a:solidFill>
               </a:rPr>
-              <a:t>Live: hosted Qwen withdrawn, credit used up (400/402)</a:t>
-            </a:r>
-          </a:p>
-        </p:txBody>
-      </p:sp>
-      <p:sp>
-        <p:nvSpPr>
-          <p:cNvPr id="27" name="R6 fix"/>
+              <a:t xml:space="preserve">R6 Qwen local via Ollama</a:t>
+            </a:r>
+            <a:endParaRPr lang="en-GB" sz="1150" dirty="0"/>
+          </a:p>
+          <a:p>
+            <a:pPr marL="137160" indent="-137160">
+              <a:spcAft>
+                <a:spcPts val="500"/>
+              </a:spcAft>
+              <a:buFont typeface="Arial"/>
+              <a:buChar char="•"/>
+            </a:pPr>
+            <a:r>
+              <a:rPr lang="en-GB" sz="1150" dirty="0">
+                <a:solidFill>
+                  <a:schemeClr val="tx1"/>
+                </a:solidFill>
+              </a:rPr>
+              <a:t xml:space="preserve">R7 longer 429 back-off</a:t>
+            </a:r>
+            <a:endParaRPr lang="en-GB" sz="1150" dirty="0"/>
+          </a:p>
+          <a:p>
+            <a:pPr marL="137160" indent="-137160">
+              <a:spcAft>
+                <a:spcPts val="500"/>
+              </a:spcAft>
+              <a:buFont typeface="Arial"/>
+              <a:buChar char="•"/>
+            </a:pPr>
+            <a:r>
+              <a:rPr lang="en-GB" sz="1150" dirty="0">
+                <a:solidFill>
+                  <a:schemeClr val="tx1"/>
+                </a:solidFill>
+              </a:rPr>
+              <a:t xml:space="preserve">R8 per-item validation</a:t>
+            </a:r>
+            <a:endParaRPr lang="en-GB" sz="1150" dirty="0"/>
+          </a:p>
+          <a:p>
+            <a:pPr marL="137160" indent="-137160">
+              <a:spcAft>
+                <a:spcPts val="500"/>
+              </a:spcAft>
+              <a:buFont typeface="Arial"/>
+              <a:buChar char="•"/>
+            </a:pPr>
+            <a:r>
+              <a:rPr lang="en-GB" sz="1150" dirty="0">
+                <a:solidFill>
+                  <a:schemeClr val="tx1"/>
+                </a:solidFill>
+              </a:rPr>
+              <a:t xml:space="preserve">R9 JSON mode</a:t>
+            </a:r>
+            <a:endParaRPr lang="en-GB" sz="1150" dirty="0"/>
+          </a:p>
+        </p:txBody>
+      </p:sp>
+      <p:sp>
+        <p:nvSpPr>
+          <p:cNvPr id="34" name="Phase 4 result"/>
           <p:cNvSpPr txBox="1"/>
           <p:nvPr/>
         </p:nvSpPr>
         <p:spPr>
           <a:xfrm>
-            <a:off x="4480560" y="2697480"/>
-            <a:ext cx="4206240" cy="338328"/>
+            <a:off x="6784848" y="3429000"/>
+            <a:ext cx="1856232" cy="502920"/>
           </a:xfrm>
           <a:prstGeom prst="rect">
             <a:avLst/>
@@ -9364,57 +10317,37 @@
           <a:noFill/>
         </p:spPr>
         <p:txBody>
-          <a:bodyPr wrap="square" rtlCol="0" anchor="ctr"/>
+          <a:bodyPr wrap="square" lIns="45720" tIns="45720" rIns="45720" bIns="45720" rtlCol="0" anchor="ctr"/>
           <a:lstStyle/>
           <a:p>
             <a:pPr indent="0" marL="0">
-              <a:buNone/>
-            </a:pPr>
-            <a:r>
-              <a:rPr lang="en-GB" sz="1150" b="1" dirty="0">
+              <a:spcAft>
+                <a:spcPts val="0"/>
+              </a:spcAft>
+              <a:buNone/>
+            </a:pPr>
+            <a:r>
+              <a:rPr lang="en-GB" sz="1050" b="1" dirty="0">
                 <a:solidFill>
                   <a:schemeClr val="accent1"/>
                 </a:solidFill>
               </a:rPr>
-              <a:t>Configurable endpoint; Qwen runs locally under Ollama</a:t>
-            </a:r>
-          </a:p>
-        </p:txBody>
-      </p:sp>
-      <p:sp>
-        <p:nvSpPr>
-          <p:cNvPr id="28" name="R7 badge"/>
-          <p:cNvSpPr/>
-          <p:nvPr/>
-        </p:nvSpPr>
-        <p:spPr>
-          <a:xfrm>
-            <a:off x="457200" y="3063240"/>
-            <a:ext cx="283464" cy="283464"/>
-          </a:xfrm>
-          <a:prstGeom prst="ellipse">
-            <a:avLst/>
-          </a:prstGeom>
-          <a:solidFill>
-            <a:schemeClr val="accent1"/>
-          </a:solidFill>
-          <a:ln w="12700">
-            <a:solidFill>
-              <a:schemeClr val="accent1"/>
-            </a:solidFill>
-          </a:ln>
-        </p:spPr>
-      </p:sp>
-      <p:sp>
-        <p:nvSpPr>
-          <p:cNvPr id="29" name="R7 label"/>
+              <a:t xml:space="preserve">83 tests; live tests 3 of 4</a:t>
+            </a:r>
+            <a:endParaRPr lang="en-GB" sz="1050" dirty="0"/>
+          </a:p>
+        </p:txBody>
+      </p:sp>
+      <p:sp>
+        <p:nvSpPr>
+          <p:cNvPr id="35" name="Footnote"/>
           <p:cNvSpPr txBox="1"/>
           <p:nvPr/>
         </p:nvSpPr>
         <p:spPr>
           <a:xfrm>
-            <a:off x="457200" y="3063240"/>
-            <a:ext cx="283464" cy="283464"/>
+            <a:off x="457200" y="4005072"/>
+            <a:ext cx="8229600" cy="292608"/>
           </a:xfrm>
           <a:prstGeom prst="rect">
             <a:avLst/>
@@ -9422,374 +10355,24 @@
           <a:noFill/>
         </p:spPr>
         <p:txBody>
-          <a:bodyPr wrap="square" lIns="0" tIns="0" rIns="0" bIns="0" rtlCol="0" anchor="ctr"/>
-          <a:lstStyle/>
-          <a:p>
-            <a:pPr algn="ctr" indent="0" marL="0">
-              <a:buNone/>
-            </a:pPr>
-            <a:r>
-              <a:rPr lang="en-GB" sz="1000" b="1" dirty="0">
-                <a:solidFill>
-                  <a:schemeClr val="bg1"/>
-                </a:solidFill>
-              </a:rPr>
-              <a:t>R7</a:t>
-            </a:r>
-          </a:p>
-        </p:txBody>
-      </p:sp>
-      <p:sp>
-        <p:nvSpPr>
-          <p:cNvPr id="30" name="R7 problem"/>
-          <p:cNvSpPr txBox="1"/>
-          <p:nvPr/>
-        </p:nvSpPr>
-        <p:spPr>
-          <a:xfrm>
-            <a:off x="868680" y="3035808"/>
-            <a:ext cx="3566160" cy="338328"/>
-          </a:xfrm>
-          <a:prstGeom prst="rect">
-            <a:avLst/>
-          </a:prstGeom>
-          <a:noFill/>
-        </p:spPr>
-        <p:txBody>
-          <a:bodyPr wrap="square" rtlCol="0" anchor="ctr"/>
+          <a:bodyPr wrap="square" lIns="45720" tIns="45720" rIns="45720" bIns="45720" rtlCol="0" anchor="ctr"/>
           <a:lstStyle/>
           <a:p>
             <a:pPr indent="0" marL="0">
-              <a:buNone/>
-            </a:pPr>
-            <a:r>
-              <a:rPr lang="en-GB" sz="1150" dirty="0">
-                <a:solidFill>
-                  <a:schemeClr val="tx1"/>
-                </a:solidFill>
-              </a:rPr>
-              <a:t>Live: Semantic Scholar throttled (429)</a:t>
-            </a:r>
-          </a:p>
-        </p:txBody>
-      </p:sp>
-      <p:sp>
-        <p:nvSpPr>
-          <p:cNvPr id="31" name="R7 fix"/>
-          <p:cNvSpPr txBox="1"/>
-          <p:nvPr/>
-        </p:nvSpPr>
-        <p:spPr>
-          <a:xfrm>
-            <a:off x="4480560" y="3035808"/>
-            <a:ext cx="4206240" cy="338328"/>
-          </a:xfrm>
-          <a:prstGeom prst="rect">
-            <a:avLst/>
-          </a:prstGeom>
-          <a:noFill/>
-        </p:spPr>
-        <p:txBody>
-          <a:bodyPr wrap="square" rtlCol="0" anchor="ctr"/>
-          <a:lstStyle/>
-          <a:p>
-            <a:pPr indent="0" marL="0">
-              <a:buNone/>
-            </a:pPr>
-            <a:r>
-              <a:rPr lang="en-GB" sz="1150" b="1" dirty="0">
-                <a:solidFill>
-                  <a:schemeClr val="accent1"/>
-                </a:solidFill>
-              </a:rPr>
-              <a:t>Longer back-off, Retry-After, optional API key</a:t>
-            </a:r>
-          </a:p>
-        </p:txBody>
-      </p:sp>
-      <p:sp>
-        <p:nvSpPr>
-          <p:cNvPr id="32" name="R8 badge"/>
-          <p:cNvSpPr/>
-          <p:nvPr/>
-        </p:nvSpPr>
-        <p:spPr>
-          <a:xfrm>
-            <a:off x="457200" y="3401568"/>
-            <a:ext cx="283464" cy="283464"/>
-          </a:xfrm>
-          <a:prstGeom prst="ellipse">
-            <a:avLst/>
-          </a:prstGeom>
-          <a:solidFill>
-            <a:schemeClr val="accent1"/>
-          </a:solidFill>
-          <a:ln w="12700">
-            <a:solidFill>
-              <a:schemeClr val="accent1"/>
-            </a:solidFill>
-          </a:ln>
-        </p:spPr>
-      </p:sp>
-      <p:sp>
-        <p:nvSpPr>
-          <p:cNvPr id="33" name="R8 label"/>
-          <p:cNvSpPr txBox="1"/>
-          <p:nvPr/>
-        </p:nvSpPr>
-        <p:spPr>
-          <a:xfrm>
-            <a:off x="457200" y="3401568"/>
-            <a:ext cx="283464" cy="283464"/>
-          </a:xfrm>
-          <a:prstGeom prst="rect">
-            <a:avLst/>
-          </a:prstGeom>
-          <a:noFill/>
-        </p:spPr>
-        <p:txBody>
-          <a:bodyPr wrap="square" lIns="0" tIns="0" rIns="0" bIns="0" rtlCol="0" anchor="ctr"/>
-          <a:lstStyle/>
-          <a:p>
-            <a:pPr algn="ctr" indent="0" marL="0">
-              <a:buNone/>
-            </a:pPr>
-            <a:r>
-              <a:rPr lang="en-GB" sz="1000" b="1" dirty="0">
-                <a:solidFill>
-                  <a:schemeClr val="bg1"/>
-                </a:solidFill>
-              </a:rPr>
-              <a:t>R8</a:t>
-            </a:r>
-          </a:p>
-        </p:txBody>
-      </p:sp>
-      <p:sp>
-        <p:nvSpPr>
-          <p:cNvPr id="34" name="R8 problem"/>
-          <p:cNvSpPr txBox="1"/>
-          <p:nvPr/>
-        </p:nvSpPr>
-        <p:spPr>
-          <a:xfrm>
-            <a:off x="868680" y="3374136"/>
-            <a:ext cx="3566160" cy="338328"/>
-          </a:xfrm>
-          <a:prstGeom prst="rect">
-            <a:avLst/>
-          </a:prstGeom>
-          <a:noFill/>
-        </p:spPr>
-        <p:txBody>
-          <a:bodyPr wrap="square" rtlCol="0" anchor="ctr"/>
-          <a:lstStyle/>
-          <a:p>
-            <a:pPr indent="0" marL="0">
-              <a:buNone/>
-            </a:pPr>
-            <a:r>
-              <a:rPr lang="en-GB" sz="1150" dirty="0">
-                <a:solidFill>
-                  <a:schemeClr val="tx1"/>
-                </a:solidFill>
-              </a:rPr>
-              <a:t>Live: one bad appraisal discarded all 12</a:t>
-            </a:r>
-          </a:p>
-        </p:txBody>
-      </p:sp>
-      <p:sp>
-        <p:nvSpPr>
-          <p:cNvPr id="35" name="R8 fix"/>
-          <p:cNvSpPr txBox="1"/>
-          <p:nvPr/>
-        </p:nvSpPr>
-        <p:spPr>
-          <a:xfrm>
-            <a:off x="4480560" y="3374136"/>
-            <a:ext cx="4206240" cy="338328"/>
-          </a:xfrm>
-          <a:prstGeom prst="rect">
-            <a:avLst/>
-          </a:prstGeom>
-          <a:noFill/>
-        </p:spPr>
-        <p:txBody>
-          <a:bodyPr wrap="square" rtlCol="0" anchor="ctr"/>
-          <a:lstStyle/>
-          <a:p>
-            <a:pPr indent="0" marL="0">
-              <a:buNone/>
-            </a:pPr>
-            <a:r>
-              <a:rPr lang="en-GB" sz="1150" b="1" dirty="0">
-                <a:solidFill>
-                  <a:schemeClr val="accent1"/>
-                </a:solidFill>
-              </a:rPr>
-              <a:t>Validate each item; 11 of 12 now kept from the LLM</a:t>
-            </a:r>
-          </a:p>
-        </p:txBody>
-      </p:sp>
-      <p:sp>
-        <p:nvSpPr>
-          <p:cNvPr id="36" name="R9 badge"/>
-          <p:cNvSpPr/>
-          <p:nvPr/>
-        </p:nvSpPr>
-        <p:spPr>
-          <a:xfrm>
-            <a:off x="457200" y="3739896"/>
-            <a:ext cx="283464" cy="283464"/>
-          </a:xfrm>
-          <a:prstGeom prst="ellipse">
-            <a:avLst/>
-          </a:prstGeom>
-          <a:solidFill>
-            <a:schemeClr val="accent1"/>
-          </a:solidFill>
-          <a:ln w="12700">
-            <a:solidFill>
-              <a:schemeClr val="accent1"/>
-            </a:solidFill>
-          </a:ln>
-        </p:spPr>
-      </p:sp>
-      <p:sp>
-        <p:nvSpPr>
-          <p:cNvPr id="37" name="R9 label"/>
-          <p:cNvSpPr txBox="1"/>
-          <p:nvPr/>
-        </p:nvSpPr>
-        <p:spPr>
-          <a:xfrm>
-            <a:off x="457200" y="3739896"/>
-            <a:ext cx="283464" cy="283464"/>
-          </a:xfrm>
-          <a:prstGeom prst="rect">
-            <a:avLst/>
-          </a:prstGeom>
-          <a:noFill/>
-        </p:spPr>
-        <p:txBody>
-          <a:bodyPr wrap="square" lIns="0" tIns="0" rIns="0" bIns="0" rtlCol="0" anchor="ctr"/>
-          <a:lstStyle/>
-          <a:p>
-            <a:pPr algn="ctr" indent="0" marL="0">
-              <a:buNone/>
-            </a:pPr>
-            <a:r>
-              <a:rPr lang="en-GB" sz="1000" b="1" dirty="0">
-                <a:solidFill>
-                  <a:schemeClr val="bg1"/>
-                </a:solidFill>
-              </a:rPr>
-              <a:t>R9</a:t>
-            </a:r>
-          </a:p>
-        </p:txBody>
-      </p:sp>
-      <p:sp>
-        <p:nvSpPr>
-          <p:cNvPr id="38" name="R9 problem"/>
-          <p:cNvSpPr txBox="1"/>
-          <p:nvPr/>
-        </p:nvSpPr>
-        <p:spPr>
-          <a:xfrm>
-            <a:off x="868680" y="3712464"/>
-            <a:ext cx="3566160" cy="338328"/>
-          </a:xfrm>
-          <a:prstGeom prst="rect">
-            <a:avLst/>
-          </a:prstGeom>
-          <a:noFill/>
-        </p:spPr>
-        <p:txBody>
-          <a:bodyPr wrap="square" rtlCol="0" anchor="ctr"/>
-          <a:lstStyle/>
-          <a:p>
-            <a:pPr indent="0" marL="0">
-              <a:buNone/>
-            </a:pPr>
-            <a:r>
-              <a:rPr lang="en-GB" sz="1150" dirty="0">
-                <a:solidFill>
-                  <a:schemeClr val="tx1"/>
-                </a:solidFill>
-              </a:rPr>
-              <a:t>Live: briefing JSON missing a comma</a:t>
-            </a:r>
-          </a:p>
-        </p:txBody>
-      </p:sp>
-      <p:sp>
-        <p:nvSpPr>
-          <p:cNvPr id="39" name="R9 fix"/>
-          <p:cNvSpPr txBox="1"/>
-          <p:nvPr/>
-        </p:nvSpPr>
-        <p:spPr>
-          <a:xfrm>
-            <a:off x="4480560" y="3712464"/>
-            <a:ext cx="4206240" cy="338328"/>
-          </a:xfrm>
-          <a:prstGeom prst="rect">
-            <a:avLst/>
-          </a:prstGeom>
-          <a:noFill/>
-        </p:spPr>
-        <p:txBody>
-          <a:bodyPr wrap="square" rtlCol="0" anchor="ctr"/>
-          <a:lstStyle/>
-          <a:p>
-            <a:pPr indent="0" marL="0">
-              <a:buNone/>
-            </a:pPr>
-            <a:r>
-              <a:rPr lang="en-GB" sz="1150" b="1" dirty="0">
-                <a:solidFill>
-                  <a:schemeClr val="accent1"/>
-                </a:solidFill>
-              </a:rPr>
-              <a:t>Opt-in JSON mode constrains output to valid JSON</a:t>
-            </a:r>
-          </a:p>
-        </p:txBody>
-      </p:sp>
-      <p:sp>
-        <p:nvSpPr>
-          <p:cNvPr id="40" name="Footnote"/>
-          <p:cNvSpPr txBox="1"/>
-          <p:nvPr/>
-        </p:nvSpPr>
-        <p:spPr>
-          <a:xfrm>
-            <a:off x="457200" y="4078224"/>
-            <a:ext cx="8229600" cy="457200"/>
-          </a:xfrm>
-          <a:prstGeom prst="rect">
-            <a:avLst/>
-          </a:prstGeom>
-          <a:noFill/>
-        </p:spPr>
-        <p:txBody>
-          <a:bodyPr wrap="square" rtlCol="0" anchor="ctr"/>
-          <a:lstStyle/>
-          <a:p>
-            <a:pPr indent="0" marL="0">
-              <a:buNone/>
-            </a:pPr>
-            <a:r>
-              <a:rPr lang="en-GB" sz="1100" i="1" dirty="0">
+              <a:spcAft>
+                <a:spcPts val="0"/>
+              </a:spcAft>
+              <a:buNone/>
+            </a:pPr>
+            <a:r>
+              <a:rPr lang="en-GB" sz="1050" i="1" dirty="0">
                 <a:solidFill>
                   <a:schemeClr val="accent5"/>
                 </a:solidFill>
               </a:rPr>
-              <a:t>R1 to R5 came from offline testing; R6 to R9 came from the live run on Windows 11 with Qwen2.5-7B under Ollama. Each fix has a regression test (docs/TESTING.md), and the Git history shows every step.</a:t>
-            </a:r>
+              <a:t xml:space="preserve">Every step is a commit or pull request on GitHub, and each fix has a regression test (docs/TESTING.md).</a:t>
+            </a:r>
+            <a:endParaRPr lang="en-GB" sz="1050" dirty="0"/>
           </a:p>
         </p:txBody>
       </p:sp>

</xml_diff>